<commit_message>
Form 3 Module 1 (L1-L6, FS1, PW1, PW2): revise to the validated model
Co-Authored-By: Claude Opus 5.5 <noreply@anthropic.com>
Claude-Session: https://claude.ai/code/session_0115LFSb2ktGLWPeVksFkSer
</commit_message>
<xml_diff>
--- a/lecons/F3/04_FORM4_LESSON03_Great_Circles_and_IDL.pptx
+++ b/lecons/F3/04_FORM4_LESSON03_Great_Circles_and_IDL.pptx
@@ -52,9 +52,13 @@
     <p:sldId id="300" r:id="rId46"/>
     <p:sldId id="301" r:id="rId47"/>
     <p:sldId id="302" r:id="rId48"/>
+    <p:sldId id="303" r:id="rId49"/>
+    <p:sldId id="304" r:id="rId50"/>
+    <p:sldId id="305" r:id="rId51"/>
+    <p:sldId id="306" r:id="rId52"/>
   </p:sldIdLst>
   <p:notesMasterIdLst>
-    <p:notesMasterId r:id="rId49"/>
+    <p:notesMasterId r:id="rId53"/>
   </p:notesMasterIdLst>
   <p:sldSz cx="12192000" cy="6858000"/>
   <p:notesSz cx="6858000" cy="12192000"/>
@@ -636,7 +640,7 @@
           <a:p>
             <a:r>
               <a:rPr lang="en-US" dirty="0"/>
-              <a:t>Listen carefully to this situation from real life. On 31 December, Fatimé watches the news. In the afternoon, people in Australia are already celebrating the New Year. After midnight in Garoua, people in America are still waiting. Think about it, because I am going to ask you some questions.</a:t>
+              <a:t>Listen carefully to this situation from real life. On 31 December, Fatimé watches the news: in the afternoon, people in Australia are already celebrating the New Year, but after midnight in Garoua, people in America are still waiting. She asks: "Why does the New Year not start at the same time everywhere, and where does a new day begin?" Think about it, because I am going to ask you some questions.</a:t>
             </a:r>
             <a:endParaRPr lang="en-US" dirty="0"/>
           </a:p>
@@ -812,7 +816,7 @@
           <a:p>
             <a:r>
               <a:rPr lang="en-US" dirty="0"/>
-              <a:t>Good. Fatimé does not understand why the New Year comes at different times.</a:t>
+              <a:t>Good. Fatimé does not understand why the New Year comes at different times and where a new day begins.</a:t>
             </a:r>
             <a:endParaRPr lang="en-US" dirty="0"/>
           </a:p>
@@ -900,7 +904,7 @@
           <a:p>
             <a:r>
               <a:rPr lang="en-US" dirty="0"/>
-              <a:t>Question 2: Which country celebrates first? Think for a moment, then raise your hand to answer.</a:t>
+              <a:t>Question 2: Which country celebrates before Cameroon? Think for a moment, then raise your hand to answer.</a:t>
             </a:r>
             <a:endParaRPr lang="en-US" dirty="0"/>
           </a:p>
@@ -1956,7 +1960,7 @@
           <a:p>
             <a:r>
               <a:rPr lang="en-US" dirty="0"/>
-              <a:t>Let us check the answer together. It is far to the east, near the Date Line, where each new day begins.</a:t>
+              <a:t>Let us check the answer together. It is far to the east, near the Date Line where each new day begins.</a:t>
             </a:r>
             <a:endParaRPr lang="en-US" dirty="0"/>
           </a:p>
@@ -2396,7 +2400,7 @@
           <a:p>
             <a:r>
               <a:rPr lang="en-US" dirty="0"/>
-              <a:t>Let us copy Great Circles. Great circles are explained as follows. On this slide we have Great circle and Small circle. Write each point on a new line, with the key term first, and explain it in your own words when we revise. When you finish, we go to the next slide.</a:t>
+              <a:t>Let us copy the definitions. The key terms of this lesson are defined as follows. On this slide we have Great circle. Write each point on a new line, with the key term first, and explain it in your own words when we revise. When you finish, we go to the next slide.</a:t>
             </a:r>
             <a:endParaRPr lang="en-US" dirty="0"/>
           </a:p>
@@ -2572,7 +2576,7 @@
           <a:p>
             <a:r>
               <a:rPr lang="en-US" dirty="0"/>
-              <a:t>We continue with Great Circles. On this slide we have Examples and Importance. Write each point on a new line, with the key term first, and explain it in your own words when we revise.</a:t>
+              <a:t>We continue with the definitions. On this slide we have Small circle and International Date Line. Write each point on a new line, with the key term first, and explain it in your own words when we revise.</a:t>
             </a:r>
             <a:endParaRPr lang="en-US" dirty="0"/>
           </a:p>
@@ -2660,7 +2664,7 @@
           <a:p>
             <a:r>
               <a:rPr lang="en-US" dirty="0"/>
-              <a:t>Now draw this illustration in your notebook: great circles and small circles. Give it a title and label it clearly.</a:t>
+              <a:t>Let us copy Illustrations. Great and small circles are illustrated by the following examples. Copy the point on The Equator on the left, then draw the diagram on the right: great and small circles. Give it a title and label it clearly.</a:t>
             </a:r>
             <a:endParaRPr lang="en-US" dirty="0"/>
           </a:p>
@@ -2748,7 +2752,7 @@
           <a:p>
             <a:r>
               <a:rPr lang="en-US" dirty="0"/>
-              <a:t>Let us copy The International Date Line. The International Date Line is explained as follows. On this slide we have Meaning and Position. Write each point on a new line, with the key term first, and explain it in your own words when we revise. When you finish, we go to the next slide.</a:t>
+              <a:t>We continue with Illustrations. On this slide we have Meridians and Small circles. Write each point on a new line, with the key term first, and explain it in your own words when we revise.</a:t>
             </a:r>
             <a:endParaRPr lang="en-US" dirty="0"/>
           </a:p>
@@ -2836,7 +2840,7 @@
           <a:p>
             <a:r>
               <a:rPr lang="en-US" dirty="0"/>
-              <a:t>We continue with The International Date Line. On this slide we have Crossing westwards and Crossing eastwards. Write each point on a new line, with the key term first, and explain it in your own words when we revise.</a:t>
+              <a:t>Let us copy Importance. Great circles are important for the following reasons. On this slide we have Shortest route. Write each point on a new line, with the key term first, and explain it in your own words when we revise. When you finish, we go to the next slide.</a:t>
             </a:r>
             <a:endParaRPr lang="en-US" dirty="0"/>
           </a:p>
@@ -2924,7 +2928,7 @@
           <a:p>
             <a:r>
               <a:rPr lang="en-US" dirty="0"/>
-              <a:t>Now draw this illustration in your notebook: the International Date Line. Give it a title and label it clearly.</a:t>
+              <a:t>We continue with Importance. On this slide we have Air transport, Sea transport and Day and night. Write each point on a new line, with the key term first, and explain it in your own words when we revise.</a:t>
             </a:r>
             <a:endParaRPr lang="en-US" dirty="0"/>
           </a:p>
@@ -3012,7 +3016,7 @@
           <a:p>
             <a:r>
               <a:rPr lang="en-US" dirty="0"/>
-              <a:t>Now let us check what you have understood. Question 1: Is the Equator a great circle? Why? Answer in your exercise book.</a:t>
+              <a:t>Let us copy Illustration. The International Date Line is placed as follows. Copy the point on Position on the left, then draw the diagram on the right: the International Date Line. Give it a title and label it clearly.</a:t>
             </a:r>
             <a:endParaRPr lang="en-US" dirty="0"/>
           </a:p>
@@ -3100,7 +3104,7 @@
           <a:p>
             <a:r>
               <a:rPr lang="en-US" dirty="0"/>
-              <a:t>The expected answer is: yes. It cuts the Earth into two equal halves. If you got it right, well done.</a:t>
+              <a:t>We continue with Illustration. On this slide we have Bends and Two dates. Write each point on a new line, with the key term first, and explain it in your own words when we revise.</a:t>
             </a:r>
             <a:endParaRPr lang="en-US" dirty="0"/>
           </a:p>
@@ -3188,7 +3192,7 @@
           <a:p>
             <a:r>
               <a:rPr lang="en-US" dirty="0"/>
-              <a:t>Now let us check what you have understood. Question 2: What happens to the date when we cross the Date Line going west? Answer in your exercise book.</a:t>
+              <a:t>Let us copy Importance. The International Date Line is important for the following reasons. On this slide we have Start of the day and Crossing westwards. Write each point on a new line, with the key term first, and explain it in your own words when we revise. When you finish, we go to the next slide.</a:t>
             </a:r>
             <a:endParaRPr lang="en-US" dirty="0"/>
           </a:p>
@@ -3276,7 +3280,7 @@
           <a:p>
             <a:r>
               <a:rPr lang="en-US" dirty="0"/>
-              <a:t>The expected answer is: we add one day. If you got it right, well done.</a:t>
+              <a:t>We continue with Importance. On this slide we have Crossing eastwards and Correct dates. Write each point on a new line, with the key term first, and explain it in your own words when we revise.</a:t>
             </a:r>
             <a:endParaRPr lang="en-US" dirty="0"/>
           </a:p>
@@ -3364,7 +3368,7 @@
           <a:p>
             <a:r>
               <a:rPr lang="en-US" dirty="0"/>
-              <a:t>Take your time to copy this part; we will continue together.</a:t>
+              <a:t>Now let us check what you have understood. Question 1: Is the Equator a great circle? Why? Answer in your exercise book.</a:t>
             </a:r>
             <a:endParaRPr lang="en-US" dirty="0"/>
           </a:p>
@@ -3540,7 +3544,7 @@
           <a:p>
             <a:r>
               <a:rPr lang="en-US" dirty="0"/>
-              <a:t>For those who need more practice, fill in the blanks in your exercise book. The answers are: number 1, great; number 2, 180th; number 3, add.</a:t>
+              <a:t>The expected answer is: yes. It cuts the Earth into two equal halves. If you got it right, well done.</a:t>
             </a:r>
             <a:endParaRPr lang="en-US" dirty="0"/>
           </a:p>
@@ -3628,7 +3632,7 @@
           <a:p>
             <a:r>
               <a:rPr lang="en-US" dirty="0"/>
-              <a:t>For your homework: Bring an atlas, a ruler and a pencil to the next lesson. Find the map of Cameroon in your atlas. We shall correct it at the beginning of our next lesson.</a:t>
+              <a:t>Now let us check what you have understood. Question 2: What happens to the date when we cross the Date Line going west? Answer in your exercise book.</a:t>
             </a:r>
             <a:endParaRPr lang="en-US" dirty="0"/>
           </a:p>
@@ -3716,7 +3720,7 @@
           <a:p>
             <a:r>
               <a:rPr lang="en-US" dirty="0"/>
-              <a:t>Our next lesson will be on Practical Work 1: Locate a Place on a Map. Thank you for your attention, and see you next time.</a:t>
+              <a:t>The expected answer is: we add one day. If you got it right, well done.</a:t>
             </a:r>
             <a:endParaRPr lang="en-US" dirty="0"/>
           </a:p>
@@ -3804,7 +3808,7 @@
           <a:p>
             <a:r>
               <a:rPr lang="en-US" dirty="0"/>
-              <a:t>Let us play the bilingual game. I say a word in English, and you give me the French word. Then we do the reverse.</a:t>
+              <a:t>Take your time to copy this part; we will continue together.</a:t>
             </a:r>
             <a:endParaRPr lang="en-US" dirty="0"/>
           </a:p>
@@ -3892,7 +3896,7 @@
           <a:p>
             <a:r>
               <a:rPr lang="en-US" dirty="0"/>
-              <a:t>I record this information in the official logbook of the class after the lesson.</a:t>
+              <a:t>For those who need more practice, fill in the blanks in your exercise book. The answers are: number 1, great; number 2, 180th; number 3, add.</a:t>
             </a:r>
             <a:endParaRPr lang="en-US" dirty="0"/>
           </a:p>
@@ -3980,7 +3984,7 @@
           <a:p>
             <a:r>
               <a:rPr lang="en-US" dirty="0"/>
-              <a:t>I complete the second page of the logbook: the matter taught, the evaluation, the homework and the attendance.</a:t>
+              <a:t>For your homework: Bring an atlas, a ruler and a pencil to the next lesson. Find the map of Cameroon in your atlas. We shall correct it at the beginning of our next lesson.</a:t>
             </a:r>
             <a:endParaRPr lang="en-US" dirty="0"/>
           </a:p>
@@ -4068,7 +4072,7 @@
           <a:p>
             <a:r>
               <a:rPr lang="en-US" dirty="0"/>
-              <a:t>This slide is for me, the teacher: it gives the timing of the lesson and what to do if the projector is not available.</a:t>
+              <a:t>Our next lesson will be on Practical Work 1: Locate a Place on a Map. Thank you for your attention, and see you next time.</a:t>
             </a:r>
             <a:endParaRPr lang="en-US" dirty="0"/>
           </a:p>
@@ -4156,7 +4160,7 @@
           <a:p>
             <a:r>
               <a:rPr lang="en-US" dirty="0"/>
-              <a:t>These are the references and picture credits used to prepare this lesson.</a:t>
+              <a:t>Let us play the bilingual game. I say a word in English, and you give me the French word. Then we do the reverse.</a:t>
             </a:r>
             <a:endParaRPr lang="en-US" dirty="0"/>
           </a:p>
@@ -4180,6 +4184,182 @@
             <a:fld id="{F7021451-1387-4CA6-816F-3879F97B5CBC}" type="slidenum">
               <a:rPr lang="en-US"/>
               <a:t>47</a:t>
+            </a:fld>
+            <a:endParaRPr lang="en-US"/>
+          </a:p>
+        </p:txBody>
+      </p:sp>
+    </p:spTree>
+    <p:extLst>
+      <p:ext uri="{BB962C8B-B14F-4D97-AF65-F5344CB8AC3E}">
+        <p14:creationId xmlns:p14="http://schemas.microsoft.com/office/powerpoint/2010/main" val="1024086991"/>
+      </p:ext>
+    </p:extLst>
+  </p:cSld>
+  <p:clrMapOvr>
+    <a:masterClrMapping/>
+  </p:clrMapOvr>
+</p:notes>
+</file>
+
+<file path=ppt/notesSlides/notesSlide48.xml><?xml version="1.0" encoding="utf-8"?>
+<p:notes xmlns:a="http://schemas.openxmlformats.org/drawingml/2006/main" xmlns:r="http://schemas.openxmlformats.org/officeDocument/2006/relationships" xmlns:p="http://schemas.openxmlformats.org/presentationml/2006/main">
+  <p:cSld>
+    <p:spTree>
+      <p:nvGrpSpPr>
+        <p:cNvPr id="1" name=""/>
+        <p:cNvGrpSpPr/>
+        <p:nvPr/>
+      </p:nvGrpSpPr>
+      <p:grpSpPr>
+        <a:xfrm>
+          <a:off x="0" y="0"/>
+          <a:ext cx="0" cy="0"/>
+          <a:chOff x="0" y="0"/>
+          <a:chExt cx="0" cy="0"/>
+        </a:xfrm>
+      </p:grpSpPr>
+      <p:sp>
+        <p:nvSpPr>
+          <p:cNvPr id="2" name="Slide Image Placeholder 1"/>
+          <p:cNvSpPr>
+            <a:spLocks noGrp="1" noRot="1" noChangeAspect="1"/>
+          </p:cNvSpPr>
+          <p:nvPr>
+            <p:ph type="sldImg"/>
+          </p:nvPr>
+        </p:nvSpPr>
+        <p:spPr/>
+      </p:sp>
+      <p:sp>
+        <p:nvSpPr>
+          <p:cNvPr id="3" name="Notes Placeholder 2"/>
+          <p:cNvSpPr>
+            <a:spLocks noGrp="1"/>
+          </p:cNvSpPr>
+          <p:nvPr>
+            <p:ph type="body" idx="1"/>
+          </p:nvPr>
+        </p:nvSpPr>
+        <p:spPr/>
+        <p:txBody>
+          <a:bodyPr/>
+          <a:lstStyle/>
+          <a:p>
+            <a:r>
+              <a:rPr lang="en-US" dirty="0"/>
+              <a:t>I record this information in the official logbook of the class after the lesson.</a:t>
+            </a:r>
+            <a:endParaRPr lang="en-US" dirty="0"/>
+          </a:p>
+        </p:txBody>
+      </p:sp>
+      <p:sp>
+        <p:nvSpPr>
+          <p:cNvPr id="4" name="Slide Number Placeholder 3"/>
+          <p:cNvSpPr>
+            <a:spLocks noGrp="1"/>
+          </p:cNvSpPr>
+          <p:nvPr>
+            <p:ph type="sldNum" sz="quarter" idx="10"/>
+          </p:nvPr>
+        </p:nvSpPr>
+        <p:spPr/>
+        <p:txBody>
+          <a:bodyPr/>
+          <a:lstStyle/>
+          <a:p>
+            <a:fld id="{F7021451-1387-4CA6-816F-3879F97B5CBC}" type="slidenum">
+              <a:rPr lang="en-US"/>
+              <a:t>48</a:t>
+            </a:fld>
+            <a:endParaRPr lang="en-US"/>
+          </a:p>
+        </p:txBody>
+      </p:sp>
+    </p:spTree>
+    <p:extLst>
+      <p:ext uri="{BB962C8B-B14F-4D97-AF65-F5344CB8AC3E}">
+        <p14:creationId xmlns:p14="http://schemas.microsoft.com/office/powerpoint/2010/main" val="1024086991"/>
+      </p:ext>
+    </p:extLst>
+  </p:cSld>
+  <p:clrMapOvr>
+    <a:masterClrMapping/>
+  </p:clrMapOvr>
+</p:notes>
+</file>
+
+<file path=ppt/notesSlides/notesSlide49.xml><?xml version="1.0" encoding="utf-8"?>
+<p:notes xmlns:a="http://schemas.openxmlformats.org/drawingml/2006/main" xmlns:r="http://schemas.openxmlformats.org/officeDocument/2006/relationships" xmlns:p="http://schemas.openxmlformats.org/presentationml/2006/main">
+  <p:cSld>
+    <p:spTree>
+      <p:nvGrpSpPr>
+        <p:cNvPr id="1" name=""/>
+        <p:cNvGrpSpPr/>
+        <p:nvPr/>
+      </p:nvGrpSpPr>
+      <p:grpSpPr>
+        <a:xfrm>
+          <a:off x="0" y="0"/>
+          <a:ext cx="0" cy="0"/>
+          <a:chOff x="0" y="0"/>
+          <a:chExt cx="0" cy="0"/>
+        </a:xfrm>
+      </p:grpSpPr>
+      <p:sp>
+        <p:nvSpPr>
+          <p:cNvPr id="2" name="Slide Image Placeholder 1"/>
+          <p:cNvSpPr>
+            <a:spLocks noGrp="1" noRot="1" noChangeAspect="1"/>
+          </p:cNvSpPr>
+          <p:nvPr>
+            <p:ph type="sldImg"/>
+          </p:nvPr>
+        </p:nvSpPr>
+        <p:spPr/>
+      </p:sp>
+      <p:sp>
+        <p:nvSpPr>
+          <p:cNvPr id="3" name="Notes Placeholder 2"/>
+          <p:cNvSpPr>
+            <a:spLocks noGrp="1"/>
+          </p:cNvSpPr>
+          <p:nvPr>
+            <p:ph type="body" idx="1"/>
+          </p:nvPr>
+        </p:nvSpPr>
+        <p:spPr/>
+        <p:txBody>
+          <a:bodyPr/>
+          <a:lstStyle/>
+          <a:p>
+            <a:r>
+              <a:rPr lang="en-US" dirty="0"/>
+              <a:t>I complete the second page of the logbook: the matter taught, the evaluation, the homework and the attendance.</a:t>
+            </a:r>
+            <a:endParaRPr lang="en-US" dirty="0"/>
+          </a:p>
+        </p:txBody>
+      </p:sp>
+      <p:sp>
+        <p:nvSpPr>
+          <p:cNvPr id="4" name="Slide Number Placeholder 3"/>
+          <p:cNvSpPr>
+            <a:spLocks noGrp="1"/>
+          </p:cNvSpPr>
+          <p:nvPr>
+            <p:ph type="sldNum" sz="quarter" idx="10"/>
+          </p:nvPr>
+        </p:nvSpPr>
+        <p:spPr/>
+        <p:txBody>
+          <a:bodyPr/>
+          <a:lstStyle/>
+          <a:p>
+            <a:fld id="{F7021451-1387-4CA6-816F-3879F97B5CBC}" type="slidenum">
+              <a:rPr lang="en-US"/>
+              <a:t>49</a:t>
             </a:fld>
             <a:endParaRPr lang="en-US"/>
           </a:p>
@@ -4268,6 +4448,182 @@
             <a:fld id="{F7021451-1387-4CA6-816F-3879F97B5CBC}" type="slidenum">
               <a:rPr lang="en-US"/>
               <a:t>5</a:t>
+            </a:fld>
+            <a:endParaRPr lang="en-US"/>
+          </a:p>
+        </p:txBody>
+      </p:sp>
+    </p:spTree>
+    <p:extLst>
+      <p:ext uri="{BB962C8B-B14F-4D97-AF65-F5344CB8AC3E}">
+        <p14:creationId xmlns:p14="http://schemas.microsoft.com/office/powerpoint/2010/main" val="1024086991"/>
+      </p:ext>
+    </p:extLst>
+  </p:cSld>
+  <p:clrMapOvr>
+    <a:masterClrMapping/>
+  </p:clrMapOvr>
+</p:notes>
+</file>
+
+<file path=ppt/notesSlides/notesSlide50.xml><?xml version="1.0" encoding="utf-8"?>
+<p:notes xmlns:a="http://schemas.openxmlformats.org/drawingml/2006/main" xmlns:r="http://schemas.openxmlformats.org/officeDocument/2006/relationships" xmlns:p="http://schemas.openxmlformats.org/presentationml/2006/main">
+  <p:cSld>
+    <p:spTree>
+      <p:nvGrpSpPr>
+        <p:cNvPr id="1" name=""/>
+        <p:cNvGrpSpPr/>
+        <p:nvPr/>
+      </p:nvGrpSpPr>
+      <p:grpSpPr>
+        <a:xfrm>
+          <a:off x="0" y="0"/>
+          <a:ext cx="0" cy="0"/>
+          <a:chOff x="0" y="0"/>
+          <a:chExt cx="0" cy="0"/>
+        </a:xfrm>
+      </p:grpSpPr>
+      <p:sp>
+        <p:nvSpPr>
+          <p:cNvPr id="2" name="Slide Image Placeholder 1"/>
+          <p:cNvSpPr>
+            <a:spLocks noGrp="1" noRot="1" noChangeAspect="1"/>
+          </p:cNvSpPr>
+          <p:nvPr>
+            <p:ph type="sldImg"/>
+          </p:nvPr>
+        </p:nvSpPr>
+        <p:spPr/>
+      </p:sp>
+      <p:sp>
+        <p:nvSpPr>
+          <p:cNvPr id="3" name="Notes Placeholder 2"/>
+          <p:cNvSpPr>
+            <a:spLocks noGrp="1"/>
+          </p:cNvSpPr>
+          <p:nvPr>
+            <p:ph type="body" idx="1"/>
+          </p:nvPr>
+        </p:nvSpPr>
+        <p:spPr/>
+        <p:txBody>
+          <a:bodyPr/>
+          <a:lstStyle/>
+          <a:p>
+            <a:r>
+              <a:rPr lang="en-US" dirty="0"/>
+              <a:t>This slide is for me, the teacher: it gives the timing of the lesson and what to do if the projector is not available.</a:t>
+            </a:r>
+            <a:endParaRPr lang="en-US" dirty="0"/>
+          </a:p>
+        </p:txBody>
+      </p:sp>
+      <p:sp>
+        <p:nvSpPr>
+          <p:cNvPr id="4" name="Slide Number Placeholder 3"/>
+          <p:cNvSpPr>
+            <a:spLocks noGrp="1"/>
+          </p:cNvSpPr>
+          <p:nvPr>
+            <p:ph type="sldNum" sz="quarter" idx="10"/>
+          </p:nvPr>
+        </p:nvSpPr>
+        <p:spPr/>
+        <p:txBody>
+          <a:bodyPr/>
+          <a:lstStyle/>
+          <a:p>
+            <a:fld id="{F7021451-1387-4CA6-816F-3879F97B5CBC}" type="slidenum">
+              <a:rPr lang="en-US"/>
+              <a:t>50</a:t>
+            </a:fld>
+            <a:endParaRPr lang="en-US"/>
+          </a:p>
+        </p:txBody>
+      </p:sp>
+    </p:spTree>
+    <p:extLst>
+      <p:ext uri="{BB962C8B-B14F-4D97-AF65-F5344CB8AC3E}">
+        <p14:creationId xmlns:p14="http://schemas.microsoft.com/office/powerpoint/2010/main" val="1024086991"/>
+      </p:ext>
+    </p:extLst>
+  </p:cSld>
+  <p:clrMapOvr>
+    <a:masterClrMapping/>
+  </p:clrMapOvr>
+</p:notes>
+</file>
+
+<file path=ppt/notesSlides/notesSlide51.xml><?xml version="1.0" encoding="utf-8"?>
+<p:notes xmlns:a="http://schemas.openxmlformats.org/drawingml/2006/main" xmlns:r="http://schemas.openxmlformats.org/officeDocument/2006/relationships" xmlns:p="http://schemas.openxmlformats.org/presentationml/2006/main">
+  <p:cSld>
+    <p:spTree>
+      <p:nvGrpSpPr>
+        <p:cNvPr id="1" name=""/>
+        <p:cNvGrpSpPr/>
+        <p:nvPr/>
+      </p:nvGrpSpPr>
+      <p:grpSpPr>
+        <a:xfrm>
+          <a:off x="0" y="0"/>
+          <a:ext cx="0" cy="0"/>
+          <a:chOff x="0" y="0"/>
+          <a:chExt cx="0" cy="0"/>
+        </a:xfrm>
+      </p:grpSpPr>
+      <p:sp>
+        <p:nvSpPr>
+          <p:cNvPr id="2" name="Slide Image Placeholder 1"/>
+          <p:cNvSpPr>
+            <a:spLocks noGrp="1" noRot="1" noChangeAspect="1"/>
+          </p:cNvSpPr>
+          <p:nvPr>
+            <p:ph type="sldImg"/>
+          </p:nvPr>
+        </p:nvSpPr>
+        <p:spPr/>
+      </p:sp>
+      <p:sp>
+        <p:nvSpPr>
+          <p:cNvPr id="3" name="Notes Placeholder 2"/>
+          <p:cNvSpPr>
+            <a:spLocks noGrp="1"/>
+          </p:cNvSpPr>
+          <p:nvPr>
+            <p:ph type="body" idx="1"/>
+          </p:nvPr>
+        </p:nvSpPr>
+        <p:spPr/>
+        <p:txBody>
+          <a:bodyPr/>
+          <a:lstStyle/>
+          <a:p>
+            <a:r>
+              <a:rPr lang="en-US" dirty="0"/>
+              <a:t>These are the references and picture credits used to prepare this lesson.</a:t>
+            </a:r>
+            <a:endParaRPr lang="en-US" dirty="0"/>
+          </a:p>
+        </p:txBody>
+      </p:sp>
+      <p:sp>
+        <p:nvSpPr>
+          <p:cNvPr id="4" name="Slide Number Placeholder 3"/>
+          <p:cNvSpPr>
+            <a:spLocks noGrp="1"/>
+          </p:cNvSpPr>
+          <p:nvPr>
+            <p:ph type="sldNum" sz="quarter" idx="10"/>
+          </p:nvPr>
+        </p:nvSpPr>
+        <p:spPr/>
+        <p:txBody>
+          <a:bodyPr/>
+          <a:lstStyle/>
+          <a:p>
+            <a:fld id="{F7021451-1387-4CA6-816F-3879F97B5CBC}" type="slidenum">
+              <a:rPr lang="en-US"/>
+              <a:t>51</a:t>
             </a:fld>
             <a:endParaRPr lang="en-US"/>
           </a:p>
@@ -5976,7 +6332,7 @@
         <p:spPr>
           <a:xfrm>
             <a:off x="0" y="658368"/>
-            <a:ext cx="3840480" cy="5833872"/>
+            <a:ext cx="1463040" cy="5833872"/>
           </a:xfrm>
           <a:prstGeom prst="rect">
             <a:avLst/>
@@ -5991,8 +6347,8 @@
         </p:nvSpPr>
         <p:spPr>
           <a:xfrm>
-            <a:off x="4069080" y="1005840"/>
-            <a:ext cx="7802575" cy="731520"/>
+            <a:off x="1691640" y="1005840"/>
+            <a:ext cx="10180015" cy="731520"/>
           </a:xfrm>
           <a:prstGeom prst="rect">
             <a:avLst/>
@@ -6032,8 +6388,8 @@
         </p:nvSpPr>
         <p:spPr>
           <a:xfrm>
-            <a:off x="4069080" y="1783080"/>
-            <a:ext cx="7802575" cy="4663440"/>
+            <a:off x="1691640" y="1783080"/>
+            <a:ext cx="10180015" cy="4663440"/>
           </a:xfrm>
           <a:prstGeom prst="rect">
             <a:avLst/>
@@ -6060,7 +6416,7 @@
                 <a:ea typeface="Times New Roman" pitchFamily="34" charset="-122"/>
                 <a:cs typeface="Times New Roman" pitchFamily="34" charset="-120"/>
               </a:rPr>
-              <a:t>On 31 December, Fatimé watches the news. In the afternoon, people in Australia are already celebrating the New Year. After midnight in Garoua, people in America are still waiting.</a:t>
+              <a:t>On 31 December, Fatimé watches the news: in the afternoon, people in Australia are already celebrating the New Year, but after midnight in Garoua, people in America are still waiting. She asks: "Why does the New Year not start at the same time everywhere, and where does a new day begin?"</a:t>
             </a:r>
             <a:endParaRPr lang="en-US" sz="4000" dirty="0"/>
           </a:p>
@@ -6498,7 +6854,7 @@
                 <a:ea typeface="Times New Roman" pitchFamily="34" charset="-122"/>
                 <a:cs typeface="Times New Roman" pitchFamily="34" charset="-120"/>
               </a:rPr>
-              <a:t>Fatimé does not understand why the New Year comes at different times.</a:t>
+              <a:t>Fatimé does not understand why the New Year comes at different times and where a new day begins.</a:t>
             </a:r>
             <a:endParaRPr lang="en-US" sz="4000" dirty="0"/>
           </a:p>
@@ -6717,7 +7073,7 @@
                 <a:ea typeface="Times New Roman" pitchFamily="34" charset="-122"/>
                 <a:cs typeface="Times New Roman" pitchFamily="34" charset="-120"/>
               </a:rPr>
-              <a:t>Which country celebrates first?</a:t>
+              <a:t>Which country celebrates before Cameroon?</a:t>
             </a:r>
             <a:endParaRPr lang="en-US" sz="4000" dirty="0"/>
           </a:p>
@@ -9711,7 +10067,7 @@
                 <a:ea typeface="Times New Roman" pitchFamily="34" charset="-122"/>
                 <a:cs typeface="Times New Roman" pitchFamily="34" charset="-120"/>
               </a:rPr>
-              <a:t>It is far to the east, near the Date Line, where each new day begins.</a:t>
+              <a:t>It is far to the east, near the Date Line where each new day begins.</a:t>
             </a:r>
             <a:endParaRPr lang="en-US" sz="4000" dirty="0"/>
           </a:p>
@@ -10757,7 +11113,7 @@
         <p:spPr>
           <a:xfrm>
             <a:off x="0" y="658368"/>
-            <a:ext cx="2468880" cy="5833872"/>
+            <a:ext cx="5120640" cy="5833872"/>
           </a:xfrm>
           <a:prstGeom prst="rect">
             <a:avLst/>
@@ -10772,8 +11128,8 @@
         </p:nvSpPr>
         <p:spPr>
           <a:xfrm>
-            <a:off x="2697480" y="1005840"/>
-            <a:ext cx="9174175" cy="731520"/>
+            <a:off x="5349240" y="1005840"/>
+            <a:ext cx="6522415" cy="731520"/>
           </a:xfrm>
           <a:prstGeom prst="rect">
             <a:avLst/>
@@ -10799,7 +11155,7 @@
                 <a:ea typeface="Times New Roman" pitchFamily="34" charset="-122"/>
                 <a:cs typeface="Times New Roman" pitchFamily="34" charset="-120"/>
               </a:rPr>
-              <a:t>1. Great Circles</a:t>
+              <a:t>DEFINITIONS</a:t>
             </a:r>
             <a:endParaRPr lang="en-US" sz="3600" dirty="0"/>
           </a:p>
@@ -10813,8 +11169,8 @@
         </p:nvSpPr>
         <p:spPr>
           <a:xfrm>
-            <a:off x="2697480" y="1783080"/>
-            <a:ext cx="9174175" cy="4663440"/>
+            <a:off x="5349240" y="1783080"/>
+            <a:ext cx="6522415" cy="4663440"/>
           </a:xfrm>
           <a:prstGeom prst="rect">
             <a:avLst/>
@@ -10841,7 +11197,7 @@
                 <a:ea typeface="Times New Roman" pitchFamily="34" charset="-122"/>
                 <a:cs typeface="Times New Roman" pitchFamily="34" charset="-120"/>
               </a:rPr>
-              <a:t>Great circles are explained as follows:</a:t>
+              <a:t>The key terms of this lesson are defined as follows:</a:t>
             </a:r>
             <a:endParaRPr lang="en-US" sz="4000" dirty="0"/>
           </a:p>
@@ -10878,44 +11234,7 @@
                 <a:ea typeface="Times New Roman" pitchFamily="34" charset="-122"/>
                 <a:cs typeface="Times New Roman" pitchFamily="34" charset="-120"/>
               </a:rPr>
-              <a:t>It is a circle that cuts the Earth into two equal halves.</a:t>
-            </a:r>
-            <a:endParaRPr lang="en-US" sz="4000" dirty="0"/>
-          </a:p>
-          <a:p>
-            <a:pPr algn="l" indent="0" marL="0">
-              <a:spcAft>
-                <a:spcPts val="800"/>
-              </a:spcAft>
-              <a:buNone/>
-            </a:pPr>
-            <a:r>
-              <a:rPr lang="en-US" sz="4000" b="1" dirty="0">
-                <a:solidFill>
-                  <a:srgbClr val="111111"/>
-                </a:solidFill>
-                <a:latin typeface="Times New Roman" pitchFamily="34" charset="0"/>
-                <a:ea typeface="Times New Roman" pitchFamily="34" charset="-122"/>
-                <a:cs typeface="Times New Roman" pitchFamily="34" charset="-120"/>
-              </a:rPr>
-              <a:t>Small circle: </a:t>
-            </a:r>
-            <a:pPr algn="l" indent="0" marL="0">
-              <a:spcAft>
-                <a:spcPts val="800"/>
-              </a:spcAft>
-              <a:buNone/>
-            </a:pPr>
-            <a:r>
-              <a:rPr lang="en-US" sz="4000" dirty="0">
-                <a:solidFill>
-                  <a:srgbClr val="111111"/>
-                </a:solidFill>
-                <a:latin typeface="Times New Roman" pitchFamily="34" charset="0"/>
-                <a:ea typeface="Times New Roman" pitchFamily="34" charset="-122"/>
-                <a:cs typeface="Times New Roman" pitchFamily="34" charset="-120"/>
-              </a:rPr>
-              <a:t>It is a circle, like a tropic, that does not cut the Earth into equal halves.</a:t>
+              <a:t>It is a circle on the surface of the Earth whose plane passes through the centre, cutting the Earth into two equal halves.</a:t>
             </a:r>
             <a:endParaRPr lang="en-US" sz="4000" dirty="0"/>
           </a:p>
@@ -12101,7 +12420,7 @@
                 <a:ea typeface="Times New Roman" pitchFamily="34" charset="-122"/>
                 <a:cs typeface="Times New Roman" pitchFamily="34" charset="-120"/>
               </a:rPr>
-              <a:t>1. Great Circles (continued)</a:t>
+              <a:t>DEFINITIONS (continued)</a:t>
             </a:r>
             <a:endParaRPr lang="en-US" sz="3600" dirty="0"/>
           </a:p>
@@ -12143,7 +12462,7 @@
                 <a:ea typeface="Times New Roman" pitchFamily="34" charset="-122"/>
                 <a:cs typeface="Times New Roman" pitchFamily="34" charset="-120"/>
               </a:rPr>
-              <a:t>Examples: </a:t>
+              <a:t>Small circle: </a:t>
             </a:r>
             <a:pPr algn="l" indent="0" marL="0">
               <a:spcAft>
@@ -12160,7 +12479,7 @@
                 <a:ea typeface="Times New Roman" pitchFamily="34" charset="-122"/>
                 <a:cs typeface="Times New Roman" pitchFamily="34" charset="-120"/>
               </a:rPr>
-              <a:t>The Equator and every meridian joined to its opposite meridian are great circles.</a:t>
+              <a:t>It is a circle whose plane does not pass through the centre of the Earth.</a:t>
             </a:r>
             <a:endParaRPr lang="en-US" sz="4000" dirty="0"/>
           </a:p>
@@ -12180,7 +12499,7 @@
                 <a:ea typeface="Times New Roman" pitchFamily="34" charset="-122"/>
                 <a:cs typeface="Times New Roman" pitchFamily="34" charset="-120"/>
               </a:rPr>
-              <a:t>Importance: </a:t>
+              <a:t>International Date Line: </a:t>
             </a:r>
             <a:pPr algn="l" indent="0" marL="0">
               <a:spcAft>
@@ -12197,7 +12516,7 @@
                 <a:ea typeface="Times New Roman" pitchFamily="34" charset="-122"/>
                 <a:cs typeface="Times New Roman" pitchFamily="34" charset="-120"/>
               </a:rPr>
-              <a:t>A great circle gives the shortest route between two places, so pilots and ships follow it.</a:t>
+              <a:t>It is the imaginary line, near the 180° meridian, where each new calendar day begins.</a:t>
             </a:r>
             <a:endParaRPr lang="en-US" sz="4000" dirty="0"/>
           </a:p>
@@ -12323,8 +12642,8 @@
         </p:nvSpPr>
         <p:spPr>
           <a:xfrm>
-            <a:off x="457200" y="1005840"/>
-            <a:ext cx="11277295" cy="731520"/>
+            <a:off x="365760" y="1005840"/>
+            <a:ext cx="11460175" cy="731520"/>
           </a:xfrm>
           <a:prstGeom prst="rect">
             <a:avLst/>
@@ -12333,7 +12652,9 @@
           <a:ln/>
         </p:spPr>
         <p:txBody>
-          <a:bodyPr wrap="square" lIns="0" tIns="0" rIns="0" bIns="0" rtlCol="0" anchor="ctr"/>
+          <a:bodyPr wrap="square" lIns="0" tIns="0" rIns="0" bIns="0" rtlCol="0" anchor="ctr">
+            <a:normAutofit/>
+          </a:bodyPr>
           <a:lstStyle/>
           <a:p>
             <a:pPr algn="ctr" indent="0" marL="0">
@@ -12354,9 +12675,129 @@
           </a:p>
         </p:txBody>
       </p:sp>
+      <p:sp>
+        <p:nvSpPr>
+          <p:cNvPr id="4" name="Text 2"/>
+          <p:cNvSpPr/>
+          <p:nvPr/>
+        </p:nvSpPr>
+        <p:spPr>
+          <a:xfrm>
+            <a:off x="365760" y="1737360"/>
+            <a:ext cx="5120640" cy="457200"/>
+          </a:xfrm>
+          <a:prstGeom prst="rect">
+            <a:avLst/>
+          </a:prstGeom>
+          <a:noFill/>
+          <a:ln/>
+        </p:spPr>
+        <p:txBody>
+          <a:bodyPr wrap="square" lIns="0" tIns="0" rIns="0" bIns="0" rtlCol="0" anchor="ctr">
+            <a:normAutofit/>
+          </a:bodyPr>
+          <a:lstStyle/>
+          <a:p>
+            <a:pPr algn="l" indent="0" marL="0">
+              <a:buNone/>
+            </a:pPr>
+            <a:r>
+              <a:rPr lang="en-US" sz="3000" b="1" dirty="0">
+                <a:solidFill>
+                  <a:srgbClr val="990011"/>
+                </a:solidFill>
+                <a:latin typeface="Times New Roman" pitchFamily="34" charset="0"/>
+                <a:ea typeface="Times New Roman" pitchFamily="34" charset="-122"/>
+                <a:cs typeface="Times New Roman" pitchFamily="34" charset="-120"/>
+              </a:rPr>
+              <a:t>A) Illustrations</a:t>
+            </a:r>
+            <a:endParaRPr lang="en-US" sz="3000" dirty="0"/>
+          </a:p>
+        </p:txBody>
+      </p:sp>
+      <p:sp>
+        <p:nvSpPr>
+          <p:cNvPr id="5" name="Text 3"/>
+          <p:cNvSpPr/>
+          <p:nvPr/>
+        </p:nvSpPr>
+        <p:spPr>
+          <a:xfrm>
+            <a:off x="365760" y="2240280"/>
+            <a:ext cx="4846320" cy="4160520"/>
+          </a:xfrm>
+          <a:prstGeom prst="rect">
+            <a:avLst/>
+          </a:prstGeom>
+          <a:noFill/>
+          <a:ln/>
+        </p:spPr>
+        <p:txBody>
+          <a:bodyPr wrap="square" lIns="0" tIns="0" rIns="0" bIns="0" rtlCol="0" anchor="t"/>
+          <a:lstStyle/>
+          <a:p>
+            <a:pPr algn="l" indent="0" marL="0">
+              <a:spcAft>
+                <a:spcPts val="800"/>
+              </a:spcAft>
+              <a:buNone/>
+            </a:pPr>
+            <a:r>
+              <a:rPr lang="en-US" sz="3600" i="1" dirty="0">
+                <a:solidFill>
+                  <a:srgbClr val="111111"/>
+                </a:solidFill>
+                <a:latin typeface="Times New Roman" pitchFamily="34" charset="0"/>
+                <a:ea typeface="Times New Roman" pitchFamily="34" charset="-122"/>
+                <a:cs typeface="Times New Roman" pitchFamily="34" charset="-120"/>
+              </a:rPr>
+              <a:t>Great and small circles are illustrated by the following examples:</a:t>
+            </a:r>
+            <a:endParaRPr lang="en-US" sz="3600" dirty="0"/>
+          </a:p>
+          <a:p>
+            <a:pPr algn="l" indent="0" marL="0">
+              <a:spcAft>
+                <a:spcPts val="800"/>
+              </a:spcAft>
+              <a:buNone/>
+            </a:pPr>
+            <a:r>
+              <a:rPr lang="en-US" sz="3600" b="1" dirty="0">
+                <a:solidFill>
+                  <a:srgbClr val="111111"/>
+                </a:solidFill>
+                <a:latin typeface="Times New Roman" pitchFamily="34" charset="0"/>
+                <a:ea typeface="Times New Roman" pitchFamily="34" charset="-122"/>
+                <a:cs typeface="Times New Roman" pitchFamily="34" charset="-120"/>
+              </a:rPr>
+              <a:t>The Equator: </a:t>
+            </a:r>
+            <a:pPr algn="l" indent="0" marL="0">
+              <a:spcAft>
+                <a:spcPts val="800"/>
+              </a:spcAft>
+              <a:buNone/>
+            </a:pPr>
+            <a:r>
+              <a:rPr lang="en-US" sz="3600" dirty="0">
+                <a:solidFill>
+                  <a:srgbClr val="111111"/>
+                </a:solidFill>
+                <a:latin typeface="Times New Roman" pitchFamily="34" charset="0"/>
+                <a:ea typeface="Times New Roman" pitchFamily="34" charset="-122"/>
+                <a:cs typeface="Times New Roman" pitchFamily="34" charset="-120"/>
+              </a:rPr>
+              <a:t>It is the only line of latitude that is a great circle.</a:t>
+            </a:r>
+            <a:endParaRPr lang="en-US" sz="3600" dirty="0"/>
+          </a:p>
+        </p:txBody>
+      </p:sp>
       <p:pic>
         <p:nvPicPr>
-          <p:cNvPr id="4" name="Image 0" descr="/home/claude/f4/img/v2/great_circles_big.png">    </p:cNvPr>
+          <p:cNvPr id="6" name="Image 0" descr="/home/claude/f4/img/v2/great_circles_big.png">    </p:cNvPr>
           <p:cNvPicPr>
             <a:picLocks noChangeAspect="1"/>
           </p:cNvPicPr>
@@ -12370,8 +12811,8 @@
         </p:blipFill>
         <p:spPr>
           <a:xfrm>
-            <a:off x="629930" y="1783080"/>
-            <a:ext cx="10931835" cy="4270248"/>
+            <a:off x="5349240" y="2617506"/>
+            <a:ext cx="6659575" cy="2601397"/>
           </a:xfrm>
           <a:prstGeom prst="rect">
             <a:avLst/>
@@ -12380,14 +12821,14 @@
       </p:pic>
       <p:sp>
         <p:nvSpPr>
-          <p:cNvPr id="5" name="Text 2"/>
+          <p:cNvPr id="7" name="Text 4"/>
           <p:cNvSpPr/>
           <p:nvPr/>
         </p:nvSpPr>
         <p:spPr>
           <a:xfrm>
-            <a:off x="457200" y="6089904"/>
-            <a:ext cx="11277295" cy="347472"/>
+            <a:off x="5349240" y="6089904"/>
+            <a:ext cx="6659575" cy="347472"/>
           </a:xfrm>
           <a:prstGeom prst="rect">
             <a:avLst/>
@@ -12403,7 +12844,7 @@
               <a:buNone/>
             </a:pPr>
             <a:r>
-              <a:rPr lang="en-US" sz="1800" i="1" dirty="0">
+              <a:rPr lang="en-US" sz="1600" i="1" dirty="0">
                 <a:solidFill>
                   <a:srgbClr val="555555"/>
                 </a:solidFill>
@@ -12411,9 +12852,9 @@
                 <a:ea typeface="Times New Roman" pitchFamily="34" charset="-122"/>
                 <a:cs typeface="Times New Roman" pitchFamily="34" charset="-120"/>
               </a:rPr>
-              <a:t>Illustration: great circles and small circles</a:t>
-            </a:r>
-            <a:endParaRPr lang="en-US" sz="1800" dirty="0"/>
+              <a:t>Illustration: great and small circles</a:t>
+            </a:r>
+            <a:endParaRPr lang="en-US" sz="1600" dirty="0"/>
           </a:p>
         </p:txBody>
       </p:sp>
@@ -12588,7 +13029,7 @@
                 <a:ea typeface="Times New Roman" pitchFamily="34" charset="-122"/>
                 <a:cs typeface="Times New Roman" pitchFamily="34" charset="-120"/>
               </a:rPr>
-              <a:t>2. The International Date Line</a:t>
+              <a:t>1. Great Circles</a:t>
             </a:r>
             <a:endParaRPr lang="en-US" sz="3600" dirty="0"/>
           </a:p>
@@ -12602,8 +13043,47 @@
         </p:nvSpPr>
         <p:spPr>
           <a:xfrm>
-            <a:off x="4069080" y="1783080"/>
-            <a:ext cx="7802575" cy="4663440"/>
+            <a:off x="4069080" y="1737360"/>
+            <a:ext cx="7802575" cy="457200"/>
+          </a:xfrm>
+          <a:prstGeom prst="rect">
+            <a:avLst/>
+          </a:prstGeom>
+          <a:noFill/>
+          <a:ln/>
+        </p:spPr>
+        <p:txBody>
+          <a:bodyPr wrap="square" lIns="0" tIns="0" rIns="0" bIns="0" rtlCol="0" anchor="ctr"/>
+          <a:lstStyle/>
+          <a:p>
+            <a:pPr algn="l" indent="0" marL="0">
+              <a:buNone/>
+            </a:pPr>
+            <a:r>
+              <a:rPr lang="en-US" sz="3200" b="1" dirty="0">
+                <a:solidFill>
+                  <a:srgbClr val="990011"/>
+                </a:solidFill>
+                <a:latin typeface="Times New Roman" pitchFamily="34" charset="0"/>
+                <a:ea typeface="Times New Roman" pitchFamily="34" charset="-122"/>
+                <a:cs typeface="Times New Roman" pitchFamily="34" charset="-120"/>
+              </a:rPr>
+              <a:t>A) Illustrations</a:t>
+            </a:r>
+            <a:endParaRPr lang="en-US" sz="3200" dirty="0"/>
+          </a:p>
+        </p:txBody>
+      </p:sp>
+      <p:sp>
+        <p:nvSpPr>
+          <p:cNvPr id="6" name="Text 3"/>
+          <p:cNvSpPr/>
+          <p:nvPr/>
+        </p:nvSpPr>
+        <p:spPr>
+          <a:xfrm>
+            <a:off x="4069080" y="2240280"/>
+            <a:ext cx="7802575" cy="4206240"/>
           </a:xfrm>
           <a:prstGeom prst="rect">
             <a:avLst/>
@@ -12622,7 +13102,7 @@
               <a:buNone/>
             </a:pPr>
             <a:r>
-              <a:rPr lang="en-US" sz="4000" i="1" dirty="0">
+              <a:rPr lang="en-US" sz="4000" b="1" dirty="0">
                 <a:solidFill>
                   <a:srgbClr val="111111"/>
                 </a:solidFill>
@@ -12630,11 +13110,8 @@
                 <a:ea typeface="Times New Roman" pitchFamily="34" charset="-122"/>
                 <a:cs typeface="Times New Roman" pitchFamily="34" charset="-120"/>
               </a:rPr>
-              <a:t>The International Date Line is explained as follows:</a:t>
-            </a:r>
-            <a:endParaRPr lang="en-US" sz="4000" dirty="0"/>
-          </a:p>
-          <a:p>
+              <a:t>Meridians: </a:t>
+            </a:r>
             <a:pPr algn="l" indent="0" marL="0">
               <a:spcAft>
                 <a:spcPts val="800"/>
@@ -12642,7 +13119,7 @@
               <a:buNone/>
             </a:pPr>
             <a:r>
-              <a:rPr lang="en-US" sz="4000" b="1" dirty="0">
+              <a:rPr lang="en-US" sz="4000" dirty="0">
                 <a:solidFill>
                   <a:srgbClr val="111111"/>
                 </a:solidFill>
@@ -12650,8 +13127,11 @@
                 <a:ea typeface="Times New Roman" pitchFamily="34" charset="-122"/>
                 <a:cs typeface="Times New Roman" pitchFamily="34" charset="-120"/>
               </a:rPr>
-              <a:t>Meaning: </a:t>
-            </a:r>
+              <a:t>Every meridian joined to its opposite meridian forms a great circle.</a:t>
+            </a:r>
+            <a:endParaRPr lang="en-US" sz="4000" dirty="0"/>
+          </a:p>
+          <a:p>
             <a:pPr algn="l" indent="0" marL="0">
               <a:spcAft>
                 <a:spcPts val="800"/>
@@ -12659,7 +13139,7 @@
               <a:buNone/>
             </a:pPr>
             <a:r>
-              <a:rPr lang="en-US" sz="4000" dirty="0">
+              <a:rPr lang="en-US" sz="4000" b="1" dirty="0">
                 <a:solidFill>
                   <a:srgbClr val="111111"/>
                 </a:solidFill>
@@ -12667,11 +13147,8 @@
                 <a:ea typeface="Times New Roman" pitchFamily="34" charset="-122"/>
                 <a:cs typeface="Times New Roman" pitchFamily="34" charset="-120"/>
               </a:rPr>
-              <a:t>It is the line where each new calendar day begins.</a:t>
-            </a:r>
-            <a:endParaRPr lang="en-US" sz="4000" dirty="0"/>
-          </a:p>
-          <a:p>
+              <a:t>Small circles: </a:t>
+            </a:r>
             <a:pPr algn="l" indent="0" marL="0">
               <a:spcAft>
                 <a:spcPts val="800"/>
@@ -12679,7 +13156,7 @@
               <a:buNone/>
             </a:pPr>
             <a:r>
-              <a:rPr lang="en-US" sz="4000" b="1" dirty="0">
+              <a:rPr lang="en-US" sz="4000" dirty="0">
                 <a:solidFill>
                   <a:srgbClr val="111111"/>
                 </a:solidFill>
@@ -12687,24 +13164,7 @@
                 <a:ea typeface="Times New Roman" pitchFamily="34" charset="-122"/>
                 <a:cs typeface="Times New Roman" pitchFamily="34" charset="-120"/>
               </a:rPr>
-              <a:t>Position: </a:t>
-            </a:r>
-            <a:pPr algn="l" indent="0" marL="0">
-              <a:spcAft>
-                <a:spcPts val="800"/>
-              </a:spcAft>
-              <a:buNone/>
-            </a:pPr>
-            <a:r>
-              <a:rPr lang="en-US" sz="4000" dirty="0">
-                <a:solidFill>
-                  <a:srgbClr val="111111"/>
-                </a:solidFill>
-                <a:latin typeface="Times New Roman" pitchFamily="34" charset="0"/>
-                <a:ea typeface="Times New Roman" pitchFamily="34" charset="-122"/>
-                <a:cs typeface="Times New Roman" pitchFamily="34" charset="-120"/>
-              </a:rPr>
-              <a:t>It follows the 180° meridian in the Pacific Ocean but bends to avoid land.</a:t>
+              <a:t>The tropics, the polar circles and all other parallels are small circles.</a:t>
             </a:r>
             <a:endParaRPr lang="en-US" sz="4000" dirty="0"/>
           </a:p>
@@ -12881,7 +13341,7 @@
                 <a:ea typeface="Times New Roman" pitchFamily="34" charset="-122"/>
                 <a:cs typeface="Times New Roman" pitchFamily="34" charset="-120"/>
               </a:rPr>
-              <a:t>2. The International Date Line (continued)</a:t>
+              <a:t>1. Great Circles</a:t>
             </a:r>
             <a:endParaRPr lang="en-US" sz="3600" dirty="0"/>
           </a:p>
@@ -12895,8 +13355,47 @@
         </p:nvSpPr>
         <p:spPr>
           <a:xfrm>
-            <a:off x="5349240" y="1783080"/>
-            <a:ext cx="6522415" cy="4663440"/>
+            <a:off x="5349240" y="1737360"/>
+            <a:ext cx="6522415" cy="457200"/>
+          </a:xfrm>
+          <a:prstGeom prst="rect">
+            <a:avLst/>
+          </a:prstGeom>
+          <a:noFill/>
+          <a:ln/>
+        </p:spPr>
+        <p:txBody>
+          <a:bodyPr wrap="square" lIns="0" tIns="0" rIns="0" bIns="0" rtlCol="0" anchor="ctr"/>
+          <a:lstStyle/>
+          <a:p>
+            <a:pPr algn="l" indent="0" marL="0">
+              <a:buNone/>
+            </a:pPr>
+            <a:r>
+              <a:rPr lang="en-US" sz="3200" b="1" dirty="0">
+                <a:solidFill>
+                  <a:srgbClr val="990011"/>
+                </a:solidFill>
+                <a:latin typeface="Times New Roman" pitchFamily="34" charset="0"/>
+                <a:ea typeface="Times New Roman" pitchFamily="34" charset="-122"/>
+                <a:cs typeface="Times New Roman" pitchFamily="34" charset="-120"/>
+              </a:rPr>
+              <a:t>B) Importance</a:t>
+            </a:r>
+            <a:endParaRPr lang="en-US" sz="3200" dirty="0"/>
+          </a:p>
+        </p:txBody>
+      </p:sp>
+      <p:sp>
+        <p:nvSpPr>
+          <p:cNvPr id="6" name="Text 3"/>
+          <p:cNvSpPr/>
+          <p:nvPr/>
+        </p:nvSpPr>
+        <p:spPr>
+          <a:xfrm>
+            <a:off x="5349240" y="2240280"/>
+            <a:ext cx="6522415" cy="4206240"/>
           </a:xfrm>
           <a:prstGeom prst="rect">
             <a:avLst/>
@@ -12915,7 +13414,7 @@
               <a:buNone/>
             </a:pPr>
             <a:r>
-              <a:rPr lang="en-US" sz="4000" b="1" dirty="0">
+              <a:rPr lang="en-US" sz="4000" i="1" dirty="0">
                 <a:solidFill>
                   <a:srgbClr val="111111"/>
                 </a:solidFill>
@@ -12923,8 +13422,11 @@
                 <a:ea typeface="Times New Roman" pitchFamily="34" charset="-122"/>
                 <a:cs typeface="Times New Roman" pitchFamily="34" charset="-120"/>
               </a:rPr>
-              <a:t>Crossing westwards: </a:t>
-            </a:r>
+              <a:t>Great circles are important for the following reasons:</a:t>
+            </a:r>
+            <a:endParaRPr lang="en-US" sz="4000" dirty="0"/>
+          </a:p>
+          <a:p>
             <a:pPr algn="l" indent="0" marL="0">
               <a:spcAft>
                 <a:spcPts val="800"/>
@@ -12932,7 +13434,7 @@
               <a:buNone/>
             </a:pPr>
             <a:r>
-              <a:rPr lang="en-US" sz="4000" dirty="0">
+              <a:rPr lang="en-US" sz="4000" b="1" dirty="0">
                 <a:solidFill>
                   <a:srgbClr val="111111"/>
                 </a:solidFill>
@@ -12940,11 +13442,8 @@
                 <a:ea typeface="Times New Roman" pitchFamily="34" charset="-122"/>
                 <a:cs typeface="Times New Roman" pitchFamily="34" charset="-120"/>
               </a:rPr>
-              <a:t>A traveller who crosses it going west adds one day.</a:t>
-            </a:r>
-            <a:endParaRPr lang="en-US" sz="4000" dirty="0"/>
-          </a:p>
-          <a:p>
+              <a:t>Shortest route: </a:t>
+            </a:r>
             <a:pPr algn="l" indent="0" marL="0">
               <a:spcAft>
                 <a:spcPts val="800"/>
@@ -12952,7 +13451,7 @@
               <a:buNone/>
             </a:pPr>
             <a:r>
-              <a:rPr lang="en-US" sz="4000" b="1" dirty="0">
+              <a:rPr lang="en-US" sz="4000" dirty="0">
                 <a:solidFill>
                   <a:srgbClr val="111111"/>
                 </a:solidFill>
@@ -12960,24 +13459,7 @@
                 <a:ea typeface="Times New Roman" pitchFamily="34" charset="-122"/>
                 <a:cs typeface="Times New Roman" pitchFamily="34" charset="-120"/>
               </a:rPr>
-              <a:t>Crossing eastwards: </a:t>
-            </a:r>
-            <a:pPr algn="l" indent="0" marL="0">
-              <a:spcAft>
-                <a:spcPts val="800"/>
-              </a:spcAft>
-              <a:buNone/>
-            </a:pPr>
-            <a:r>
-              <a:rPr lang="en-US" sz="4000" dirty="0">
-                <a:solidFill>
-                  <a:srgbClr val="111111"/>
-                </a:solidFill>
-                <a:latin typeface="Times New Roman" pitchFamily="34" charset="0"/>
-                <a:ea typeface="Times New Roman" pitchFamily="34" charset="-122"/>
-                <a:cs typeface="Times New Roman" pitchFamily="34" charset="-120"/>
-              </a:rPr>
-              <a:t>A traveller who crosses it going east removes one day.</a:t>
+              <a:t>A great circle gives the shortest distance between two places on the Earth.</a:t>
             </a:r>
             <a:endParaRPr lang="en-US" sz="4000" dirty="0"/>
           </a:p>
@@ -13095,48 +13577,9 @@
           </a:p>
         </p:txBody>
       </p:sp>
-      <p:sp>
-        <p:nvSpPr>
-          <p:cNvPr id="3" name="Text 1"/>
-          <p:cNvSpPr/>
-          <p:nvPr/>
-        </p:nvSpPr>
-        <p:spPr>
-          <a:xfrm>
-            <a:off x="457200" y="1005840"/>
-            <a:ext cx="11277295" cy="731520"/>
-          </a:xfrm>
-          <a:prstGeom prst="rect">
-            <a:avLst/>
-          </a:prstGeom>
-          <a:noFill/>
-          <a:ln/>
-        </p:spPr>
-        <p:txBody>
-          <a:bodyPr wrap="square" lIns="0" tIns="0" rIns="0" bIns="0" rtlCol="0" anchor="ctr"/>
-          <a:lstStyle/>
-          <a:p>
-            <a:pPr algn="ctr" indent="0" marL="0">
-              <a:buNone/>
-            </a:pPr>
-            <a:r>
-              <a:rPr lang="en-US" sz="3600" b="1" dirty="0">
-                <a:solidFill>
-                  <a:srgbClr val="990011"/>
-                </a:solidFill>
-                <a:latin typeface="Times New Roman" pitchFamily="34" charset="0"/>
-                <a:ea typeface="Times New Roman" pitchFamily="34" charset="-122"/>
-                <a:cs typeface="Times New Roman" pitchFamily="34" charset="-120"/>
-              </a:rPr>
-              <a:t>2. The International Date Line</a:t>
-            </a:r>
-            <a:endParaRPr lang="en-US" sz="3600" dirty="0"/>
-          </a:p>
-        </p:txBody>
-      </p:sp>
       <p:pic>
         <p:nvPicPr>
-          <p:cNvPr id="4" name="Image 0" descr="/home/claude/f4/img/v2/idl_big.png">    </p:cNvPr>
+          <p:cNvPr id="3" name="Image 0" descr="/home/claude/f4/img/minesec_sheet.png">    </p:cNvPr>
           <p:cNvPicPr>
             <a:picLocks noChangeAspect="1"/>
           </p:cNvPicPr>
@@ -13150,8 +13593,8 @@
         </p:blipFill>
         <p:spPr>
           <a:xfrm>
-            <a:off x="629930" y="1783080"/>
-            <a:ext cx="10931835" cy="4270248"/>
+            <a:off x="0" y="658368"/>
+            <a:ext cx="2468880" cy="5833872"/>
           </a:xfrm>
           <a:prstGeom prst="rect">
             <a:avLst/>
@@ -13160,14 +13603,14 @@
       </p:pic>
       <p:sp>
         <p:nvSpPr>
-          <p:cNvPr id="5" name="Text 2"/>
+          <p:cNvPr id="4" name="Text 1"/>
           <p:cNvSpPr/>
           <p:nvPr/>
         </p:nvSpPr>
         <p:spPr>
           <a:xfrm>
-            <a:off x="457200" y="6089904"/>
-            <a:ext cx="11277295" cy="347472"/>
+            <a:off x="2697480" y="1005840"/>
+            <a:ext cx="9174175" cy="731520"/>
           </a:xfrm>
           <a:prstGeom prst="rect">
             <a:avLst/>
@@ -13176,24 +13619,198 @@
           <a:ln/>
         </p:spPr>
         <p:txBody>
-          <a:bodyPr wrap="square" lIns="0" tIns="0" rIns="0" bIns="0" rtlCol="0" anchor="ctr"/>
+          <a:bodyPr wrap="square" lIns="0" tIns="0" rIns="0" bIns="0" rtlCol="0" anchor="ctr">
+            <a:normAutofit/>
+          </a:bodyPr>
           <a:lstStyle/>
           <a:p>
             <a:pPr algn="ctr" indent="0" marL="0">
               <a:buNone/>
             </a:pPr>
             <a:r>
-              <a:rPr lang="en-US" sz="1800" i="1" dirty="0">
-                <a:solidFill>
-                  <a:srgbClr val="555555"/>
+              <a:rPr lang="en-US" sz="3600" b="1" dirty="0">
+                <a:solidFill>
+                  <a:srgbClr val="990011"/>
                 </a:solidFill>
                 <a:latin typeface="Times New Roman" pitchFamily="34" charset="0"/>
                 <a:ea typeface="Times New Roman" pitchFamily="34" charset="-122"/>
                 <a:cs typeface="Times New Roman" pitchFamily="34" charset="-120"/>
               </a:rPr>
-              <a:t>Illustration: the International Date Line</a:t>
-            </a:r>
-            <a:endParaRPr lang="en-US" sz="1800" dirty="0"/>
+              <a:t>1. Great Circles</a:t>
+            </a:r>
+            <a:endParaRPr lang="en-US" sz="3600" dirty="0"/>
+          </a:p>
+        </p:txBody>
+      </p:sp>
+      <p:sp>
+        <p:nvSpPr>
+          <p:cNvPr id="5" name="Text 2"/>
+          <p:cNvSpPr/>
+          <p:nvPr/>
+        </p:nvSpPr>
+        <p:spPr>
+          <a:xfrm>
+            <a:off x="2697480" y="1737360"/>
+            <a:ext cx="9174175" cy="457200"/>
+          </a:xfrm>
+          <a:prstGeom prst="rect">
+            <a:avLst/>
+          </a:prstGeom>
+          <a:noFill/>
+          <a:ln/>
+        </p:spPr>
+        <p:txBody>
+          <a:bodyPr wrap="square" lIns="0" tIns="0" rIns="0" bIns="0" rtlCol="0" anchor="ctr"/>
+          <a:lstStyle/>
+          <a:p>
+            <a:pPr algn="l" indent="0" marL="0">
+              <a:buNone/>
+            </a:pPr>
+            <a:r>
+              <a:rPr lang="en-US" sz="3200" b="1" dirty="0">
+                <a:solidFill>
+                  <a:srgbClr val="990011"/>
+                </a:solidFill>
+                <a:latin typeface="Times New Roman" pitchFamily="34" charset="0"/>
+                <a:ea typeface="Times New Roman" pitchFamily="34" charset="-122"/>
+                <a:cs typeface="Times New Roman" pitchFamily="34" charset="-120"/>
+              </a:rPr>
+              <a:t>B) Importance (continued)</a:t>
+            </a:r>
+            <a:endParaRPr lang="en-US" sz="3200" dirty="0"/>
+          </a:p>
+        </p:txBody>
+      </p:sp>
+      <p:sp>
+        <p:nvSpPr>
+          <p:cNvPr id="6" name="Text 3"/>
+          <p:cNvSpPr/>
+          <p:nvPr/>
+        </p:nvSpPr>
+        <p:spPr>
+          <a:xfrm>
+            <a:off x="2697480" y="2240280"/>
+            <a:ext cx="9174175" cy="4206240"/>
+          </a:xfrm>
+          <a:prstGeom prst="rect">
+            <a:avLst/>
+          </a:prstGeom>
+          <a:noFill/>
+          <a:ln/>
+        </p:spPr>
+        <p:txBody>
+          <a:bodyPr wrap="square" lIns="0" tIns="0" rIns="0" bIns="0" rtlCol="0" anchor="t"/>
+          <a:lstStyle/>
+          <a:p>
+            <a:pPr algn="l" indent="0" marL="0">
+              <a:spcAft>
+                <a:spcPts val="800"/>
+              </a:spcAft>
+              <a:buNone/>
+            </a:pPr>
+            <a:r>
+              <a:rPr lang="en-US" sz="4000" b="1" dirty="0">
+                <a:solidFill>
+                  <a:srgbClr val="111111"/>
+                </a:solidFill>
+                <a:latin typeface="Times New Roman" pitchFamily="34" charset="0"/>
+                <a:ea typeface="Times New Roman" pitchFamily="34" charset="-122"/>
+                <a:cs typeface="Times New Roman" pitchFamily="34" charset="-120"/>
+              </a:rPr>
+              <a:t>Air transport: </a:t>
+            </a:r>
+            <a:pPr algn="l" indent="0" marL="0">
+              <a:spcAft>
+                <a:spcPts val="800"/>
+              </a:spcAft>
+              <a:buNone/>
+            </a:pPr>
+            <a:r>
+              <a:rPr lang="en-US" sz="4000" dirty="0">
+                <a:solidFill>
+                  <a:srgbClr val="111111"/>
+                </a:solidFill>
+                <a:latin typeface="Times New Roman" pitchFamily="34" charset="0"/>
+                <a:ea typeface="Times New Roman" pitchFamily="34" charset="-122"/>
+                <a:cs typeface="Times New Roman" pitchFamily="34" charset="-120"/>
+              </a:rPr>
+              <a:t>Aeroplanes follow great circle routes to save time and fuel.</a:t>
+            </a:r>
+            <a:endParaRPr lang="en-US" sz="4000" dirty="0"/>
+          </a:p>
+          <a:p>
+            <a:pPr algn="l" indent="0" marL="0">
+              <a:spcAft>
+                <a:spcPts val="800"/>
+              </a:spcAft>
+              <a:buNone/>
+            </a:pPr>
+            <a:r>
+              <a:rPr lang="en-US" sz="4000" b="1" dirty="0">
+                <a:solidFill>
+                  <a:srgbClr val="111111"/>
+                </a:solidFill>
+                <a:latin typeface="Times New Roman" pitchFamily="34" charset="0"/>
+                <a:ea typeface="Times New Roman" pitchFamily="34" charset="-122"/>
+                <a:cs typeface="Times New Roman" pitchFamily="34" charset="-120"/>
+              </a:rPr>
+              <a:t>Sea transport: </a:t>
+            </a:r>
+            <a:pPr algn="l" indent="0" marL="0">
+              <a:spcAft>
+                <a:spcPts val="800"/>
+              </a:spcAft>
+              <a:buNone/>
+            </a:pPr>
+            <a:r>
+              <a:rPr lang="en-US" sz="4000" dirty="0">
+                <a:solidFill>
+                  <a:srgbClr val="111111"/>
+                </a:solidFill>
+                <a:latin typeface="Times New Roman" pitchFamily="34" charset="0"/>
+                <a:ea typeface="Times New Roman" pitchFamily="34" charset="-122"/>
+                <a:cs typeface="Times New Roman" pitchFamily="34" charset="-120"/>
+              </a:rPr>
+              <a:t>Ships follow great circle routes on long ocean journeys.</a:t>
+            </a:r>
+            <a:endParaRPr lang="en-US" sz="4000" dirty="0"/>
+          </a:p>
+          <a:p>
+            <a:pPr algn="l" indent="0" marL="0">
+              <a:spcAft>
+                <a:spcPts val="800"/>
+              </a:spcAft>
+              <a:buNone/>
+            </a:pPr>
+            <a:r>
+              <a:rPr lang="en-US" sz="4000" b="1" dirty="0">
+                <a:solidFill>
+                  <a:srgbClr val="111111"/>
+                </a:solidFill>
+                <a:latin typeface="Times New Roman" pitchFamily="34" charset="0"/>
+                <a:ea typeface="Times New Roman" pitchFamily="34" charset="-122"/>
+                <a:cs typeface="Times New Roman" pitchFamily="34" charset="-120"/>
+              </a:rPr>
+              <a:t>Day and night: </a:t>
+            </a:r>
+            <a:pPr algn="l" indent="0" marL="0">
+              <a:spcAft>
+                <a:spcPts val="800"/>
+              </a:spcAft>
+              <a:buNone/>
+            </a:pPr>
+            <a:r>
+              <a:rPr lang="en-US" sz="4000" dirty="0">
+                <a:solidFill>
+                  <a:srgbClr val="111111"/>
+                </a:solidFill>
+                <a:latin typeface="Times New Roman" pitchFamily="34" charset="0"/>
+                <a:ea typeface="Times New Roman" pitchFamily="34" charset="-122"/>
+                <a:cs typeface="Times New Roman" pitchFamily="34" charset="-120"/>
+              </a:rPr>
+              <a:t>The line between day and night on the Earth is a great circle.</a:t>
+            </a:r>
+            <a:endParaRPr lang="en-US" sz="4000" dirty="0"/>
           </a:p>
         </p:txBody>
       </p:sp>
@@ -13303,15 +13920,176 @@
                 <a:ea typeface="Calibri" pitchFamily="34" charset="-122"/>
                 <a:cs typeface="Calibri" pitchFamily="34" charset="-120"/>
               </a:rPr>
-              <a:t>FORMATIVE EVALUATION</a:t>
+              <a:t>BOARD SUMMARY</a:t>
             </a:r>
             <a:endParaRPr lang="en-US" sz="1400" dirty="0"/>
+          </a:p>
+        </p:txBody>
+      </p:sp>
+      <p:sp>
+        <p:nvSpPr>
+          <p:cNvPr id="3" name="Text 1"/>
+          <p:cNvSpPr/>
+          <p:nvPr/>
+        </p:nvSpPr>
+        <p:spPr>
+          <a:xfrm>
+            <a:off x="365760" y="1005840"/>
+            <a:ext cx="11460175" cy="731520"/>
+          </a:xfrm>
+          <a:prstGeom prst="rect">
+            <a:avLst/>
+          </a:prstGeom>
+          <a:noFill/>
+          <a:ln/>
+        </p:spPr>
+        <p:txBody>
+          <a:bodyPr wrap="square" lIns="0" tIns="0" rIns="0" bIns="0" rtlCol="0" anchor="ctr">
+            <a:normAutofit/>
+          </a:bodyPr>
+          <a:lstStyle/>
+          <a:p>
+            <a:pPr algn="ctr" indent="0" marL="0">
+              <a:buNone/>
+            </a:pPr>
+            <a:r>
+              <a:rPr lang="en-US" sz="3600" b="1" dirty="0">
+                <a:solidFill>
+                  <a:srgbClr val="990011"/>
+                </a:solidFill>
+                <a:latin typeface="Times New Roman" pitchFamily="34" charset="0"/>
+                <a:ea typeface="Times New Roman" pitchFamily="34" charset="-122"/>
+                <a:cs typeface="Times New Roman" pitchFamily="34" charset="-120"/>
+              </a:rPr>
+              <a:t>2. The International Date Line</a:t>
+            </a:r>
+            <a:endParaRPr lang="en-US" sz="3600" dirty="0"/>
+          </a:p>
+        </p:txBody>
+      </p:sp>
+      <p:sp>
+        <p:nvSpPr>
+          <p:cNvPr id="4" name="Text 2"/>
+          <p:cNvSpPr/>
+          <p:nvPr/>
+        </p:nvSpPr>
+        <p:spPr>
+          <a:xfrm>
+            <a:off x="365760" y="1737360"/>
+            <a:ext cx="5120640" cy="457200"/>
+          </a:xfrm>
+          <a:prstGeom prst="rect">
+            <a:avLst/>
+          </a:prstGeom>
+          <a:noFill/>
+          <a:ln/>
+        </p:spPr>
+        <p:txBody>
+          <a:bodyPr wrap="square" lIns="0" tIns="0" rIns="0" bIns="0" rtlCol="0" anchor="ctr">
+            <a:normAutofit/>
+          </a:bodyPr>
+          <a:lstStyle/>
+          <a:p>
+            <a:pPr algn="l" indent="0" marL="0">
+              <a:buNone/>
+            </a:pPr>
+            <a:r>
+              <a:rPr lang="en-US" sz="3000" b="1" dirty="0">
+                <a:solidFill>
+                  <a:srgbClr val="990011"/>
+                </a:solidFill>
+                <a:latin typeface="Times New Roman" pitchFamily="34" charset="0"/>
+                <a:ea typeface="Times New Roman" pitchFamily="34" charset="-122"/>
+                <a:cs typeface="Times New Roman" pitchFamily="34" charset="-120"/>
+              </a:rPr>
+              <a:t>A) Illustration</a:t>
+            </a:r>
+            <a:endParaRPr lang="en-US" sz="3000" dirty="0"/>
+          </a:p>
+        </p:txBody>
+      </p:sp>
+      <p:sp>
+        <p:nvSpPr>
+          <p:cNvPr id="5" name="Text 3"/>
+          <p:cNvSpPr/>
+          <p:nvPr/>
+        </p:nvSpPr>
+        <p:spPr>
+          <a:xfrm>
+            <a:off x="365760" y="2240280"/>
+            <a:ext cx="4846320" cy="4160520"/>
+          </a:xfrm>
+          <a:prstGeom prst="rect">
+            <a:avLst/>
+          </a:prstGeom>
+          <a:noFill/>
+          <a:ln/>
+        </p:spPr>
+        <p:txBody>
+          <a:bodyPr wrap="square" lIns="0" tIns="0" rIns="0" bIns="0" rtlCol="0" anchor="t"/>
+          <a:lstStyle/>
+          <a:p>
+            <a:pPr algn="l" indent="0" marL="0">
+              <a:spcAft>
+                <a:spcPts val="800"/>
+              </a:spcAft>
+              <a:buNone/>
+            </a:pPr>
+            <a:r>
+              <a:rPr lang="en-US" sz="3600" i="1" dirty="0">
+                <a:solidFill>
+                  <a:srgbClr val="111111"/>
+                </a:solidFill>
+                <a:latin typeface="Times New Roman" pitchFamily="34" charset="0"/>
+                <a:ea typeface="Times New Roman" pitchFamily="34" charset="-122"/>
+                <a:cs typeface="Times New Roman" pitchFamily="34" charset="-120"/>
+              </a:rPr>
+              <a:t>The International Date Line is placed as follows:</a:t>
+            </a:r>
+            <a:endParaRPr lang="en-US" sz="3600" dirty="0"/>
+          </a:p>
+          <a:p>
+            <a:pPr algn="l" indent="0" marL="0">
+              <a:spcAft>
+                <a:spcPts val="800"/>
+              </a:spcAft>
+              <a:buNone/>
+            </a:pPr>
+            <a:r>
+              <a:rPr lang="en-US" sz="3600" b="1" dirty="0">
+                <a:solidFill>
+                  <a:srgbClr val="111111"/>
+                </a:solidFill>
+                <a:latin typeface="Times New Roman" pitchFamily="34" charset="0"/>
+                <a:ea typeface="Times New Roman" pitchFamily="34" charset="-122"/>
+                <a:cs typeface="Times New Roman" pitchFamily="34" charset="-120"/>
+              </a:rPr>
+              <a:t>Position: </a:t>
+            </a:r>
+            <a:pPr algn="l" indent="0" marL="0">
+              <a:spcAft>
+                <a:spcPts val="800"/>
+              </a:spcAft>
+              <a:buNone/>
+            </a:pPr>
+            <a:r>
+              <a:rPr lang="en-US" sz="3600" dirty="0">
+                <a:solidFill>
+                  <a:srgbClr val="111111"/>
+                </a:solidFill>
+                <a:latin typeface="Times New Roman" pitchFamily="34" charset="0"/>
+                <a:ea typeface="Times New Roman" pitchFamily="34" charset="-122"/>
+                <a:cs typeface="Times New Roman" pitchFamily="34" charset="-120"/>
+              </a:rPr>
+              <a:t>It follows the 180° meridian in the Pacific Ocean.</a:t>
+            </a:r>
+            <a:endParaRPr lang="en-US" sz="3600" dirty="0"/>
           </a:p>
         </p:txBody>
       </p:sp>
       <p:pic>
         <p:nvPicPr>
-          <p:cNvPr id="3" name="Image 0" descr="/home/claude/f4/img/minesec_sheet.png">    </p:cNvPr>
+          <p:cNvPr id="6" name="Image 0" descr="/home/claude/f4/img/v2/idl_big.png">    </p:cNvPr>
           <p:cNvPicPr>
             <a:picLocks noChangeAspect="1"/>
           </p:cNvPicPr>
@@ -13325,8 +14103,8 @@
         </p:blipFill>
         <p:spPr>
           <a:xfrm>
-            <a:off x="0" y="658368"/>
-            <a:ext cx="5120640" cy="5833872"/>
+            <a:off x="5349240" y="2617506"/>
+            <a:ext cx="6659575" cy="2601397"/>
           </a:xfrm>
           <a:prstGeom prst="rect">
             <a:avLst/>
@@ -13335,14 +14113,14 @@
       </p:pic>
       <p:sp>
         <p:nvSpPr>
-          <p:cNvPr id="4" name="Text 1"/>
+          <p:cNvPr id="7" name="Text 4"/>
           <p:cNvSpPr/>
           <p:nvPr/>
         </p:nvSpPr>
         <p:spPr>
           <a:xfrm>
-            <a:off x="5349240" y="1005840"/>
-            <a:ext cx="6522415" cy="731520"/>
+            <a:off x="5349240" y="6089904"/>
+            <a:ext cx="6659575" cy="347472"/>
           </a:xfrm>
           <a:prstGeom prst="rect">
             <a:avLst/>
@@ -13351,68 +14129,24 @@
           <a:ln/>
         </p:spPr>
         <p:txBody>
-          <a:bodyPr wrap="square" lIns="0" tIns="0" rIns="0" bIns="0" rtlCol="0" anchor="ctr">
-            <a:normAutofit/>
-          </a:bodyPr>
+          <a:bodyPr wrap="square" lIns="0" tIns="0" rIns="0" bIns="0" rtlCol="0" anchor="ctr"/>
           <a:lstStyle/>
           <a:p>
             <a:pPr algn="ctr" indent="0" marL="0">
               <a:buNone/>
             </a:pPr>
             <a:r>
-              <a:rPr lang="en-US" sz="3600" b="1" dirty="0">
-                <a:solidFill>
-                  <a:srgbClr val="990011"/>
+              <a:rPr lang="en-US" sz="1600" i="1" dirty="0">
+                <a:solidFill>
+                  <a:srgbClr val="555555"/>
                 </a:solidFill>
                 <a:latin typeface="Times New Roman" pitchFamily="34" charset="0"/>
                 <a:ea typeface="Times New Roman" pitchFamily="34" charset="-122"/>
                 <a:cs typeface="Times New Roman" pitchFamily="34" charset="-120"/>
               </a:rPr>
-              <a:t>Evaluation 1</a:t>
-            </a:r>
-            <a:endParaRPr lang="en-US" sz="3600" dirty="0"/>
-          </a:p>
-        </p:txBody>
-      </p:sp>
-      <p:sp>
-        <p:nvSpPr>
-          <p:cNvPr id="5" name="Text 2"/>
-          <p:cNvSpPr/>
-          <p:nvPr/>
-        </p:nvSpPr>
-        <p:spPr>
-          <a:xfrm>
-            <a:off x="5349240" y="1783080"/>
-            <a:ext cx="6522415" cy="4663440"/>
-          </a:xfrm>
-          <a:prstGeom prst="rect">
-            <a:avLst/>
-          </a:prstGeom>
-          <a:noFill/>
-          <a:ln/>
-        </p:spPr>
-        <p:txBody>
-          <a:bodyPr wrap="square" lIns="0" tIns="0" rIns="0" bIns="0" rtlCol="0" anchor="t"/>
-          <a:lstStyle/>
-          <a:p>
-            <a:pPr algn="l" indent="0" marL="0">
-              <a:spcAft>
-                <a:spcPts val="800"/>
-              </a:spcAft>
-              <a:buNone/>
-            </a:pPr>
-            <a:r>
-              <a:rPr lang="en-US" sz="4000" dirty="0">
-                <a:solidFill>
-                  <a:srgbClr val="111111"/>
-                </a:solidFill>
-                <a:latin typeface="Times New Roman" pitchFamily="34" charset="0"/>
-                <a:ea typeface="Times New Roman" pitchFamily="34" charset="-122"/>
-                <a:cs typeface="Times New Roman" pitchFamily="34" charset="-120"/>
-              </a:rPr>
-              <a:t>Is the Equator a great circle? Why?</a:t>
-            </a:r>
-            <a:endParaRPr lang="en-US" sz="4000" dirty="0"/>
+              <a:t>Illustration: the International Date Line</a:t>
+            </a:r>
+            <a:endParaRPr lang="en-US" sz="1600" dirty="0"/>
           </a:p>
         </p:txBody>
       </p:sp>
@@ -13522,7 +14256,7 @@
                 <a:ea typeface="Calibri" pitchFamily="34" charset="-122"/>
                 <a:cs typeface="Calibri" pitchFamily="34" charset="-120"/>
               </a:rPr>
-              <a:t>FORMATIVE EVALUATION</a:t>
+              <a:t>BOARD SUMMARY</a:t>
             </a:r>
             <a:endParaRPr lang="en-US" sz="1400" dirty="0"/>
           </a:p>
@@ -13545,7 +14279,7 @@
         <p:spPr>
           <a:xfrm>
             <a:off x="0" y="658368"/>
-            <a:ext cx="5120640" cy="5833872"/>
+            <a:ext cx="3840480" cy="5833872"/>
           </a:xfrm>
           <a:prstGeom prst="rect">
             <a:avLst/>
@@ -13560,8 +14294,8 @@
         </p:nvSpPr>
         <p:spPr>
           <a:xfrm>
-            <a:off x="5349240" y="1005840"/>
-            <a:ext cx="6522415" cy="731520"/>
+            <a:off x="4069080" y="1005840"/>
+            <a:ext cx="7802575" cy="731520"/>
           </a:xfrm>
           <a:prstGeom prst="rect">
             <a:avLst/>
@@ -13587,7 +14321,7 @@
                 <a:ea typeface="Times New Roman" pitchFamily="34" charset="-122"/>
                 <a:cs typeface="Times New Roman" pitchFamily="34" charset="-120"/>
               </a:rPr>
-              <a:t>Expected Answer</a:t>
+              <a:t>2. The International Date Line</a:t>
             </a:r>
             <a:endParaRPr lang="en-US" sz="3600" dirty="0"/>
           </a:p>
@@ -13601,8 +14335,47 @@
         </p:nvSpPr>
         <p:spPr>
           <a:xfrm>
-            <a:off x="5349240" y="1783080"/>
-            <a:ext cx="6522415" cy="4663440"/>
+            <a:off x="4069080" y="1737360"/>
+            <a:ext cx="7802575" cy="457200"/>
+          </a:xfrm>
+          <a:prstGeom prst="rect">
+            <a:avLst/>
+          </a:prstGeom>
+          <a:noFill/>
+          <a:ln/>
+        </p:spPr>
+        <p:txBody>
+          <a:bodyPr wrap="square" lIns="0" tIns="0" rIns="0" bIns="0" rtlCol="0" anchor="ctr"/>
+          <a:lstStyle/>
+          <a:p>
+            <a:pPr algn="l" indent="0" marL="0">
+              <a:buNone/>
+            </a:pPr>
+            <a:r>
+              <a:rPr lang="en-US" sz="3200" b="1" dirty="0">
+                <a:solidFill>
+                  <a:srgbClr val="990011"/>
+                </a:solidFill>
+                <a:latin typeface="Times New Roman" pitchFamily="34" charset="0"/>
+                <a:ea typeface="Times New Roman" pitchFamily="34" charset="-122"/>
+                <a:cs typeface="Times New Roman" pitchFamily="34" charset="-120"/>
+              </a:rPr>
+              <a:t>A) Illustration</a:t>
+            </a:r>
+            <a:endParaRPr lang="en-US" sz="3200" dirty="0"/>
+          </a:p>
+        </p:txBody>
+      </p:sp>
+      <p:sp>
+        <p:nvSpPr>
+          <p:cNvPr id="6" name="Text 3"/>
+          <p:cNvSpPr/>
+          <p:nvPr/>
+        </p:nvSpPr>
+        <p:spPr>
+          <a:xfrm>
+            <a:off x="4069080" y="2240280"/>
+            <a:ext cx="7802575" cy="4206240"/>
           </a:xfrm>
           <a:prstGeom prst="rect">
             <a:avLst/>
@@ -13621,7 +14394,7 @@
               <a:buNone/>
             </a:pPr>
             <a:r>
-              <a:rPr lang="en-US" sz="4000" dirty="0">
+              <a:rPr lang="en-US" sz="4000" b="1" dirty="0">
                 <a:solidFill>
                   <a:srgbClr val="111111"/>
                 </a:solidFill>
@@ -13629,7 +14402,61 @@
                 <a:ea typeface="Times New Roman" pitchFamily="34" charset="-122"/>
                 <a:cs typeface="Times New Roman" pitchFamily="34" charset="-120"/>
               </a:rPr>
-              <a:t>Yes. It cuts the Earth into two equal halves.</a:t>
+              <a:t>Bends: </a:t>
+            </a:r>
+            <a:pPr algn="l" indent="0" marL="0">
+              <a:spcAft>
+                <a:spcPts val="800"/>
+              </a:spcAft>
+              <a:buNone/>
+            </a:pPr>
+            <a:r>
+              <a:rPr lang="en-US" sz="4000" dirty="0">
+                <a:solidFill>
+                  <a:srgbClr val="111111"/>
+                </a:solidFill>
+                <a:latin typeface="Times New Roman" pitchFamily="34" charset="0"/>
+                <a:ea typeface="Times New Roman" pitchFamily="34" charset="-122"/>
+                <a:cs typeface="Times New Roman" pitchFamily="34" charset="-120"/>
+              </a:rPr>
+              <a:t>It bends around islands and countries so that each country keeps one date.</a:t>
+            </a:r>
+            <a:endParaRPr lang="en-US" sz="4000" dirty="0"/>
+          </a:p>
+          <a:p>
+            <a:pPr algn="l" indent="0" marL="0">
+              <a:spcAft>
+                <a:spcPts val="800"/>
+              </a:spcAft>
+              <a:buNone/>
+            </a:pPr>
+            <a:r>
+              <a:rPr lang="en-US" sz="4000" b="1" dirty="0">
+                <a:solidFill>
+                  <a:srgbClr val="111111"/>
+                </a:solidFill>
+                <a:latin typeface="Times New Roman" pitchFamily="34" charset="0"/>
+                <a:ea typeface="Times New Roman" pitchFamily="34" charset="-122"/>
+                <a:cs typeface="Times New Roman" pitchFamily="34" charset="-120"/>
+              </a:rPr>
+              <a:t>Two dates: </a:t>
+            </a:r>
+            <a:pPr algn="l" indent="0" marL="0">
+              <a:spcAft>
+                <a:spcPts val="800"/>
+              </a:spcAft>
+              <a:buNone/>
+            </a:pPr>
+            <a:r>
+              <a:rPr lang="en-US" sz="4000" dirty="0">
+                <a:solidFill>
+                  <a:srgbClr val="111111"/>
+                </a:solidFill>
+                <a:latin typeface="Times New Roman" pitchFamily="34" charset="0"/>
+                <a:ea typeface="Times New Roman" pitchFamily="34" charset="-122"/>
+                <a:cs typeface="Times New Roman" pitchFamily="34" charset="-120"/>
+              </a:rPr>
+              <a:t>West of the line the date is one day ahead of the date east of the line.</a:t>
             </a:r>
             <a:endParaRPr lang="en-US" sz="4000" dirty="0"/>
           </a:p>
@@ -13741,7 +14568,7 @@
                 <a:ea typeface="Calibri" pitchFamily="34" charset="-122"/>
                 <a:cs typeface="Calibri" pitchFamily="34" charset="-120"/>
               </a:rPr>
-              <a:t>FORMATIVE EVALUATION</a:t>
+              <a:t>BOARD SUMMARY</a:t>
             </a:r>
             <a:endParaRPr lang="en-US" sz="1400" dirty="0"/>
           </a:p>
@@ -13764,7 +14591,7 @@
         <p:spPr>
           <a:xfrm>
             <a:off x="0" y="658368"/>
-            <a:ext cx="5120640" cy="5833872"/>
+            <a:ext cx="2468880" cy="5833872"/>
           </a:xfrm>
           <a:prstGeom prst="rect">
             <a:avLst/>
@@ -13779,8 +14606,8 @@
         </p:nvSpPr>
         <p:spPr>
           <a:xfrm>
-            <a:off x="5349240" y="1005840"/>
-            <a:ext cx="6522415" cy="731520"/>
+            <a:off x="2697480" y="1005840"/>
+            <a:ext cx="9174175" cy="731520"/>
           </a:xfrm>
           <a:prstGeom prst="rect">
             <a:avLst/>
@@ -13806,7 +14633,7 @@
                 <a:ea typeface="Times New Roman" pitchFamily="34" charset="-122"/>
                 <a:cs typeface="Times New Roman" pitchFamily="34" charset="-120"/>
               </a:rPr>
-              <a:t>Evaluation 2</a:t>
+              <a:t>2. The International Date Line</a:t>
             </a:r>
             <a:endParaRPr lang="en-US" sz="3600" dirty="0"/>
           </a:p>
@@ -13820,8 +14647,47 @@
         </p:nvSpPr>
         <p:spPr>
           <a:xfrm>
-            <a:off x="5349240" y="1783080"/>
-            <a:ext cx="6522415" cy="4663440"/>
+            <a:off x="2697480" y="1737360"/>
+            <a:ext cx="9174175" cy="457200"/>
+          </a:xfrm>
+          <a:prstGeom prst="rect">
+            <a:avLst/>
+          </a:prstGeom>
+          <a:noFill/>
+          <a:ln/>
+        </p:spPr>
+        <p:txBody>
+          <a:bodyPr wrap="square" lIns="0" tIns="0" rIns="0" bIns="0" rtlCol="0" anchor="ctr"/>
+          <a:lstStyle/>
+          <a:p>
+            <a:pPr algn="l" indent="0" marL="0">
+              <a:buNone/>
+            </a:pPr>
+            <a:r>
+              <a:rPr lang="en-US" sz="3200" b="1" dirty="0">
+                <a:solidFill>
+                  <a:srgbClr val="990011"/>
+                </a:solidFill>
+                <a:latin typeface="Times New Roman" pitchFamily="34" charset="0"/>
+                <a:ea typeface="Times New Roman" pitchFamily="34" charset="-122"/>
+                <a:cs typeface="Times New Roman" pitchFamily="34" charset="-120"/>
+              </a:rPr>
+              <a:t>B) Importance</a:t>
+            </a:r>
+            <a:endParaRPr lang="en-US" sz="3200" dirty="0"/>
+          </a:p>
+        </p:txBody>
+      </p:sp>
+      <p:sp>
+        <p:nvSpPr>
+          <p:cNvPr id="6" name="Text 3"/>
+          <p:cNvSpPr/>
+          <p:nvPr/>
+        </p:nvSpPr>
+        <p:spPr>
+          <a:xfrm>
+            <a:off x="2697480" y="2240280"/>
+            <a:ext cx="9174175" cy="4206240"/>
           </a:xfrm>
           <a:prstGeom prst="rect">
             <a:avLst/>
@@ -13840,7 +14706,7 @@
               <a:buNone/>
             </a:pPr>
             <a:r>
-              <a:rPr lang="en-US" sz="4000" dirty="0">
+              <a:rPr lang="en-US" sz="4000" i="1" dirty="0">
                 <a:solidFill>
                   <a:srgbClr val="111111"/>
                 </a:solidFill>
@@ -13848,7 +14714,81 @@
                 <a:ea typeface="Times New Roman" pitchFamily="34" charset="-122"/>
                 <a:cs typeface="Times New Roman" pitchFamily="34" charset="-120"/>
               </a:rPr>
-              <a:t>What happens to the date when we cross the Date Line going west?</a:t>
+              <a:t>The International Date Line is important for the following reasons:</a:t>
+            </a:r>
+            <a:endParaRPr lang="en-US" sz="4000" dirty="0"/>
+          </a:p>
+          <a:p>
+            <a:pPr algn="l" indent="0" marL="0">
+              <a:spcAft>
+                <a:spcPts val="800"/>
+              </a:spcAft>
+              <a:buNone/>
+            </a:pPr>
+            <a:r>
+              <a:rPr lang="en-US" sz="4000" b="1" dirty="0">
+                <a:solidFill>
+                  <a:srgbClr val="111111"/>
+                </a:solidFill>
+                <a:latin typeface="Times New Roman" pitchFamily="34" charset="0"/>
+                <a:ea typeface="Times New Roman" pitchFamily="34" charset="-122"/>
+                <a:cs typeface="Times New Roman" pitchFamily="34" charset="-120"/>
+              </a:rPr>
+              <a:t>Start of the day: </a:t>
+            </a:r>
+            <a:pPr algn="l" indent="0" marL="0">
+              <a:spcAft>
+                <a:spcPts val="800"/>
+              </a:spcAft>
+              <a:buNone/>
+            </a:pPr>
+            <a:r>
+              <a:rPr lang="en-US" sz="4000" dirty="0">
+                <a:solidFill>
+                  <a:srgbClr val="111111"/>
+                </a:solidFill>
+                <a:latin typeface="Times New Roman" pitchFamily="34" charset="0"/>
+                <a:ea typeface="Times New Roman" pitchFamily="34" charset="-122"/>
+                <a:cs typeface="Times New Roman" pitchFamily="34" charset="-120"/>
+              </a:rPr>
+              <a:t>It shows where each new calendar day begins on the Earth.</a:t>
+            </a:r>
+            <a:endParaRPr lang="en-US" sz="4000" dirty="0"/>
+          </a:p>
+          <a:p>
+            <a:pPr algn="l" indent="0" marL="0">
+              <a:spcAft>
+                <a:spcPts val="800"/>
+              </a:spcAft>
+              <a:buNone/>
+            </a:pPr>
+            <a:r>
+              <a:rPr lang="en-US" sz="4000" b="1" dirty="0">
+                <a:solidFill>
+                  <a:srgbClr val="111111"/>
+                </a:solidFill>
+                <a:latin typeface="Times New Roman" pitchFamily="34" charset="0"/>
+                <a:ea typeface="Times New Roman" pitchFamily="34" charset="-122"/>
+                <a:cs typeface="Times New Roman" pitchFamily="34" charset="-120"/>
+              </a:rPr>
+              <a:t>Crossing westwards: </a:t>
+            </a:r>
+            <a:pPr algn="l" indent="0" marL="0">
+              <a:spcAft>
+                <a:spcPts val="800"/>
+              </a:spcAft>
+              <a:buNone/>
+            </a:pPr>
+            <a:r>
+              <a:rPr lang="en-US" sz="4000" dirty="0">
+                <a:solidFill>
+                  <a:srgbClr val="111111"/>
+                </a:solidFill>
+                <a:latin typeface="Times New Roman" pitchFamily="34" charset="0"/>
+                <a:ea typeface="Times New Roman" pitchFamily="34" charset="-122"/>
+                <a:cs typeface="Times New Roman" pitchFamily="34" charset="-120"/>
+              </a:rPr>
+              <a:t>A traveller who crosses it going west adds one day.</a:t>
             </a:r>
             <a:endParaRPr lang="en-US" sz="4000" dirty="0"/>
           </a:p>
@@ -13960,7 +14900,7 @@
                 <a:ea typeface="Calibri" pitchFamily="34" charset="-122"/>
                 <a:cs typeface="Calibri" pitchFamily="34" charset="-120"/>
               </a:rPr>
-              <a:t>FORMATIVE EVALUATION</a:t>
+              <a:t>BOARD SUMMARY</a:t>
             </a:r>
             <a:endParaRPr lang="en-US" sz="1400" dirty="0"/>
           </a:p>
@@ -13983,7 +14923,7 @@
         <p:spPr>
           <a:xfrm>
             <a:off x="0" y="658368"/>
-            <a:ext cx="5120640" cy="5833872"/>
+            <a:ext cx="3840480" cy="5833872"/>
           </a:xfrm>
           <a:prstGeom prst="rect">
             <a:avLst/>
@@ -13998,8 +14938,8 @@
         </p:nvSpPr>
         <p:spPr>
           <a:xfrm>
-            <a:off x="5349240" y="1005840"/>
-            <a:ext cx="6522415" cy="731520"/>
+            <a:off x="4069080" y="1005840"/>
+            <a:ext cx="7802575" cy="731520"/>
           </a:xfrm>
           <a:prstGeom prst="rect">
             <a:avLst/>
@@ -14025,7 +14965,7 @@
                 <a:ea typeface="Times New Roman" pitchFamily="34" charset="-122"/>
                 <a:cs typeface="Times New Roman" pitchFamily="34" charset="-120"/>
               </a:rPr>
-              <a:t>Expected Answer</a:t>
+              <a:t>2. The International Date Line</a:t>
             </a:r>
             <a:endParaRPr lang="en-US" sz="3600" dirty="0"/>
           </a:p>
@@ -14039,8 +14979,47 @@
         </p:nvSpPr>
         <p:spPr>
           <a:xfrm>
-            <a:off x="5349240" y="1783080"/>
-            <a:ext cx="6522415" cy="4663440"/>
+            <a:off x="4069080" y="1737360"/>
+            <a:ext cx="7802575" cy="457200"/>
+          </a:xfrm>
+          <a:prstGeom prst="rect">
+            <a:avLst/>
+          </a:prstGeom>
+          <a:noFill/>
+          <a:ln/>
+        </p:spPr>
+        <p:txBody>
+          <a:bodyPr wrap="square" lIns="0" tIns="0" rIns="0" bIns="0" rtlCol="0" anchor="ctr"/>
+          <a:lstStyle/>
+          <a:p>
+            <a:pPr algn="l" indent="0" marL="0">
+              <a:buNone/>
+            </a:pPr>
+            <a:r>
+              <a:rPr lang="en-US" sz="3200" b="1" dirty="0">
+                <a:solidFill>
+                  <a:srgbClr val="990011"/>
+                </a:solidFill>
+                <a:latin typeface="Times New Roman" pitchFamily="34" charset="0"/>
+                <a:ea typeface="Times New Roman" pitchFamily="34" charset="-122"/>
+                <a:cs typeface="Times New Roman" pitchFamily="34" charset="-120"/>
+              </a:rPr>
+              <a:t>B) Importance (continued)</a:t>
+            </a:r>
+            <a:endParaRPr lang="en-US" sz="3200" dirty="0"/>
+          </a:p>
+        </p:txBody>
+      </p:sp>
+      <p:sp>
+        <p:nvSpPr>
+          <p:cNvPr id="6" name="Text 3"/>
+          <p:cNvSpPr/>
+          <p:nvPr/>
+        </p:nvSpPr>
+        <p:spPr>
+          <a:xfrm>
+            <a:off x="4069080" y="2240280"/>
+            <a:ext cx="7802575" cy="4206240"/>
           </a:xfrm>
           <a:prstGeom prst="rect">
             <a:avLst/>
@@ -14059,7 +15038,7 @@
               <a:buNone/>
             </a:pPr>
             <a:r>
-              <a:rPr lang="en-US" sz="4000" dirty="0">
+              <a:rPr lang="en-US" sz="4000" b="1" dirty="0">
                 <a:solidFill>
                   <a:srgbClr val="111111"/>
                 </a:solidFill>
@@ -14067,7 +15046,61 @@
                 <a:ea typeface="Times New Roman" pitchFamily="34" charset="-122"/>
                 <a:cs typeface="Times New Roman" pitchFamily="34" charset="-120"/>
               </a:rPr>
-              <a:t>We add one day.</a:t>
+              <a:t>Crossing eastwards: </a:t>
+            </a:r>
+            <a:pPr algn="l" indent="0" marL="0">
+              <a:spcAft>
+                <a:spcPts val="800"/>
+              </a:spcAft>
+              <a:buNone/>
+            </a:pPr>
+            <a:r>
+              <a:rPr lang="en-US" sz="4000" dirty="0">
+                <a:solidFill>
+                  <a:srgbClr val="111111"/>
+                </a:solidFill>
+                <a:latin typeface="Times New Roman" pitchFamily="34" charset="0"/>
+                <a:ea typeface="Times New Roman" pitchFamily="34" charset="-122"/>
+                <a:cs typeface="Times New Roman" pitchFamily="34" charset="-120"/>
+              </a:rPr>
+              <a:t>A traveller who crosses it going east removes one day.</a:t>
+            </a:r>
+            <a:endParaRPr lang="en-US" sz="4000" dirty="0"/>
+          </a:p>
+          <a:p>
+            <a:pPr algn="l" indent="0" marL="0">
+              <a:spcAft>
+                <a:spcPts val="800"/>
+              </a:spcAft>
+              <a:buNone/>
+            </a:pPr>
+            <a:r>
+              <a:rPr lang="en-US" sz="4000" b="1" dirty="0">
+                <a:solidFill>
+                  <a:srgbClr val="111111"/>
+                </a:solidFill>
+                <a:latin typeface="Times New Roman" pitchFamily="34" charset="0"/>
+                <a:ea typeface="Times New Roman" pitchFamily="34" charset="-122"/>
+                <a:cs typeface="Times New Roman" pitchFamily="34" charset="-120"/>
+              </a:rPr>
+              <a:t>Correct dates: </a:t>
+            </a:r>
+            <a:pPr algn="l" indent="0" marL="0">
+              <a:spcAft>
+                <a:spcPts val="800"/>
+              </a:spcAft>
+              <a:buNone/>
+            </a:pPr>
+            <a:r>
+              <a:rPr lang="en-US" sz="4000" dirty="0">
+                <a:solidFill>
+                  <a:srgbClr val="111111"/>
+                </a:solidFill>
+                <a:latin typeface="Times New Roman" pitchFamily="34" charset="0"/>
+                <a:ea typeface="Times New Roman" pitchFamily="34" charset="-122"/>
+                <a:cs typeface="Times New Roman" pitchFamily="34" charset="-120"/>
+              </a:rPr>
+              <a:t>It allows travellers, ships and aeroplanes to keep the correct date.</a:t>
             </a:r>
             <a:endParaRPr lang="en-US" sz="4000" dirty="0"/>
           </a:p>
@@ -14179,7 +15212,7 @@
                 <a:ea typeface="Calibri" pitchFamily="34" charset="-122"/>
                 <a:cs typeface="Calibri" pitchFamily="34" charset="-120"/>
               </a:rPr>
-              <a:t>REMEDIATION</a:t>
+              <a:t>FORMATIVE EVALUATION</a:t>
             </a:r>
             <a:endParaRPr lang="en-US" sz="1400" dirty="0"/>
           </a:p>
@@ -14244,7 +15277,7 @@
                 <a:ea typeface="Times New Roman" pitchFamily="34" charset="-122"/>
                 <a:cs typeface="Times New Roman" pitchFamily="34" charset="-120"/>
               </a:rPr>
-              <a:t>Remediation</a:t>
+              <a:t>Evaluation 1</a:t>
             </a:r>
             <a:endParaRPr lang="en-US" sz="3600" dirty="0"/>
           </a:p>
@@ -14278,7 +15311,7 @@
               <a:buNone/>
             </a:pPr>
             <a:r>
-              <a:rPr lang="en-US" sz="4000" b="1" dirty="0">
+              <a:rPr lang="en-US" sz="4000" dirty="0">
                 <a:solidFill>
                   <a:srgbClr val="111111"/>
                 </a:solidFill>
@@ -14286,51 +15319,7 @@
                 <a:ea typeface="Times New Roman" pitchFamily="34" charset="-122"/>
                 <a:cs typeface="Times New Roman" pitchFamily="34" charset="-120"/>
               </a:rPr>
-              <a:t>Fill in the blanks:</a:t>
-            </a:r>
-            <a:endParaRPr lang="en-US" sz="4000" dirty="0"/>
-          </a:p>
-          <a:p>
-            <a:pPr algn="l" marL="342900" indent="-342900">
-              <a:spcAft>
-                <a:spcPts val="800"/>
-              </a:spcAft>
-              <a:buSzPct val="100000"/>
-              <a:buFont typeface="+mj-lt"/>
-              <a:buAutoNum type="arabicPeriod" startAt="1"/>
-            </a:pPr>
-            <a:r>
-              <a:rPr lang="en-US" sz="4000" dirty="0">
-                <a:solidFill>
-                  <a:srgbClr val="111111"/>
-                </a:solidFill>
-                <a:latin typeface="Times New Roman" pitchFamily="34" charset="0"/>
-                <a:ea typeface="Times New Roman" pitchFamily="34" charset="-122"/>
-                <a:cs typeface="Times New Roman" pitchFamily="34" charset="-120"/>
-              </a:rPr>
-              <a:t>A circle that cuts the Earth into two equal halves is a ______ circle.</a:t>
-            </a:r>
-            <a:endParaRPr lang="en-US" sz="4000" dirty="0"/>
-          </a:p>
-          <a:p>
-            <a:pPr algn="l" marL="342900" indent="-342900">
-              <a:spcAft>
-                <a:spcPts val="800"/>
-              </a:spcAft>
-              <a:buSzPct val="100000"/>
-              <a:buFont typeface="+mj-lt"/>
-              <a:buAutoNum type="arabicPeriod" startAt="1"/>
-            </a:pPr>
-            <a:r>
-              <a:rPr lang="en-US" sz="4000" dirty="0">
-                <a:solidFill>
-                  <a:srgbClr val="111111"/>
-                </a:solidFill>
-                <a:latin typeface="Times New Roman" pitchFamily="34" charset="0"/>
-                <a:ea typeface="Times New Roman" pitchFamily="34" charset="-122"/>
-                <a:cs typeface="Times New Roman" pitchFamily="34" charset="-120"/>
-              </a:rPr>
-              <a:t>The International Date Line follows the ______ degree line.</a:t>
+              <a:t>Is the Equator a great circle? Why?</a:t>
             </a:r>
             <a:endParaRPr lang="en-US" sz="4000" dirty="0"/>
           </a:p>
@@ -14681,7 +15670,7 @@
                 <a:ea typeface="Calibri" pitchFamily="34" charset="-122"/>
                 <a:cs typeface="Calibri" pitchFamily="34" charset="-120"/>
               </a:rPr>
-              <a:t>REMEDIATION</a:t>
+              <a:t>FORMATIVE EVALUATION</a:t>
             </a:r>
             <a:endParaRPr lang="en-US" sz="1400" dirty="0"/>
           </a:p>
@@ -14746,7 +15735,7 @@
                 <a:ea typeface="Times New Roman" pitchFamily="34" charset="-122"/>
                 <a:cs typeface="Times New Roman" pitchFamily="34" charset="-120"/>
               </a:rPr>
-              <a:t>Remediation (continued)</a:t>
+              <a:t>Expected Answer</a:t>
             </a:r>
             <a:endParaRPr lang="en-US" sz="3600" dirty="0"/>
           </a:p>
@@ -14773,13 +15762,11 @@
           <a:bodyPr wrap="square" lIns="0" tIns="0" rIns="0" bIns="0" rtlCol="0" anchor="t"/>
           <a:lstStyle/>
           <a:p>
-            <a:pPr algn="l" marL="342900" indent="-342900">
+            <a:pPr algn="l" indent="0" marL="0">
               <a:spcAft>
                 <a:spcPts val="800"/>
               </a:spcAft>
-              <a:buSzPct val="100000"/>
-              <a:buFont typeface="+mj-lt"/>
-              <a:buAutoNum type="arabicPeriod" startAt="1"/>
+              <a:buNone/>
             </a:pPr>
             <a:r>
               <a:rPr lang="en-US" sz="4000" dirty="0">
@@ -14790,7 +15777,7 @@
                 <a:ea typeface="Times New Roman" pitchFamily="34" charset="-122"/>
                 <a:cs typeface="Times New Roman" pitchFamily="34" charset="-120"/>
               </a:rPr>
-              <a:t>Crossing the line going west, we ______ one day.</a:t>
+              <a:t>Yes. It cuts the Earth into two equal halves.</a:t>
             </a:r>
             <a:endParaRPr lang="en-US" sz="4000" dirty="0"/>
           </a:p>
@@ -14902,7 +15889,7 @@
                 <a:ea typeface="Calibri" pitchFamily="34" charset="-122"/>
                 <a:cs typeface="Calibri" pitchFamily="34" charset="-120"/>
               </a:rPr>
-              <a:t>HOMEWORK</a:t>
+              <a:t>FORMATIVE EVALUATION</a:t>
             </a:r>
             <a:endParaRPr lang="en-US" sz="1400" dirty="0"/>
           </a:p>
@@ -14967,7 +15954,7 @@
                 <a:ea typeface="Times New Roman" pitchFamily="34" charset="-122"/>
                 <a:cs typeface="Times New Roman" pitchFamily="34" charset="-120"/>
               </a:rPr>
-              <a:t>Homework</a:t>
+              <a:t>Evaluation 2</a:t>
             </a:r>
             <a:endParaRPr lang="en-US" sz="3600" dirty="0"/>
           </a:p>
@@ -15009,7 +15996,7 @@
                 <a:ea typeface="Times New Roman" pitchFamily="34" charset="-122"/>
                 <a:cs typeface="Times New Roman" pitchFamily="34" charset="-120"/>
               </a:rPr>
-              <a:t>Bring an atlas, a ruler and a pencil to the next lesson. Find the map of Cameroon in your atlas.</a:t>
+              <a:t>What happens to the date when we cross the Date Line going west?</a:t>
             </a:r>
             <a:endParaRPr lang="en-US" sz="4000" dirty="0"/>
           </a:p>
@@ -15121,7 +16108,7 @@
                 <a:ea typeface="Calibri" pitchFamily="34" charset="-122"/>
                 <a:cs typeface="Calibri" pitchFamily="34" charset="-120"/>
               </a:rPr>
-              <a:t>NEXT LESSON</a:t>
+              <a:t>FORMATIVE EVALUATION</a:t>
             </a:r>
             <a:endParaRPr lang="en-US" sz="1400" dirty="0"/>
           </a:p>
@@ -15186,7 +16173,7 @@
                 <a:ea typeface="Times New Roman" pitchFamily="34" charset="-122"/>
                 <a:cs typeface="Times New Roman" pitchFamily="34" charset="-120"/>
               </a:rPr>
-              <a:t>Next Lesson</a:t>
+              <a:t>Expected Answer</a:t>
             </a:r>
             <a:endParaRPr lang="en-US" sz="3600" dirty="0"/>
           </a:p>
@@ -15210,17 +16197,17 @@
           <a:ln/>
         </p:spPr>
         <p:txBody>
-          <a:bodyPr wrap="square" lIns="0" tIns="0" rIns="0" bIns="0" rtlCol="0" anchor="ctr"/>
-          <a:lstStyle/>
-          <a:p>
-            <a:pPr algn="ctr" indent="0" marL="0">
+          <a:bodyPr wrap="square" lIns="0" tIns="0" rIns="0" bIns="0" rtlCol="0" anchor="t"/>
+          <a:lstStyle/>
+          <a:p>
+            <a:pPr algn="l" indent="0" marL="0">
               <a:spcAft>
                 <a:spcPts val="800"/>
               </a:spcAft>
               <a:buNone/>
             </a:pPr>
             <a:r>
-              <a:rPr lang="en-US" sz="4000" b="1" dirty="0">
+              <a:rPr lang="en-US" sz="4000" dirty="0">
                 <a:solidFill>
                   <a:srgbClr val="111111"/>
                 </a:solidFill>
@@ -15228,27 +16215,7 @@
                 <a:ea typeface="Times New Roman" pitchFamily="34" charset="-122"/>
                 <a:cs typeface="Times New Roman" pitchFamily="34" charset="-120"/>
               </a:rPr>
-              <a:t>Our next lesson will be on:</a:t>
-            </a:r>
-            <a:endParaRPr lang="en-US" sz="4000" dirty="0"/>
-          </a:p>
-          <a:p>
-            <a:pPr algn="ctr" indent="0" marL="0">
-              <a:spcAft>
-                <a:spcPts val="800"/>
-              </a:spcAft>
-              <a:buNone/>
-            </a:pPr>
-            <a:r>
-              <a:rPr lang="en-US" sz="4000" b="1" dirty="0">
-                <a:solidFill>
-                  <a:srgbClr val="990011"/>
-                </a:solidFill>
-                <a:latin typeface="Times New Roman" pitchFamily="34" charset="0"/>
-                <a:ea typeface="Times New Roman" pitchFamily="34" charset="-122"/>
-                <a:cs typeface="Times New Roman" pitchFamily="34" charset="-120"/>
-              </a:rPr>
-              <a:t>Practical Work 1: Locate a Place on a Map</a:t>
+              <a:t>We add one day.</a:t>
             </a:r>
             <a:endParaRPr lang="en-US" sz="4000" dirty="0"/>
           </a:p>
@@ -15360,6 +16327,948 @@
                 <a:ea typeface="Calibri" pitchFamily="34" charset="-122"/>
                 <a:cs typeface="Calibri" pitchFamily="34" charset="-120"/>
               </a:rPr>
+              <a:t>REMEDIATION</a:t>
+            </a:r>
+            <a:endParaRPr lang="en-US" sz="1400" dirty="0"/>
+          </a:p>
+        </p:txBody>
+      </p:sp>
+      <p:pic>
+        <p:nvPicPr>
+          <p:cNvPr id="3" name="Image 0" descr="/home/claude/f4/img/minesec_sheet.png">    </p:cNvPr>
+          <p:cNvPicPr>
+            <a:picLocks noChangeAspect="1"/>
+          </p:cNvPicPr>
+          <p:nvPr/>
+        </p:nvPicPr>
+        <p:blipFill>
+          <a:blip r:embed="rId1"/>
+          <a:stretch>
+            <a:fillRect/>
+          </a:stretch>
+        </p:blipFill>
+        <p:spPr>
+          <a:xfrm>
+            <a:off x="0" y="658368"/>
+            <a:ext cx="5120640" cy="5833872"/>
+          </a:xfrm>
+          <a:prstGeom prst="rect">
+            <a:avLst/>
+          </a:prstGeom>
+        </p:spPr>
+      </p:pic>
+      <p:sp>
+        <p:nvSpPr>
+          <p:cNvPr id="4" name="Text 1"/>
+          <p:cNvSpPr/>
+          <p:nvPr/>
+        </p:nvSpPr>
+        <p:spPr>
+          <a:xfrm>
+            <a:off x="5349240" y="1005840"/>
+            <a:ext cx="6522415" cy="731520"/>
+          </a:xfrm>
+          <a:prstGeom prst="rect">
+            <a:avLst/>
+          </a:prstGeom>
+          <a:noFill/>
+          <a:ln/>
+        </p:spPr>
+        <p:txBody>
+          <a:bodyPr wrap="square" lIns="0" tIns="0" rIns="0" bIns="0" rtlCol="0" anchor="ctr">
+            <a:normAutofit/>
+          </a:bodyPr>
+          <a:lstStyle/>
+          <a:p>
+            <a:pPr algn="ctr" indent="0" marL="0">
+              <a:buNone/>
+            </a:pPr>
+            <a:r>
+              <a:rPr lang="en-US" sz="3600" b="1" dirty="0">
+                <a:solidFill>
+                  <a:srgbClr val="990011"/>
+                </a:solidFill>
+                <a:latin typeface="Times New Roman" pitchFamily="34" charset="0"/>
+                <a:ea typeface="Times New Roman" pitchFamily="34" charset="-122"/>
+                <a:cs typeface="Times New Roman" pitchFamily="34" charset="-120"/>
+              </a:rPr>
+              <a:t>Remediation</a:t>
+            </a:r>
+            <a:endParaRPr lang="en-US" sz="3600" dirty="0"/>
+          </a:p>
+        </p:txBody>
+      </p:sp>
+      <p:sp>
+        <p:nvSpPr>
+          <p:cNvPr id="5" name="Text 2"/>
+          <p:cNvSpPr/>
+          <p:nvPr/>
+        </p:nvSpPr>
+        <p:spPr>
+          <a:xfrm>
+            <a:off x="5349240" y="1783080"/>
+            <a:ext cx="6522415" cy="4663440"/>
+          </a:xfrm>
+          <a:prstGeom prst="rect">
+            <a:avLst/>
+          </a:prstGeom>
+          <a:noFill/>
+          <a:ln/>
+        </p:spPr>
+        <p:txBody>
+          <a:bodyPr wrap="square" lIns="0" tIns="0" rIns="0" bIns="0" rtlCol="0" anchor="t"/>
+          <a:lstStyle/>
+          <a:p>
+            <a:pPr algn="l" indent="0" marL="0">
+              <a:spcAft>
+                <a:spcPts val="800"/>
+              </a:spcAft>
+              <a:buNone/>
+            </a:pPr>
+            <a:r>
+              <a:rPr lang="en-US" sz="4000" b="1" dirty="0">
+                <a:solidFill>
+                  <a:srgbClr val="111111"/>
+                </a:solidFill>
+                <a:latin typeface="Times New Roman" pitchFamily="34" charset="0"/>
+                <a:ea typeface="Times New Roman" pitchFamily="34" charset="-122"/>
+                <a:cs typeface="Times New Roman" pitchFamily="34" charset="-120"/>
+              </a:rPr>
+              <a:t>Fill in the blanks:</a:t>
+            </a:r>
+            <a:endParaRPr lang="en-US" sz="4000" dirty="0"/>
+          </a:p>
+          <a:p>
+            <a:pPr algn="l" marL="342900" indent="-342900">
+              <a:spcAft>
+                <a:spcPts val="800"/>
+              </a:spcAft>
+              <a:buSzPct val="100000"/>
+              <a:buFont typeface="+mj-lt"/>
+              <a:buAutoNum type="arabicPeriod" startAt="1"/>
+            </a:pPr>
+            <a:r>
+              <a:rPr lang="en-US" sz="4000" dirty="0">
+                <a:solidFill>
+                  <a:srgbClr val="111111"/>
+                </a:solidFill>
+                <a:latin typeface="Times New Roman" pitchFamily="34" charset="0"/>
+                <a:ea typeface="Times New Roman" pitchFamily="34" charset="-122"/>
+                <a:cs typeface="Times New Roman" pitchFamily="34" charset="-120"/>
+              </a:rPr>
+              <a:t>A circle that cuts the Earth into two equal halves is a ______ circle.</a:t>
+            </a:r>
+            <a:endParaRPr lang="en-US" sz="4000" dirty="0"/>
+          </a:p>
+          <a:p>
+            <a:pPr algn="l" marL="342900" indent="-342900">
+              <a:spcAft>
+                <a:spcPts val="800"/>
+              </a:spcAft>
+              <a:buSzPct val="100000"/>
+              <a:buFont typeface="+mj-lt"/>
+              <a:buAutoNum type="arabicPeriod" startAt="1"/>
+            </a:pPr>
+            <a:r>
+              <a:rPr lang="en-US" sz="4000" dirty="0">
+                <a:solidFill>
+                  <a:srgbClr val="111111"/>
+                </a:solidFill>
+                <a:latin typeface="Times New Roman" pitchFamily="34" charset="0"/>
+                <a:ea typeface="Times New Roman" pitchFamily="34" charset="-122"/>
+                <a:cs typeface="Times New Roman" pitchFamily="34" charset="-120"/>
+              </a:rPr>
+              <a:t>The International Date Line follows the ______ degree line.</a:t>
+            </a:r>
+            <a:endParaRPr lang="en-US" sz="4000" dirty="0"/>
+          </a:p>
+        </p:txBody>
+      </p:sp>
+      <p:sp>
+        <p:nvSpPr>
+          <p:cNvPr id="25" name="Slide Number Placeholder 0"/>
+          <p:cNvSpPr>
+            <a:spLocks noGrp="1"/>
+          </p:cNvSpPr>
+          <p:nvPr>
+            <p:ph type="sldNum" sz="quarter" idx="4294967295"/>
+          </p:nvPr>
+        </p:nvSpPr>
+        <p:spPr>
+          <a:xfrm>
+            <a:off x="27432" y="91440"/>
+            <a:ext cx="585216" cy="475488"/>
+          </a:xfrm>
+          <a:prstGeom prst="rect">
+            <a:avLst/>
+          </a:prstGeom>
+          <a:extLst>
+            <a:ext uri="{C572A759-6A51-4108-AA02-DFA0A04FC94B}">
+              <ma14:wrappingTextBoxFlag xmlns:ma14="http://schemas.microsoft.com/office/mac/drawingml/2011/main" val="0"/>
+            </a:ext>
+          </a:extLst>
+        </p:spPr>
+        <p:txBody>
+          <a:bodyPr/>
+          <a:lstStyle>
+            <a:lvl1pPr>
+              <a:defRPr sz="2000">
+                <a:solidFill>
+                  <a:srgbClr val="FFFFFF"/>
+                </a:solidFill>
+                <a:latin typeface="Calibri"/>
+                <a:ea typeface="Calibri"/>
+                <a:cs typeface="Calibri"/>
+              </a:defRPr>
+            </a:lvl1pPr>
+          </a:lstStyle>
+          <a:p>
+            <a:pPr algn="ctr"/>
+            <a:fld id="{F7021451-1387-4CA6-816F-3879F97B5CBC}" type="slidenum">
+              <a:rPr b="1" lang="en-US"/>
+              <a:t>43</a:t>
+            </a:fld>
+            <a:endParaRPr lang="en-US"/>
+          </a:p>
+        </p:txBody>
+      </p:sp>
+    </p:spTree>
+  </p:cSld>
+  <p:clrMapOvr>
+    <a:masterClrMapping/>
+  </p:clrMapOvr>
+</p:sld>
+</file>
+
+<file path=ppt/slides/slide44.xml><?xml version="1.0" encoding="utf-8"?>
+<p:sld xmlns:a="http://schemas.openxmlformats.org/drawingml/2006/main" xmlns:r="http://schemas.openxmlformats.org/officeDocument/2006/relationships" xmlns:p="http://schemas.openxmlformats.org/presentationml/2006/main">
+  <p:cSld name="Slide 44">
+    <p:spTree>
+      <p:nvGrpSpPr>
+        <p:cNvPr id="1" name=""/>
+        <p:cNvGrpSpPr/>
+        <p:nvPr/>
+      </p:nvGrpSpPr>
+      <p:grpSpPr>
+        <a:xfrm>
+          <a:off x="0" y="0"/>
+          <a:ext cx="0" cy="0"/>
+          <a:chOff x="0" y="0"/>
+          <a:chExt cx="0" cy="0"/>
+        </a:xfrm>
+      </p:grpSpPr>
+      <p:sp>
+        <p:nvSpPr>
+          <p:cNvPr id="2" name="Text 0"/>
+          <p:cNvSpPr/>
+          <p:nvPr/>
+        </p:nvSpPr>
+        <p:spPr>
+          <a:xfrm>
+            <a:off x="457200" y="713232"/>
+            <a:ext cx="11368735" cy="274320"/>
+          </a:xfrm>
+          <a:prstGeom prst="rect">
+            <a:avLst/>
+          </a:prstGeom>
+          <a:noFill/>
+          <a:ln/>
+        </p:spPr>
+        <p:txBody>
+          <a:bodyPr wrap="square" lIns="0" tIns="0" rIns="0" bIns="0" rtlCol="0" anchor="ctr"/>
+          <a:lstStyle/>
+          <a:p>
+            <a:pPr algn="r" indent="0" marL="0">
+              <a:buNone/>
+            </a:pPr>
+            <a:r>
+              <a:rPr lang="en-US" sz="1400" b="1" dirty="0">
+                <a:solidFill>
+                  <a:srgbClr val="1C3F6E"/>
+                </a:solidFill>
+                <a:latin typeface="Calibri" pitchFamily="34" charset="0"/>
+                <a:ea typeface="Calibri" pitchFamily="34" charset="-122"/>
+                <a:cs typeface="Calibri" pitchFamily="34" charset="-120"/>
+              </a:rPr>
+              <a:t>REMEDIATION</a:t>
+            </a:r>
+            <a:endParaRPr lang="en-US" sz="1400" dirty="0"/>
+          </a:p>
+        </p:txBody>
+      </p:sp>
+      <p:pic>
+        <p:nvPicPr>
+          <p:cNvPr id="3" name="Image 0" descr="/home/claude/f4/img/minesec_sheet.png">    </p:cNvPr>
+          <p:cNvPicPr>
+            <a:picLocks noChangeAspect="1"/>
+          </p:cNvPicPr>
+          <p:nvPr/>
+        </p:nvPicPr>
+        <p:blipFill>
+          <a:blip r:embed="rId1"/>
+          <a:stretch>
+            <a:fillRect/>
+          </a:stretch>
+        </p:blipFill>
+        <p:spPr>
+          <a:xfrm>
+            <a:off x="0" y="658368"/>
+            <a:ext cx="5120640" cy="5833872"/>
+          </a:xfrm>
+          <a:prstGeom prst="rect">
+            <a:avLst/>
+          </a:prstGeom>
+        </p:spPr>
+      </p:pic>
+      <p:sp>
+        <p:nvSpPr>
+          <p:cNvPr id="4" name="Text 1"/>
+          <p:cNvSpPr/>
+          <p:nvPr/>
+        </p:nvSpPr>
+        <p:spPr>
+          <a:xfrm>
+            <a:off x="5349240" y="1005840"/>
+            <a:ext cx="6522415" cy="731520"/>
+          </a:xfrm>
+          <a:prstGeom prst="rect">
+            <a:avLst/>
+          </a:prstGeom>
+          <a:noFill/>
+          <a:ln/>
+        </p:spPr>
+        <p:txBody>
+          <a:bodyPr wrap="square" lIns="0" tIns="0" rIns="0" bIns="0" rtlCol="0" anchor="ctr">
+            <a:normAutofit/>
+          </a:bodyPr>
+          <a:lstStyle/>
+          <a:p>
+            <a:pPr algn="ctr" indent="0" marL="0">
+              <a:buNone/>
+            </a:pPr>
+            <a:r>
+              <a:rPr lang="en-US" sz="3600" b="1" dirty="0">
+                <a:solidFill>
+                  <a:srgbClr val="990011"/>
+                </a:solidFill>
+                <a:latin typeface="Times New Roman" pitchFamily="34" charset="0"/>
+                <a:ea typeface="Times New Roman" pitchFamily="34" charset="-122"/>
+                <a:cs typeface="Times New Roman" pitchFamily="34" charset="-120"/>
+              </a:rPr>
+              <a:t>Remediation (continued)</a:t>
+            </a:r>
+            <a:endParaRPr lang="en-US" sz="3600" dirty="0"/>
+          </a:p>
+        </p:txBody>
+      </p:sp>
+      <p:sp>
+        <p:nvSpPr>
+          <p:cNvPr id="5" name="Text 2"/>
+          <p:cNvSpPr/>
+          <p:nvPr/>
+        </p:nvSpPr>
+        <p:spPr>
+          <a:xfrm>
+            <a:off x="5349240" y="1783080"/>
+            <a:ext cx="6522415" cy="4663440"/>
+          </a:xfrm>
+          <a:prstGeom prst="rect">
+            <a:avLst/>
+          </a:prstGeom>
+          <a:noFill/>
+          <a:ln/>
+        </p:spPr>
+        <p:txBody>
+          <a:bodyPr wrap="square" lIns="0" tIns="0" rIns="0" bIns="0" rtlCol="0" anchor="t"/>
+          <a:lstStyle/>
+          <a:p>
+            <a:pPr algn="l" marL="342900" indent="-342900">
+              <a:spcAft>
+                <a:spcPts val="800"/>
+              </a:spcAft>
+              <a:buSzPct val="100000"/>
+              <a:buFont typeface="+mj-lt"/>
+              <a:buAutoNum type="arabicPeriod" startAt="1"/>
+            </a:pPr>
+            <a:r>
+              <a:rPr lang="en-US" sz="4000" dirty="0">
+                <a:solidFill>
+                  <a:srgbClr val="111111"/>
+                </a:solidFill>
+                <a:latin typeface="Times New Roman" pitchFamily="34" charset="0"/>
+                <a:ea typeface="Times New Roman" pitchFamily="34" charset="-122"/>
+                <a:cs typeface="Times New Roman" pitchFamily="34" charset="-120"/>
+              </a:rPr>
+              <a:t>Crossing the line going west, we ______ one day.</a:t>
+            </a:r>
+            <a:endParaRPr lang="en-US" sz="4000" dirty="0"/>
+          </a:p>
+        </p:txBody>
+      </p:sp>
+      <p:sp>
+        <p:nvSpPr>
+          <p:cNvPr id="25" name="Slide Number Placeholder 0"/>
+          <p:cNvSpPr>
+            <a:spLocks noGrp="1"/>
+          </p:cNvSpPr>
+          <p:nvPr>
+            <p:ph type="sldNum" sz="quarter" idx="4294967295"/>
+          </p:nvPr>
+        </p:nvSpPr>
+        <p:spPr>
+          <a:xfrm>
+            <a:off x="27432" y="91440"/>
+            <a:ext cx="585216" cy="475488"/>
+          </a:xfrm>
+          <a:prstGeom prst="rect">
+            <a:avLst/>
+          </a:prstGeom>
+          <a:extLst>
+            <a:ext uri="{C572A759-6A51-4108-AA02-DFA0A04FC94B}">
+              <ma14:wrappingTextBoxFlag xmlns:ma14="http://schemas.microsoft.com/office/mac/drawingml/2011/main" val="0"/>
+            </a:ext>
+          </a:extLst>
+        </p:spPr>
+        <p:txBody>
+          <a:bodyPr/>
+          <a:lstStyle>
+            <a:lvl1pPr>
+              <a:defRPr sz="2000">
+                <a:solidFill>
+                  <a:srgbClr val="FFFFFF"/>
+                </a:solidFill>
+                <a:latin typeface="Calibri"/>
+                <a:ea typeface="Calibri"/>
+                <a:cs typeface="Calibri"/>
+              </a:defRPr>
+            </a:lvl1pPr>
+          </a:lstStyle>
+          <a:p>
+            <a:pPr algn="ctr"/>
+            <a:fld id="{F7021451-1387-4CA6-816F-3879F97B5CBC}" type="slidenum">
+              <a:rPr b="1" lang="en-US"/>
+              <a:t>44</a:t>
+            </a:fld>
+            <a:endParaRPr lang="en-US"/>
+          </a:p>
+        </p:txBody>
+      </p:sp>
+    </p:spTree>
+  </p:cSld>
+  <p:clrMapOvr>
+    <a:masterClrMapping/>
+  </p:clrMapOvr>
+</p:sld>
+</file>
+
+<file path=ppt/slides/slide45.xml><?xml version="1.0" encoding="utf-8"?>
+<p:sld xmlns:a="http://schemas.openxmlformats.org/drawingml/2006/main" xmlns:r="http://schemas.openxmlformats.org/officeDocument/2006/relationships" xmlns:p="http://schemas.openxmlformats.org/presentationml/2006/main">
+  <p:cSld name="Slide 45">
+    <p:spTree>
+      <p:nvGrpSpPr>
+        <p:cNvPr id="1" name=""/>
+        <p:cNvGrpSpPr/>
+        <p:nvPr/>
+      </p:nvGrpSpPr>
+      <p:grpSpPr>
+        <a:xfrm>
+          <a:off x="0" y="0"/>
+          <a:ext cx="0" cy="0"/>
+          <a:chOff x="0" y="0"/>
+          <a:chExt cx="0" cy="0"/>
+        </a:xfrm>
+      </p:grpSpPr>
+      <p:sp>
+        <p:nvSpPr>
+          <p:cNvPr id="2" name="Text 0"/>
+          <p:cNvSpPr/>
+          <p:nvPr/>
+        </p:nvSpPr>
+        <p:spPr>
+          <a:xfrm>
+            <a:off x="457200" y="713232"/>
+            <a:ext cx="11368735" cy="274320"/>
+          </a:xfrm>
+          <a:prstGeom prst="rect">
+            <a:avLst/>
+          </a:prstGeom>
+          <a:noFill/>
+          <a:ln/>
+        </p:spPr>
+        <p:txBody>
+          <a:bodyPr wrap="square" lIns="0" tIns="0" rIns="0" bIns="0" rtlCol="0" anchor="ctr"/>
+          <a:lstStyle/>
+          <a:p>
+            <a:pPr algn="r" indent="0" marL="0">
+              <a:buNone/>
+            </a:pPr>
+            <a:r>
+              <a:rPr lang="en-US" sz="1400" b="1" dirty="0">
+                <a:solidFill>
+                  <a:srgbClr val="1C3F6E"/>
+                </a:solidFill>
+                <a:latin typeface="Calibri" pitchFamily="34" charset="0"/>
+                <a:ea typeface="Calibri" pitchFamily="34" charset="-122"/>
+                <a:cs typeface="Calibri" pitchFamily="34" charset="-120"/>
+              </a:rPr>
+              <a:t>HOMEWORK</a:t>
+            </a:r>
+            <a:endParaRPr lang="en-US" sz="1400" dirty="0"/>
+          </a:p>
+        </p:txBody>
+      </p:sp>
+      <p:pic>
+        <p:nvPicPr>
+          <p:cNvPr id="3" name="Image 0" descr="/home/claude/f4/img/minesec_sheet.png">    </p:cNvPr>
+          <p:cNvPicPr>
+            <a:picLocks noChangeAspect="1"/>
+          </p:cNvPicPr>
+          <p:nvPr/>
+        </p:nvPicPr>
+        <p:blipFill>
+          <a:blip r:embed="rId1"/>
+          <a:stretch>
+            <a:fillRect/>
+          </a:stretch>
+        </p:blipFill>
+        <p:spPr>
+          <a:xfrm>
+            <a:off x="0" y="658368"/>
+            <a:ext cx="5120640" cy="5833872"/>
+          </a:xfrm>
+          <a:prstGeom prst="rect">
+            <a:avLst/>
+          </a:prstGeom>
+        </p:spPr>
+      </p:pic>
+      <p:sp>
+        <p:nvSpPr>
+          <p:cNvPr id="4" name="Text 1"/>
+          <p:cNvSpPr/>
+          <p:nvPr/>
+        </p:nvSpPr>
+        <p:spPr>
+          <a:xfrm>
+            <a:off x="5349240" y="1005840"/>
+            <a:ext cx="6522415" cy="731520"/>
+          </a:xfrm>
+          <a:prstGeom prst="rect">
+            <a:avLst/>
+          </a:prstGeom>
+          <a:noFill/>
+          <a:ln/>
+        </p:spPr>
+        <p:txBody>
+          <a:bodyPr wrap="square" lIns="0" tIns="0" rIns="0" bIns="0" rtlCol="0" anchor="ctr">
+            <a:normAutofit/>
+          </a:bodyPr>
+          <a:lstStyle/>
+          <a:p>
+            <a:pPr algn="ctr" indent="0" marL="0">
+              <a:buNone/>
+            </a:pPr>
+            <a:r>
+              <a:rPr lang="en-US" sz="3600" b="1" dirty="0">
+                <a:solidFill>
+                  <a:srgbClr val="990011"/>
+                </a:solidFill>
+                <a:latin typeface="Times New Roman" pitchFamily="34" charset="0"/>
+                <a:ea typeface="Times New Roman" pitchFamily="34" charset="-122"/>
+                <a:cs typeface="Times New Roman" pitchFamily="34" charset="-120"/>
+              </a:rPr>
+              <a:t>Homework</a:t>
+            </a:r>
+            <a:endParaRPr lang="en-US" sz="3600" dirty="0"/>
+          </a:p>
+        </p:txBody>
+      </p:sp>
+      <p:sp>
+        <p:nvSpPr>
+          <p:cNvPr id="5" name="Text 2"/>
+          <p:cNvSpPr/>
+          <p:nvPr/>
+        </p:nvSpPr>
+        <p:spPr>
+          <a:xfrm>
+            <a:off x="5349240" y="1783080"/>
+            <a:ext cx="6522415" cy="4663440"/>
+          </a:xfrm>
+          <a:prstGeom prst="rect">
+            <a:avLst/>
+          </a:prstGeom>
+          <a:noFill/>
+          <a:ln/>
+        </p:spPr>
+        <p:txBody>
+          <a:bodyPr wrap="square" lIns="0" tIns="0" rIns="0" bIns="0" rtlCol="0" anchor="t"/>
+          <a:lstStyle/>
+          <a:p>
+            <a:pPr algn="l" indent="0" marL="0">
+              <a:spcAft>
+                <a:spcPts val="800"/>
+              </a:spcAft>
+              <a:buNone/>
+            </a:pPr>
+            <a:r>
+              <a:rPr lang="en-US" sz="4000" dirty="0">
+                <a:solidFill>
+                  <a:srgbClr val="111111"/>
+                </a:solidFill>
+                <a:latin typeface="Times New Roman" pitchFamily="34" charset="0"/>
+                <a:ea typeface="Times New Roman" pitchFamily="34" charset="-122"/>
+                <a:cs typeface="Times New Roman" pitchFamily="34" charset="-120"/>
+              </a:rPr>
+              <a:t>Bring an atlas, a ruler and a pencil to the next lesson. Find the map of Cameroon in your atlas.</a:t>
+            </a:r>
+            <a:endParaRPr lang="en-US" sz="4000" dirty="0"/>
+          </a:p>
+        </p:txBody>
+      </p:sp>
+      <p:sp>
+        <p:nvSpPr>
+          <p:cNvPr id="25" name="Slide Number Placeholder 0"/>
+          <p:cNvSpPr>
+            <a:spLocks noGrp="1"/>
+          </p:cNvSpPr>
+          <p:nvPr>
+            <p:ph type="sldNum" sz="quarter" idx="4294967295"/>
+          </p:nvPr>
+        </p:nvSpPr>
+        <p:spPr>
+          <a:xfrm>
+            <a:off x="27432" y="91440"/>
+            <a:ext cx="585216" cy="475488"/>
+          </a:xfrm>
+          <a:prstGeom prst="rect">
+            <a:avLst/>
+          </a:prstGeom>
+          <a:extLst>
+            <a:ext uri="{C572A759-6A51-4108-AA02-DFA0A04FC94B}">
+              <ma14:wrappingTextBoxFlag xmlns:ma14="http://schemas.microsoft.com/office/mac/drawingml/2011/main" val="0"/>
+            </a:ext>
+          </a:extLst>
+        </p:spPr>
+        <p:txBody>
+          <a:bodyPr/>
+          <a:lstStyle>
+            <a:lvl1pPr>
+              <a:defRPr sz="2000">
+                <a:solidFill>
+                  <a:srgbClr val="FFFFFF"/>
+                </a:solidFill>
+                <a:latin typeface="Calibri"/>
+                <a:ea typeface="Calibri"/>
+                <a:cs typeface="Calibri"/>
+              </a:defRPr>
+            </a:lvl1pPr>
+          </a:lstStyle>
+          <a:p>
+            <a:pPr algn="ctr"/>
+            <a:fld id="{F7021451-1387-4CA6-816F-3879F97B5CBC}" type="slidenum">
+              <a:rPr b="1" lang="en-US"/>
+              <a:t>45</a:t>
+            </a:fld>
+            <a:endParaRPr lang="en-US"/>
+          </a:p>
+        </p:txBody>
+      </p:sp>
+    </p:spTree>
+  </p:cSld>
+  <p:clrMapOvr>
+    <a:masterClrMapping/>
+  </p:clrMapOvr>
+</p:sld>
+</file>
+
+<file path=ppt/slides/slide46.xml><?xml version="1.0" encoding="utf-8"?>
+<p:sld xmlns:a="http://schemas.openxmlformats.org/drawingml/2006/main" xmlns:r="http://schemas.openxmlformats.org/officeDocument/2006/relationships" xmlns:p="http://schemas.openxmlformats.org/presentationml/2006/main">
+  <p:cSld name="Slide 46">
+    <p:spTree>
+      <p:nvGrpSpPr>
+        <p:cNvPr id="1" name=""/>
+        <p:cNvGrpSpPr/>
+        <p:nvPr/>
+      </p:nvGrpSpPr>
+      <p:grpSpPr>
+        <a:xfrm>
+          <a:off x="0" y="0"/>
+          <a:ext cx="0" cy="0"/>
+          <a:chOff x="0" y="0"/>
+          <a:chExt cx="0" cy="0"/>
+        </a:xfrm>
+      </p:grpSpPr>
+      <p:sp>
+        <p:nvSpPr>
+          <p:cNvPr id="2" name="Text 0"/>
+          <p:cNvSpPr/>
+          <p:nvPr/>
+        </p:nvSpPr>
+        <p:spPr>
+          <a:xfrm>
+            <a:off x="457200" y="713232"/>
+            <a:ext cx="11368735" cy="274320"/>
+          </a:xfrm>
+          <a:prstGeom prst="rect">
+            <a:avLst/>
+          </a:prstGeom>
+          <a:noFill/>
+          <a:ln/>
+        </p:spPr>
+        <p:txBody>
+          <a:bodyPr wrap="square" lIns="0" tIns="0" rIns="0" bIns="0" rtlCol="0" anchor="ctr"/>
+          <a:lstStyle/>
+          <a:p>
+            <a:pPr algn="r" indent="0" marL="0">
+              <a:buNone/>
+            </a:pPr>
+            <a:r>
+              <a:rPr lang="en-US" sz="1400" b="1" dirty="0">
+                <a:solidFill>
+                  <a:srgbClr val="1C3F6E"/>
+                </a:solidFill>
+                <a:latin typeface="Calibri" pitchFamily="34" charset="0"/>
+                <a:ea typeface="Calibri" pitchFamily="34" charset="-122"/>
+                <a:cs typeface="Calibri" pitchFamily="34" charset="-120"/>
+              </a:rPr>
+              <a:t>NEXT LESSON</a:t>
+            </a:r>
+            <a:endParaRPr lang="en-US" sz="1400" dirty="0"/>
+          </a:p>
+        </p:txBody>
+      </p:sp>
+      <p:pic>
+        <p:nvPicPr>
+          <p:cNvPr id="3" name="Image 0" descr="/home/claude/f4/img/minesec_sheet.png">    </p:cNvPr>
+          <p:cNvPicPr>
+            <a:picLocks noChangeAspect="1"/>
+          </p:cNvPicPr>
+          <p:nvPr/>
+        </p:nvPicPr>
+        <p:blipFill>
+          <a:blip r:embed="rId1"/>
+          <a:stretch>
+            <a:fillRect/>
+          </a:stretch>
+        </p:blipFill>
+        <p:spPr>
+          <a:xfrm>
+            <a:off x="0" y="658368"/>
+            <a:ext cx="5120640" cy="5833872"/>
+          </a:xfrm>
+          <a:prstGeom prst="rect">
+            <a:avLst/>
+          </a:prstGeom>
+        </p:spPr>
+      </p:pic>
+      <p:sp>
+        <p:nvSpPr>
+          <p:cNvPr id="4" name="Text 1"/>
+          <p:cNvSpPr/>
+          <p:nvPr/>
+        </p:nvSpPr>
+        <p:spPr>
+          <a:xfrm>
+            <a:off x="5349240" y="1005840"/>
+            <a:ext cx="6522415" cy="731520"/>
+          </a:xfrm>
+          <a:prstGeom prst="rect">
+            <a:avLst/>
+          </a:prstGeom>
+          <a:noFill/>
+          <a:ln/>
+        </p:spPr>
+        <p:txBody>
+          <a:bodyPr wrap="square" lIns="0" tIns="0" rIns="0" bIns="0" rtlCol="0" anchor="ctr">
+            <a:normAutofit/>
+          </a:bodyPr>
+          <a:lstStyle/>
+          <a:p>
+            <a:pPr algn="ctr" indent="0" marL="0">
+              <a:buNone/>
+            </a:pPr>
+            <a:r>
+              <a:rPr lang="en-US" sz="3600" b="1" dirty="0">
+                <a:solidFill>
+                  <a:srgbClr val="990011"/>
+                </a:solidFill>
+                <a:latin typeface="Times New Roman" pitchFamily="34" charset="0"/>
+                <a:ea typeface="Times New Roman" pitchFamily="34" charset="-122"/>
+                <a:cs typeface="Times New Roman" pitchFamily="34" charset="-120"/>
+              </a:rPr>
+              <a:t>Next Lesson</a:t>
+            </a:r>
+            <a:endParaRPr lang="en-US" sz="3600" dirty="0"/>
+          </a:p>
+        </p:txBody>
+      </p:sp>
+      <p:sp>
+        <p:nvSpPr>
+          <p:cNvPr id="5" name="Text 2"/>
+          <p:cNvSpPr/>
+          <p:nvPr/>
+        </p:nvSpPr>
+        <p:spPr>
+          <a:xfrm>
+            <a:off x="5349240" y="1783080"/>
+            <a:ext cx="6522415" cy="4663440"/>
+          </a:xfrm>
+          <a:prstGeom prst="rect">
+            <a:avLst/>
+          </a:prstGeom>
+          <a:noFill/>
+          <a:ln/>
+        </p:spPr>
+        <p:txBody>
+          <a:bodyPr wrap="square" lIns="0" tIns="0" rIns="0" bIns="0" rtlCol="0" anchor="ctr"/>
+          <a:lstStyle/>
+          <a:p>
+            <a:pPr algn="ctr" indent="0" marL="0">
+              <a:spcAft>
+                <a:spcPts val="800"/>
+              </a:spcAft>
+              <a:buNone/>
+            </a:pPr>
+            <a:r>
+              <a:rPr lang="en-US" sz="4000" b="1" dirty="0">
+                <a:solidFill>
+                  <a:srgbClr val="111111"/>
+                </a:solidFill>
+                <a:latin typeface="Times New Roman" pitchFamily="34" charset="0"/>
+                <a:ea typeface="Times New Roman" pitchFamily="34" charset="-122"/>
+                <a:cs typeface="Times New Roman" pitchFamily="34" charset="-120"/>
+              </a:rPr>
+              <a:t>Our next lesson will be on:</a:t>
+            </a:r>
+            <a:endParaRPr lang="en-US" sz="4000" dirty="0"/>
+          </a:p>
+          <a:p>
+            <a:pPr algn="ctr" indent="0" marL="0">
+              <a:spcAft>
+                <a:spcPts val="800"/>
+              </a:spcAft>
+              <a:buNone/>
+            </a:pPr>
+            <a:r>
+              <a:rPr lang="en-US" sz="4000" b="1" dirty="0">
+                <a:solidFill>
+                  <a:srgbClr val="990011"/>
+                </a:solidFill>
+                <a:latin typeface="Times New Roman" pitchFamily="34" charset="0"/>
+                <a:ea typeface="Times New Roman" pitchFamily="34" charset="-122"/>
+                <a:cs typeface="Times New Roman" pitchFamily="34" charset="-120"/>
+              </a:rPr>
+              <a:t>Practical Work 1: Locate a Place on a Map</a:t>
+            </a:r>
+            <a:endParaRPr lang="en-US" sz="4000" dirty="0"/>
+          </a:p>
+        </p:txBody>
+      </p:sp>
+      <p:sp>
+        <p:nvSpPr>
+          <p:cNvPr id="25" name="Slide Number Placeholder 0"/>
+          <p:cNvSpPr>
+            <a:spLocks noGrp="1"/>
+          </p:cNvSpPr>
+          <p:nvPr>
+            <p:ph type="sldNum" sz="quarter" idx="4294967295"/>
+          </p:nvPr>
+        </p:nvSpPr>
+        <p:spPr>
+          <a:xfrm>
+            <a:off x="27432" y="91440"/>
+            <a:ext cx="585216" cy="475488"/>
+          </a:xfrm>
+          <a:prstGeom prst="rect">
+            <a:avLst/>
+          </a:prstGeom>
+          <a:extLst>
+            <a:ext uri="{C572A759-6A51-4108-AA02-DFA0A04FC94B}">
+              <ma14:wrappingTextBoxFlag xmlns:ma14="http://schemas.microsoft.com/office/mac/drawingml/2011/main" val="0"/>
+            </a:ext>
+          </a:extLst>
+        </p:spPr>
+        <p:txBody>
+          <a:bodyPr/>
+          <a:lstStyle>
+            <a:lvl1pPr>
+              <a:defRPr sz="2000">
+                <a:solidFill>
+                  <a:srgbClr val="FFFFFF"/>
+                </a:solidFill>
+                <a:latin typeface="Calibri"/>
+                <a:ea typeface="Calibri"/>
+                <a:cs typeface="Calibri"/>
+              </a:defRPr>
+            </a:lvl1pPr>
+          </a:lstStyle>
+          <a:p>
+            <a:pPr algn="ctr"/>
+            <a:fld id="{F7021451-1387-4CA6-816F-3879F97B5CBC}" type="slidenum">
+              <a:rPr b="1" lang="en-US"/>
+              <a:t>46</a:t>
+            </a:fld>
+            <a:endParaRPr lang="en-US"/>
+          </a:p>
+        </p:txBody>
+      </p:sp>
+    </p:spTree>
+  </p:cSld>
+  <p:clrMapOvr>
+    <a:masterClrMapping/>
+  </p:clrMapOvr>
+</p:sld>
+</file>
+
+<file path=ppt/slides/slide47.xml><?xml version="1.0" encoding="utf-8"?>
+<p:sld xmlns:a="http://schemas.openxmlformats.org/drawingml/2006/main" xmlns:r="http://schemas.openxmlformats.org/officeDocument/2006/relationships" xmlns:p="http://schemas.openxmlformats.org/presentationml/2006/main">
+  <p:cSld name="Slide 47">
+    <p:spTree>
+      <p:nvGrpSpPr>
+        <p:cNvPr id="1" name=""/>
+        <p:cNvGrpSpPr/>
+        <p:nvPr/>
+      </p:nvGrpSpPr>
+      <p:grpSpPr>
+        <a:xfrm>
+          <a:off x="0" y="0"/>
+          <a:ext cx="0" cy="0"/>
+          <a:chOff x="0" y="0"/>
+          <a:chExt cx="0" cy="0"/>
+        </a:xfrm>
+      </p:grpSpPr>
+      <p:sp>
+        <p:nvSpPr>
+          <p:cNvPr id="2" name="Text 0"/>
+          <p:cNvSpPr/>
+          <p:nvPr/>
+        </p:nvSpPr>
+        <p:spPr>
+          <a:xfrm>
+            <a:off x="457200" y="713232"/>
+            <a:ext cx="11368735" cy="274320"/>
+          </a:xfrm>
+          <a:prstGeom prst="rect">
+            <a:avLst/>
+          </a:prstGeom>
+          <a:noFill/>
+          <a:ln/>
+        </p:spPr>
+        <p:txBody>
+          <a:bodyPr wrap="square" lIns="0" tIns="0" rIns="0" bIns="0" rtlCol="0" anchor="ctr"/>
+          <a:lstStyle/>
+          <a:p>
+            <a:pPr algn="r" indent="0" marL="0">
+              <a:buNone/>
+            </a:pPr>
+            <a:r>
+              <a:rPr lang="en-US" sz="1400" b="1" dirty="0">
+                <a:solidFill>
+                  <a:srgbClr val="1C3F6E"/>
+                </a:solidFill>
+                <a:latin typeface="Calibri" pitchFamily="34" charset="0"/>
+                <a:ea typeface="Calibri" pitchFamily="34" charset="-122"/>
+                <a:cs typeface="Calibri" pitchFamily="34" charset="-120"/>
+              </a:rPr>
               <a:t>BILINGUAL GAME</a:t>
             </a:r>
             <a:endParaRPr lang="en-US" sz="1400" dirty="0"/>
@@ -15407,7 +17316,7 @@
       </p:sp>
       <p:graphicFrame>
         <p:nvGraphicFramePr>
-          <p:cNvPr id="44" name="Table 0"/>
+          <p:cNvPr id="48" name="Table 0"/>
           <p:cNvGraphicFramePr>
             <a:graphicFrameLocks noGrp="1"/>
           </p:cNvGraphicFramePr>
@@ -16719,7 +18628,7 @@
             <a:pPr algn="ctr"/>
             <a:fld id="{F7021451-1387-4CA6-816F-3879F97B5CBC}" type="slidenum">
               <a:rPr b="1" lang="en-US"/>
-              <a:t>43</a:t>
+              <a:t>47</a:t>
             </a:fld>
             <a:endParaRPr lang="en-US"/>
           </a:p>
@@ -16733,9 +18642,9 @@
 </p:sld>
 </file>
 
-<file path=ppt/slides/slide44.xml><?xml version="1.0" encoding="utf-8"?>
+<file path=ppt/slides/slide48.xml><?xml version="1.0" encoding="utf-8"?>
 <p:sld xmlns:a="http://schemas.openxmlformats.org/drawingml/2006/main" xmlns:r="http://schemas.openxmlformats.org/officeDocument/2006/relationships" xmlns:p="http://schemas.openxmlformats.org/presentationml/2006/main">
-  <p:cSld name="Slide 44">
+  <p:cSld name="Slide 48">
     <p:spTree>
       <p:nvGrpSpPr>
         <p:cNvPr id="1" name=""/>
@@ -16830,7 +18739,7 @@
       </p:sp>
       <p:graphicFrame>
         <p:nvGraphicFramePr>
-          <p:cNvPr id="45" name="Table 0"/>
+          <p:cNvPr id="49" name="Table 0"/>
           <p:cNvGraphicFramePr>
             <a:graphicFrameLocks noGrp="1"/>
           </p:cNvGraphicFramePr>
@@ -17452,7 +19361,7 @@
             <a:pPr algn="ctr"/>
             <a:fld id="{F7021451-1387-4CA6-816F-3879F97B5CBC}" type="slidenum">
               <a:rPr b="1" lang="en-US"/>
-              <a:t>44</a:t>
+              <a:t>48</a:t>
             </a:fld>
             <a:endParaRPr lang="en-US"/>
           </a:p>
@@ -17466,9 +19375,9 @@
 </p:sld>
 </file>
 
-<file path=ppt/slides/slide45.xml><?xml version="1.0" encoding="utf-8"?>
+<file path=ppt/slides/slide49.xml><?xml version="1.0" encoding="utf-8"?>
 <p:sld xmlns:a="http://schemas.openxmlformats.org/drawingml/2006/main" xmlns:r="http://schemas.openxmlformats.org/officeDocument/2006/relationships" xmlns:p="http://schemas.openxmlformats.org/presentationml/2006/main">
-  <p:cSld name="Slide 45">
+  <p:cSld name="Slide 49">
     <p:spTree>
       <p:nvGrpSpPr>
         <p:cNvPr id="1" name=""/>
@@ -17563,7 +19472,7 @@
       </p:sp>
       <p:graphicFrame>
         <p:nvGraphicFramePr>
-          <p:cNvPr id="46" name="Table 0"/>
+          <p:cNvPr id="50" name="Table 0"/>
           <p:cNvGraphicFramePr>
             <a:graphicFrameLocks noGrp="1"/>
           </p:cNvGraphicFramePr>
@@ -17673,7 +19582,7 @@
                           <a:ea typeface="Calibri" pitchFamily="34" charset="-122"/>
                           <a:cs typeface="Calibri" pitchFamily="34" charset="-120"/>
                         </a:rPr>
-                        <a:t>Great Circles; The International Date Line.</a:t>
+                        <a:t>DEFINITIONS; Illustrations; Importance; Illustration.</a:t>
                       </a:r>
                       <a:endParaRPr lang="en-US" sz="1600" dirty="0">
                         <a:latin typeface="Calibri" charset="0"/>
@@ -18323,573 +20232,7 @@
             <a:pPr algn="ctr"/>
             <a:fld id="{F7021451-1387-4CA6-816F-3879F97B5CBC}" type="slidenum">
               <a:rPr b="1" lang="en-US"/>
-              <a:t>45</a:t>
-            </a:fld>
-            <a:endParaRPr lang="en-US"/>
-          </a:p>
-        </p:txBody>
-      </p:sp>
-    </p:spTree>
-  </p:cSld>
-  <p:clrMapOvr>
-    <a:masterClrMapping/>
-  </p:clrMapOvr>
-</p:sld>
-</file>
-
-<file path=ppt/slides/slide46.xml><?xml version="1.0" encoding="utf-8"?>
-<p:sld xmlns:a="http://schemas.openxmlformats.org/drawingml/2006/main" xmlns:r="http://schemas.openxmlformats.org/officeDocument/2006/relationships" xmlns:p="http://schemas.openxmlformats.org/presentationml/2006/main">
-  <p:cSld name="Slide 46">
-    <p:spTree>
-      <p:nvGrpSpPr>
-        <p:cNvPr id="1" name=""/>
-        <p:cNvGrpSpPr/>
-        <p:nvPr/>
-      </p:nvGrpSpPr>
-      <p:grpSpPr>
-        <a:xfrm>
-          <a:off x="0" y="0"/>
-          <a:ext cx="0" cy="0"/>
-          <a:chOff x="0" y="0"/>
-          <a:chExt cx="0" cy="0"/>
-        </a:xfrm>
-      </p:grpSpPr>
-      <p:sp>
-        <p:nvSpPr>
-          <p:cNvPr id="2" name="Text 0"/>
-          <p:cNvSpPr/>
-          <p:nvPr/>
-        </p:nvSpPr>
-        <p:spPr>
-          <a:xfrm>
-            <a:off x="457200" y="713232"/>
-            <a:ext cx="11368735" cy="274320"/>
-          </a:xfrm>
-          <a:prstGeom prst="rect">
-            <a:avLst/>
-          </a:prstGeom>
-          <a:noFill/>
-          <a:ln/>
-        </p:spPr>
-        <p:txBody>
-          <a:bodyPr wrap="square" lIns="0" tIns="0" rIns="0" bIns="0" rtlCol="0" anchor="ctr"/>
-          <a:lstStyle/>
-          <a:p>
-            <a:pPr algn="r" indent="0" marL="0">
-              <a:buNone/>
-            </a:pPr>
-            <a:r>
-              <a:rPr lang="en-US" sz="1400" b="1" dirty="0">
-                <a:solidFill>
-                  <a:srgbClr val="1C3F6E"/>
-                </a:solidFill>
-                <a:latin typeface="Calibri" pitchFamily="34" charset="0"/>
-                <a:ea typeface="Calibri" pitchFamily="34" charset="-122"/>
-                <a:cs typeface="Calibri" pitchFamily="34" charset="-120"/>
-              </a:rPr>
-              <a:t>TEACHER'S NOTE</a:t>
-            </a:r>
-            <a:endParaRPr lang="en-US" sz="1400" dirty="0"/>
-          </a:p>
-        </p:txBody>
-      </p:sp>
-      <p:pic>
-        <p:nvPicPr>
-          <p:cNvPr id="3" name="Image 0" descr="/home/claude/f4/img/minesec_sheet.png">    </p:cNvPr>
-          <p:cNvPicPr>
-            <a:picLocks noChangeAspect="1"/>
-          </p:cNvPicPr>
-          <p:nvPr/>
-        </p:nvPicPr>
-        <p:blipFill>
-          <a:blip r:embed="rId1"/>
-          <a:stretch>
-            <a:fillRect/>
-          </a:stretch>
-        </p:blipFill>
-        <p:spPr>
-          <a:xfrm>
-            <a:off x="0" y="658368"/>
-            <a:ext cx="5120640" cy="5833872"/>
-          </a:xfrm>
-          <a:prstGeom prst="rect">
-            <a:avLst/>
-          </a:prstGeom>
-        </p:spPr>
-      </p:pic>
-      <p:sp>
-        <p:nvSpPr>
-          <p:cNvPr id="4" name="Text 1"/>
-          <p:cNvSpPr/>
-          <p:nvPr/>
-        </p:nvSpPr>
-        <p:spPr>
-          <a:xfrm>
-            <a:off x="5349240" y="1005840"/>
-            <a:ext cx="6522415" cy="731520"/>
-          </a:xfrm>
-          <a:prstGeom prst="rect">
-            <a:avLst/>
-          </a:prstGeom>
-          <a:noFill/>
-          <a:ln/>
-        </p:spPr>
-        <p:txBody>
-          <a:bodyPr wrap="square" lIns="0" tIns="0" rIns="0" bIns="0" rtlCol="0" anchor="ctr">
-            <a:normAutofit/>
-          </a:bodyPr>
-          <a:lstStyle/>
-          <a:p>
-            <a:pPr algn="ctr" indent="0" marL="0">
-              <a:buNone/>
-            </a:pPr>
-            <a:r>
-              <a:rPr lang="en-US" sz="3600" b="1" dirty="0">
-                <a:solidFill>
-                  <a:srgbClr val="990011"/>
-                </a:solidFill>
-                <a:latin typeface="Times New Roman" pitchFamily="34" charset="0"/>
-                <a:ea typeface="Times New Roman" pitchFamily="34" charset="-122"/>
-                <a:cs typeface="Times New Roman" pitchFamily="34" charset="-120"/>
-              </a:rPr>
-              <a:t>Teacher's Note</a:t>
-            </a:r>
-            <a:endParaRPr lang="en-US" sz="3600" dirty="0"/>
-          </a:p>
-        </p:txBody>
-      </p:sp>
-      <p:sp>
-        <p:nvSpPr>
-          <p:cNvPr id="5" name="Text 2"/>
-          <p:cNvSpPr/>
-          <p:nvPr/>
-        </p:nvSpPr>
-        <p:spPr>
-          <a:xfrm>
-            <a:off x="5349240" y="1783080"/>
-            <a:ext cx="6522415" cy="4663440"/>
-          </a:xfrm>
-          <a:prstGeom prst="rect">
-            <a:avLst/>
-          </a:prstGeom>
-          <a:noFill/>
-          <a:ln/>
-        </p:spPr>
-        <p:txBody>
-          <a:bodyPr wrap="square" lIns="0" tIns="0" rIns="0" bIns="0" rtlCol="0" anchor="t"/>
-          <a:lstStyle/>
-          <a:p>
-            <a:pPr algn="l" marL="342900" indent="-342900">
-              <a:spcAft>
-                <a:spcPts val="800"/>
-              </a:spcAft>
-              <a:buSzPct val="100000"/>
-              <a:buChar char="•"/>
-            </a:pPr>
-            <a:r>
-              <a:rPr lang="en-US" sz="2000" dirty="0">
-                <a:solidFill>
-                  <a:srgbClr val="111111"/>
-                </a:solidFill>
-                <a:latin typeface="Calibri" pitchFamily="34" charset="0"/>
-                <a:ea typeface="Calibri" pitchFamily="34" charset="-122"/>
-                <a:cs typeface="Calibri" pitchFamily="34" charset="-120"/>
-              </a:rPr>
-              <a:t>Timing: Homework correction, plan, objectives 4 min | Recall, situation, action 6 min | 3 activities 12 min | Board summary (copying) 15 min | Evaluation, remediation 5 min | Homework, next lesson 3 min | Logbook 5 min</a:t>
-            </a:r>
-            <a:endParaRPr lang="en-US" sz="2000" dirty="0"/>
-          </a:p>
-          <a:p>
-            <a:pPr algn="l" marL="342900" indent="-342900">
-              <a:spcAft>
-                <a:spcPts val="800"/>
-              </a:spcAft>
-              <a:buSzPct val="100000"/>
-              <a:buChar char="•"/>
-            </a:pPr>
-            <a:r>
-              <a:rPr lang="en-US" sz="2000" dirty="0">
-                <a:solidFill>
-                  <a:srgbClr val="111111"/>
-                </a:solidFill>
-                <a:latin typeface="Calibri" pitchFamily="34" charset="0"/>
-                <a:ea typeface="Calibri" pitchFamily="34" charset="-122"/>
-                <a:cs typeface="Calibri" pitchFamily="34" charset="-120"/>
-              </a:rPr>
-              <a:t>Without the projector (Activity 1): cut an orange in two equal halves, then cut a small piece from the top.</a:t>
-            </a:r>
-            <a:endParaRPr lang="en-US" sz="2000" dirty="0"/>
-          </a:p>
-          <a:p>
-            <a:pPr algn="l" marL="342900" indent="-342900">
-              <a:spcAft>
-                <a:spcPts val="800"/>
-              </a:spcAft>
-              <a:buSzPct val="100000"/>
-              <a:buChar char="•"/>
-            </a:pPr>
-            <a:r>
-              <a:rPr lang="en-US" sz="2000" dirty="0">
-                <a:solidFill>
-                  <a:srgbClr val="111111"/>
-                </a:solidFill>
-                <a:latin typeface="Calibri" pitchFamily="34" charset="0"/>
-                <a:ea typeface="Calibri" pitchFamily="34" charset="-122"/>
-                <a:cs typeface="Calibri" pitchFamily="34" charset="-120"/>
-              </a:rPr>
-              <a:t>Without the projector (Activity 2): ask learners who has seen the New Year on television.</a:t>
-            </a:r>
-            <a:endParaRPr lang="en-US" sz="2000" dirty="0"/>
-          </a:p>
-          <a:p>
-            <a:pPr algn="l" marL="342900" indent="-342900">
-              <a:spcAft>
-                <a:spcPts val="800"/>
-              </a:spcAft>
-              <a:buSzPct val="100000"/>
-              <a:buChar char="•"/>
-            </a:pPr>
-            <a:r>
-              <a:rPr lang="en-US" sz="2000" dirty="0">
-                <a:solidFill>
-                  <a:srgbClr val="111111"/>
-                </a:solidFill>
-                <a:latin typeface="Calibri" pitchFamily="34" charset="0"/>
-                <a:ea typeface="Calibri" pitchFamily="34" charset="-122"/>
-                <a:cs typeface="Calibri" pitchFamily="34" charset="-120"/>
-              </a:rPr>
-              <a:t>Without the projector (Activity 3): draw a line and write MONDAY on the left and SUNDAY on the right.</a:t>
-            </a:r>
-            <a:endParaRPr lang="en-US" sz="2000" dirty="0"/>
-          </a:p>
-        </p:txBody>
-      </p:sp>
-      <p:sp>
-        <p:nvSpPr>
-          <p:cNvPr id="25" name="Slide Number Placeholder 0"/>
-          <p:cNvSpPr>
-            <a:spLocks noGrp="1"/>
-          </p:cNvSpPr>
-          <p:nvPr>
-            <p:ph type="sldNum" sz="quarter" idx="4294967295"/>
-          </p:nvPr>
-        </p:nvSpPr>
-        <p:spPr>
-          <a:xfrm>
-            <a:off x="27432" y="91440"/>
-            <a:ext cx="585216" cy="475488"/>
-          </a:xfrm>
-          <a:prstGeom prst="rect">
-            <a:avLst/>
-          </a:prstGeom>
-          <a:extLst>
-            <a:ext uri="{C572A759-6A51-4108-AA02-DFA0A04FC94B}">
-              <ma14:wrappingTextBoxFlag xmlns:ma14="http://schemas.microsoft.com/office/mac/drawingml/2011/main" val="0"/>
-            </a:ext>
-          </a:extLst>
-        </p:spPr>
-        <p:txBody>
-          <a:bodyPr/>
-          <a:lstStyle>
-            <a:lvl1pPr>
-              <a:defRPr sz="2000">
-                <a:solidFill>
-                  <a:srgbClr val="FFFFFF"/>
-                </a:solidFill>
-                <a:latin typeface="Calibri"/>
-                <a:ea typeface="Calibri"/>
-                <a:cs typeface="Calibri"/>
-              </a:defRPr>
-            </a:lvl1pPr>
-          </a:lstStyle>
-          <a:p>
-            <a:pPr algn="ctr"/>
-            <a:fld id="{F7021451-1387-4CA6-816F-3879F97B5CBC}" type="slidenum">
-              <a:rPr b="1" lang="en-US"/>
-              <a:t>46</a:t>
-            </a:fld>
-            <a:endParaRPr lang="en-US"/>
-          </a:p>
-        </p:txBody>
-      </p:sp>
-    </p:spTree>
-  </p:cSld>
-  <p:clrMapOvr>
-    <a:masterClrMapping/>
-  </p:clrMapOvr>
-</p:sld>
-</file>
-
-<file path=ppt/slides/slide47.xml><?xml version="1.0" encoding="utf-8"?>
-<p:sld xmlns:a="http://schemas.openxmlformats.org/drawingml/2006/main" xmlns:r="http://schemas.openxmlformats.org/officeDocument/2006/relationships" xmlns:p="http://schemas.openxmlformats.org/presentationml/2006/main">
-  <p:cSld name="Slide 47">
-    <p:spTree>
-      <p:nvGrpSpPr>
-        <p:cNvPr id="1" name=""/>
-        <p:cNvGrpSpPr/>
-        <p:nvPr/>
-      </p:nvGrpSpPr>
-      <p:grpSpPr>
-        <a:xfrm>
-          <a:off x="0" y="0"/>
-          <a:ext cx="0" cy="0"/>
-          <a:chOff x="0" y="0"/>
-          <a:chExt cx="0" cy="0"/>
-        </a:xfrm>
-      </p:grpSpPr>
-      <p:sp>
-        <p:nvSpPr>
-          <p:cNvPr id="2" name="Text 0"/>
-          <p:cNvSpPr/>
-          <p:nvPr/>
-        </p:nvSpPr>
-        <p:spPr>
-          <a:xfrm>
-            <a:off x="457200" y="713232"/>
-            <a:ext cx="11368735" cy="274320"/>
-          </a:xfrm>
-          <a:prstGeom prst="rect">
-            <a:avLst/>
-          </a:prstGeom>
-          <a:noFill/>
-          <a:ln/>
-        </p:spPr>
-        <p:txBody>
-          <a:bodyPr wrap="square" lIns="0" tIns="0" rIns="0" bIns="0" rtlCol="0" anchor="ctr"/>
-          <a:lstStyle/>
-          <a:p>
-            <a:pPr algn="r" indent="0" marL="0">
-              <a:buNone/>
-            </a:pPr>
-            <a:r>
-              <a:rPr lang="en-US" sz="1400" b="1" dirty="0">
-                <a:solidFill>
-                  <a:srgbClr val="1C3F6E"/>
-                </a:solidFill>
-                <a:latin typeface="Calibri" pitchFamily="34" charset="0"/>
-                <a:ea typeface="Calibri" pitchFamily="34" charset="-122"/>
-                <a:cs typeface="Calibri" pitchFamily="34" charset="-120"/>
-              </a:rPr>
-              <a:t>REFERENCES</a:t>
-            </a:r>
-            <a:endParaRPr lang="en-US" sz="1400" dirty="0"/>
-          </a:p>
-        </p:txBody>
-      </p:sp>
-      <p:pic>
-        <p:nvPicPr>
-          <p:cNvPr id="3" name="Image 0" descr="/home/claude/f4/img/minesec_sheet.png">    </p:cNvPr>
-          <p:cNvPicPr>
-            <a:picLocks noChangeAspect="1"/>
-          </p:cNvPicPr>
-          <p:nvPr/>
-        </p:nvPicPr>
-        <p:blipFill>
-          <a:blip r:embed="rId1"/>
-          <a:stretch>
-            <a:fillRect/>
-          </a:stretch>
-        </p:blipFill>
-        <p:spPr>
-          <a:xfrm>
-            <a:off x="0" y="658368"/>
-            <a:ext cx="5120640" cy="5833872"/>
-          </a:xfrm>
-          <a:prstGeom prst="rect">
-            <a:avLst/>
-          </a:prstGeom>
-        </p:spPr>
-      </p:pic>
-      <p:sp>
-        <p:nvSpPr>
-          <p:cNvPr id="4" name="Text 1"/>
-          <p:cNvSpPr/>
-          <p:nvPr/>
-        </p:nvSpPr>
-        <p:spPr>
-          <a:xfrm>
-            <a:off x="5349240" y="1005840"/>
-            <a:ext cx="6522415" cy="731520"/>
-          </a:xfrm>
-          <a:prstGeom prst="rect">
-            <a:avLst/>
-          </a:prstGeom>
-          <a:noFill/>
-          <a:ln/>
-        </p:spPr>
-        <p:txBody>
-          <a:bodyPr wrap="square" lIns="0" tIns="0" rIns="0" bIns="0" rtlCol="0" anchor="ctr">
-            <a:normAutofit/>
-          </a:bodyPr>
-          <a:lstStyle/>
-          <a:p>
-            <a:pPr algn="ctr" indent="0" marL="0">
-              <a:buNone/>
-            </a:pPr>
-            <a:r>
-              <a:rPr lang="en-US" sz="3600" b="1" dirty="0">
-                <a:solidFill>
-                  <a:srgbClr val="990011"/>
-                </a:solidFill>
-                <a:latin typeface="Times New Roman" pitchFamily="34" charset="0"/>
-                <a:ea typeface="Times New Roman" pitchFamily="34" charset="-122"/>
-                <a:cs typeface="Times New Roman" pitchFamily="34" charset="-120"/>
-              </a:rPr>
-              <a:t>References</a:t>
-            </a:r>
-            <a:endParaRPr lang="en-US" sz="3600" dirty="0"/>
-          </a:p>
-        </p:txBody>
-      </p:sp>
-      <p:sp>
-        <p:nvSpPr>
-          <p:cNvPr id="5" name="Text 2"/>
-          <p:cNvSpPr/>
-          <p:nvPr/>
-        </p:nvSpPr>
-        <p:spPr>
-          <a:xfrm>
-            <a:off x="5349240" y="1783080"/>
-            <a:ext cx="6522415" cy="4663440"/>
-          </a:xfrm>
-          <a:prstGeom prst="rect">
-            <a:avLst/>
-          </a:prstGeom>
-          <a:noFill/>
-          <a:ln/>
-        </p:spPr>
-        <p:txBody>
-          <a:bodyPr wrap="square" lIns="0" tIns="0" rIns="0" bIns="0" rtlCol="0" anchor="t"/>
-          <a:lstStyle/>
-          <a:p>
-            <a:pPr algn="l" marL="342900" indent="-342900">
-              <a:spcAft>
-                <a:spcPts val="800"/>
-              </a:spcAft>
-              <a:buSzPct val="100000"/>
-              <a:buChar char="•"/>
-            </a:pPr>
-            <a:r>
-              <a:rPr lang="en-US" sz="1800" dirty="0">
-                <a:solidFill>
-                  <a:srgbClr val="111111"/>
-                </a:solidFill>
-                <a:latin typeface="Calibri" pitchFamily="34" charset="0"/>
-                <a:ea typeface="Calibri" pitchFamily="34" charset="-122"/>
-                <a:cs typeface="Calibri" pitchFamily="34" charset="-120"/>
-              </a:rPr>
-              <a:t>National Geography Syllabus (MINESEC), Form 4 — The Earth as a Planet in the Solar System.</a:t>
-            </a:r>
-            <a:endParaRPr lang="en-US" sz="1800" dirty="0"/>
-          </a:p>
-          <a:p>
-            <a:pPr algn="l" marL="342900" indent="-342900">
-              <a:spcAft>
-                <a:spcPts val="800"/>
-              </a:spcAft>
-              <a:buSzPct val="100000"/>
-              <a:buChar char="•"/>
-            </a:pPr>
-            <a:r>
-              <a:rPr lang="en-US" sz="1800" dirty="0">
-                <a:solidFill>
-                  <a:srgbClr val="111111"/>
-                </a:solidFill>
-                <a:latin typeface="Calibri" pitchFamily="34" charset="0"/>
-                <a:ea typeface="Calibri" pitchFamily="34" charset="-122"/>
-                <a:cs typeface="Calibri" pitchFamily="34" charset="-120"/>
-              </a:rPr>
-              <a:t>Teacher's lesson notes (Form 4), checked and corrected where necessary.</a:t>
-            </a:r>
-            <a:endParaRPr lang="en-US" sz="1800" dirty="0"/>
-          </a:p>
-          <a:p>
-            <a:pPr algn="l" marL="342900" indent="-342900">
-              <a:spcAft>
-                <a:spcPts val="800"/>
-              </a:spcAft>
-              <a:buSzPct val="100000"/>
-              <a:buChar char="•"/>
-            </a:pPr>
-            <a:r>
-              <a:rPr lang="en-US" sz="1800" dirty="0">
-                <a:solidFill>
-                  <a:srgbClr val="111111"/>
-                </a:solidFill>
-                <a:latin typeface="Calibri" pitchFamily="34" charset="0"/>
-                <a:ea typeface="Calibri" pitchFamily="34" charset="-122"/>
-                <a:cs typeface="Calibri" pitchFamily="34" charset="-120"/>
-              </a:rPr>
-              <a:t>Photo, Activity 2: “New Year's Fireworks - Sydney Harbour” by Charlie Brewer, CC BY-NC-SA 2.0, via Flickr (https://www.flickr.com/photos/11827916@N00/2157381693)</a:t>
-            </a:r>
-            <a:endParaRPr lang="en-US" sz="1800" dirty="0"/>
-          </a:p>
-          <a:p>
-            <a:pPr algn="l" marL="342900" indent="-342900">
-              <a:spcAft>
-                <a:spcPts val="800"/>
-              </a:spcAft>
-              <a:buSzPct val="100000"/>
-              <a:buChar char="•"/>
-            </a:pPr>
-            <a:r>
-              <a:rPr lang="en-US" sz="1800" dirty="0">
-                <a:solidFill>
-                  <a:srgbClr val="111111"/>
-                </a:solidFill>
-                <a:latin typeface="Calibri" pitchFamily="34" charset="0"/>
-                <a:ea typeface="Calibri" pitchFamily="34" charset="-122"/>
-                <a:cs typeface="Calibri" pitchFamily="34" charset="-120"/>
-              </a:rPr>
-              <a:t>Diagrams and animations: drawn for this lesson (Geography Department).</a:t>
-            </a:r>
-            <a:endParaRPr lang="en-US" sz="1800" dirty="0"/>
-          </a:p>
-        </p:txBody>
-      </p:sp>
-      <p:sp>
-        <p:nvSpPr>
-          <p:cNvPr id="25" name="Slide Number Placeholder 0"/>
-          <p:cNvSpPr>
-            <a:spLocks noGrp="1"/>
-          </p:cNvSpPr>
-          <p:nvPr>
-            <p:ph type="sldNum" sz="quarter" idx="4294967295"/>
-          </p:nvPr>
-        </p:nvSpPr>
-        <p:spPr>
-          <a:xfrm>
-            <a:off x="27432" y="91440"/>
-            <a:ext cx="585216" cy="475488"/>
-          </a:xfrm>
-          <a:prstGeom prst="rect">
-            <a:avLst/>
-          </a:prstGeom>
-          <a:extLst>
-            <a:ext uri="{C572A759-6A51-4108-AA02-DFA0A04FC94B}">
-              <ma14:wrappingTextBoxFlag xmlns:ma14="http://schemas.microsoft.com/office/mac/drawingml/2011/main" val="0"/>
-            </a:ext>
-          </a:extLst>
-        </p:spPr>
-        <p:txBody>
-          <a:bodyPr/>
-          <a:lstStyle>
-            <a:lvl1pPr>
-              <a:defRPr sz="2000">
-                <a:solidFill>
-                  <a:srgbClr val="FFFFFF"/>
-                </a:solidFill>
-                <a:latin typeface="Calibri"/>
-                <a:ea typeface="Calibri"/>
-                <a:cs typeface="Calibri"/>
-              </a:defRPr>
-            </a:lvl1pPr>
-          </a:lstStyle>
-          <a:p>
-            <a:pPr algn="ctr"/>
-            <a:fld id="{F7021451-1387-4CA6-816F-3879F97B5CBC}" type="slidenum">
-              <a:rPr b="1" lang="en-US"/>
-              <a:t>47</a:t>
+              <a:t>49</a:t>
             </a:fld>
             <a:endParaRPr lang="en-US"/>
           </a:p>
@@ -19109,6 +20452,572 @@
             <a:fld id="{F7021451-1387-4CA6-816F-3879F97B5CBC}" type="slidenum">
               <a:rPr b="1" lang="en-US"/>
               <a:t>5</a:t>
+            </a:fld>
+            <a:endParaRPr lang="en-US"/>
+          </a:p>
+        </p:txBody>
+      </p:sp>
+    </p:spTree>
+  </p:cSld>
+  <p:clrMapOvr>
+    <a:masterClrMapping/>
+  </p:clrMapOvr>
+</p:sld>
+</file>
+
+<file path=ppt/slides/slide50.xml><?xml version="1.0" encoding="utf-8"?>
+<p:sld xmlns:a="http://schemas.openxmlformats.org/drawingml/2006/main" xmlns:r="http://schemas.openxmlformats.org/officeDocument/2006/relationships" xmlns:p="http://schemas.openxmlformats.org/presentationml/2006/main">
+  <p:cSld name="Slide 50">
+    <p:spTree>
+      <p:nvGrpSpPr>
+        <p:cNvPr id="1" name=""/>
+        <p:cNvGrpSpPr/>
+        <p:nvPr/>
+      </p:nvGrpSpPr>
+      <p:grpSpPr>
+        <a:xfrm>
+          <a:off x="0" y="0"/>
+          <a:ext cx="0" cy="0"/>
+          <a:chOff x="0" y="0"/>
+          <a:chExt cx="0" cy="0"/>
+        </a:xfrm>
+      </p:grpSpPr>
+      <p:sp>
+        <p:nvSpPr>
+          <p:cNvPr id="2" name="Text 0"/>
+          <p:cNvSpPr/>
+          <p:nvPr/>
+        </p:nvSpPr>
+        <p:spPr>
+          <a:xfrm>
+            <a:off x="457200" y="713232"/>
+            <a:ext cx="11368735" cy="274320"/>
+          </a:xfrm>
+          <a:prstGeom prst="rect">
+            <a:avLst/>
+          </a:prstGeom>
+          <a:noFill/>
+          <a:ln/>
+        </p:spPr>
+        <p:txBody>
+          <a:bodyPr wrap="square" lIns="0" tIns="0" rIns="0" bIns="0" rtlCol="0" anchor="ctr"/>
+          <a:lstStyle/>
+          <a:p>
+            <a:pPr algn="r" indent="0" marL="0">
+              <a:buNone/>
+            </a:pPr>
+            <a:r>
+              <a:rPr lang="en-US" sz="1400" b="1" dirty="0">
+                <a:solidFill>
+                  <a:srgbClr val="1C3F6E"/>
+                </a:solidFill>
+                <a:latin typeface="Calibri" pitchFamily="34" charset="0"/>
+                <a:ea typeface="Calibri" pitchFamily="34" charset="-122"/>
+                <a:cs typeface="Calibri" pitchFamily="34" charset="-120"/>
+              </a:rPr>
+              <a:t>TEACHER'S NOTE</a:t>
+            </a:r>
+            <a:endParaRPr lang="en-US" sz="1400" dirty="0"/>
+          </a:p>
+        </p:txBody>
+      </p:sp>
+      <p:pic>
+        <p:nvPicPr>
+          <p:cNvPr id="3" name="Image 0" descr="/home/claude/f4/img/minesec_sheet.png">    </p:cNvPr>
+          <p:cNvPicPr>
+            <a:picLocks noChangeAspect="1"/>
+          </p:cNvPicPr>
+          <p:nvPr/>
+        </p:nvPicPr>
+        <p:blipFill>
+          <a:blip r:embed="rId1"/>
+          <a:stretch>
+            <a:fillRect/>
+          </a:stretch>
+        </p:blipFill>
+        <p:spPr>
+          <a:xfrm>
+            <a:off x="0" y="658368"/>
+            <a:ext cx="5120640" cy="5833872"/>
+          </a:xfrm>
+          <a:prstGeom prst="rect">
+            <a:avLst/>
+          </a:prstGeom>
+        </p:spPr>
+      </p:pic>
+      <p:sp>
+        <p:nvSpPr>
+          <p:cNvPr id="4" name="Text 1"/>
+          <p:cNvSpPr/>
+          <p:nvPr/>
+        </p:nvSpPr>
+        <p:spPr>
+          <a:xfrm>
+            <a:off x="5349240" y="1005840"/>
+            <a:ext cx="6522415" cy="731520"/>
+          </a:xfrm>
+          <a:prstGeom prst="rect">
+            <a:avLst/>
+          </a:prstGeom>
+          <a:noFill/>
+          <a:ln/>
+        </p:spPr>
+        <p:txBody>
+          <a:bodyPr wrap="square" lIns="0" tIns="0" rIns="0" bIns="0" rtlCol="0" anchor="ctr">
+            <a:normAutofit/>
+          </a:bodyPr>
+          <a:lstStyle/>
+          <a:p>
+            <a:pPr algn="ctr" indent="0" marL="0">
+              <a:buNone/>
+            </a:pPr>
+            <a:r>
+              <a:rPr lang="en-US" sz="3600" b="1" dirty="0">
+                <a:solidFill>
+                  <a:srgbClr val="990011"/>
+                </a:solidFill>
+                <a:latin typeface="Times New Roman" pitchFamily="34" charset="0"/>
+                <a:ea typeface="Times New Roman" pitchFamily="34" charset="-122"/>
+                <a:cs typeface="Times New Roman" pitchFamily="34" charset="-120"/>
+              </a:rPr>
+              <a:t>Teacher's Note</a:t>
+            </a:r>
+            <a:endParaRPr lang="en-US" sz="3600" dirty="0"/>
+          </a:p>
+        </p:txBody>
+      </p:sp>
+      <p:sp>
+        <p:nvSpPr>
+          <p:cNvPr id="5" name="Text 2"/>
+          <p:cNvSpPr/>
+          <p:nvPr/>
+        </p:nvSpPr>
+        <p:spPr>
+          <a:xfrm>
+            <a:off x="5349240" y="1783080"/>
+            <a:ext cx="6522415" cy="4663440"/>
+          </a:xfrm>
+          <a:prstGeom prst="rect">
+            <a:avLst/>
+          </a:prstGeom>
+          <a:noFill/>
+          <a:ln/>
+        </p:spPr>
+        <p:txBody>
+          <a:bodyPr wrap="square" lIns="0" tIns="0" rIns="0" bIns="0" rtlCol="0" anchor="t"/>
+          <a:lstStyle/>
+          <a:p>
+            <a:pPr algn="l" marL="342900" indent="-342900">
+              <a:spcAft>
+                <a:spcPts val="800"/>
+              </a:spcAft>
+              <a:buSzPct val="100000"/>
+              <a:buChar char="•"/>
+            </a:pPr>
+            <a:r>
+              <a:rPr lang="en-US" sz="2000" dirty="0">
+                <a:solidFill>
+                  <a:srgbClr val="111111"/>
+                </a:solidFill>
+                <a:latin typeface="Calibri" pitchFamily="34" charset="0"/>
+                <a:ea typeface="Calibri" pitchFamily="34" charset="-122"/>
+                <a:cs typeface="Calibri" pitchFamily="34" charset="-120"/>
+              </a:rPr>
+              <a:t>Timing: Homework correction, plan, objectives 4 min | Recall, situation, action 6 min | 3 activities 12 min | Board summary (copying) 15 min | Evaluation, remediation 5 min | Homework, next lesson 3 min | Logbook 5 min</a:t>
+            </a:r>
+            <a:endParaRPr lang="en-US" sz="2000" dirty="0"/>
+          </a:p>
+          <a:p>
+            <a:pPr algn="l" marL="342900" indent="-342900">
+              <a:spcAft>
+                <a:spcPts val="800"/>
+              </a:spcAft>
+              <a:buSzPct val="100000"/>
+              <a:buChar char="•"/>
+            </a:pPr>
+            <a:r>
+              <a:rPr lang="en-US" sz="2000" dirty="0">
+                <a:solidFill>
+                  <a:srgbClr val="111111"/>
+                </a:solidFill>
+                <a:latin typeface="Calibri" pitchFamily="34" charset="0"/>
+                <a:ea typeface="Calibri" pitchFamily="34" charset="-122"/>
+                <a:cs typeface="Calibri" pitchFamily="34" charset="-120"/>
+              </a:rPr>
+              <a:t>Without the projector (Activity 1): cut an orange into two equal halves, then cut a small piece from the top.</a:t>
+            </a:r>
+            <a:endParaRPr lang="en-US" sz="2000" dirty="0"/>
+          </a:p>
+          <a:p>
+            <a:pPr algn="l" marL="342900" indent="-342900">
+              <a:spcAft>
+                <a:spcPts val="800"/>
+              </a:spcAft>
+              <a:buSzPct val="100000"/>
+              <a:buChar char="•"/>
+            </a:pPr>
+            <a:r>
+              <a:rPr lang="en-US" sz="2000" dirty="0">
+                <a:solidFill>
+                  <a:srgbClr val="111111"/>
+                </a:solidFill>
+                <a:latin typeface="Calibri" pitchFamily="34" charset="0"/>
+                <a:ea typeface="Calibri" pitchFamily="34" charset="-122"/>
+                <a:cs typeface="Calibri" pitchFamily="34" charset="-120"/>
+              </a:rPr>
+              <a:t>Without the projector (Activity 2): ask learners who has seen the New Year on television.</a:t>
+            </a:r>
+            <a:endParaRPr lang="en-US" sz="2000" dirty="0"/>
+          </a:p>
+          <a:p>
+            <a:pPr algn="l" marL="342900" indent="-342900">
+              <a:spcAft>
+                <a:spcPts val="800"/>
+              </a:spcAft>
+              <a:buSzPct val="100000"/>
+              <a:buChar char="•"/>
+            </a:pPr>
+            <a:r>
+              <a:rPr lang="en-US" sz="2000" dirty="0">
+                <a:solidFill>
+                  <a:srgbClr val="111111"/>
+                </a:solidFill>
+                <a:latin typeface="Calibri" pitchFamily="34" charset="0"/>
+                <a:ea typeface="Calibri" pitchFamily="34" charset="-122"/>
+                <a:cs typeface="Calibri" pitchFamily="34" charset="-120"/>
+              </a:rPr>
+              <a:t>Without the projector (Activity 3): draw a line and write MONDAY on the left and SUNDAY on the right.</a:t>
+            </a:r>
+            <a:endParaRPr lang="en-US" sz="2000" dirty="0"/>
+          </a:p>
+        </p:txBody>
+      </p:sp>
+      <p:sp>
+        <p:nvSpPr>
+          <p:cNvPr id="25" name="Slide Number Placeholder 0"/>
+          <p:cNvSpPr>
+            <a:spLocks noGrp="1"/>
+          </p:cNvSpPr>
+          <p:nvPr>
+            <p:ph type="sldNum" sz="quarter" idx="4294967295"/>
+          </p:nvPr>
+        </p:nvSpPr>
+        <p:spPr>
+          <a:xfrm>
+            <a:off x="27432" y="91440"/>
+            <a:ext cx="585216" cy="475488"/>
+          </a:xfrm>
+          <a:prstGeom prst="rect">
+            <a:avLst/>
+          </a:prstGeom>
+          <a:extLst>
+            <a:ext uri="{C572A759-6A51-4108-AA02-DFA0A04FC94B}">
+              <ma14:wrappingTextBoxFlag xmlns:ma14="http://schemas.microsoft.com/office/mac/drawingml/2011/main" val="0"/>
+            </a:ext>
+          </a:extLst>
+        </p:spPr>
+        <p:txBody>
+          <a:bodyPr/>
+          <a:lstStyle>
+            <a:lvl1pPr>
+              <a:defRPr sz="2000">
+                <a:solidFill>
+                  <a:srgbClr val="FFFFFF"/>
+                </a:solidFill>
+                <a:latin typeface="Calibri"/>
+                <a:ea typeface="Calibri"/>
+                <a:cs typeface="Calibri"/>
+              </a:defRPr>
+            </a:lvl1pPr>
+          </a:lstStyle>
+          <a:p>
+            <a:pPr algn="ctr"/>
+            <a:fld id="{F7021451-1387-4CA6-816F-3879F97B5CBC}" type="slidenum">
+              <a:rPr b="1" lang="en-US"/>
+              <a:t>50</a:t>
+            </a:fld>
+            <a:endParaRPr lang="en-US"/>
+          </a:p>
+        </p:txBody>
+      </p:sp>
+    </p:spTree>
+  </p:cSld>
+  <p:clrMapOvr>
+    <a:masterClrMapping/>
+  </p:clrMapOvr>
+</p:sld>
+</file>
+
+<file path=ppt/slides/slide51.xml><?xml version="1.0" encoding="utf-8"?>
+<p:sld xmlns:a="http://schemas.openxmlformats.org/drawingml/2006/main" xmlns:r="http://schemas.openxmlformats.org/officeDocument/2006/relationships" xmlns:p="http://schemas.openxmlformats.org/presentationml/2006/main">
+  <p:cSld name="Slide 51">
+    <p:spTree>
+      <p:nvGrpSpPr>
+        <p:cNvPr id="1" name=""/>
+        <p:cNvGrpSpPr/>
+        <p:nvPr/>
+      </p:nvGrpSpPr>
+      <p:grpSpPr>
+        <a:xfrm>
+          <a:off x="0" y="0"/>
+          <a:ext cx="0" cy="0"/>
+          <a:chOff x="0" y="0"/>
+          <a:chExt cx="0" cy="0"/>
+        </a:xfrm>
+      </p:grpSpPr>
+      <p:sp>
+        <p:nvSpPr>
+          <p:cNvPr id="2" name="Text 0"/>
+          <p:cNvSpPr/>
+          <p:nvPr/>
+        </p:nvSpPr>
+        <p:spPr>
+          <a:xfrm>
+            <a:off x="457200" y="713232"/>
+            <a:ext cx="11368735" cy="274320"/>
+          </a:xfrm>
+          <a:prstGeom prst="rect">
+            <a:avLst/>
+          </a:prstGeom>
+          <a:noFill/>
+          <a:ln/>
+        </p:spPr>
+        <p:txBody>
+          <a:bodyPr wrap="square" lIns="0" tIns="0" rIns="0" bIns="0" rtlCol="0" anchor="ctr"/>
+          <a:lstStyle/>
+          <a:p>
+            <a:pPr algn="r" indent="0" marL="0">
+              <a:buNone/>
+            </a:pPr>
+            <a:r>
+              <a:rPr lang="en-US" sz="1400" b="1" dirty="0">
+                <a:solidFill>
+                  <a:srgbClr val="1C3F6E"/>
+                </a:solidFill>
+                <a:latin typeface="Calibri" pitchFamily="34" charset="0"/>
+                <a:ea typeface="Calibri" pitchFamily="34" charset="-122"/>
+                <a:cs typeface="Calibri" pitchFamily="34" charset="-120"/>
+              </a:rPr>
+              <a:t>REFERENCES</a:t>
+            </a:r>
+            <a:endParaRPr lang="en-US" sz="1400" dirty="0"/>
+          </a:p>
+        </p:txBody>
+      </p:sp>
+      <p:pic>
+        <p:nvPicPr>
+          <p:cNvPr id="3" name="Image 0" descr="/home/claude/f4/img/minesec_sheet.png">    </p:cNvPr>
+          <p:cNvPicPr>
+            <a:picLocks noChangeAspect="1"/>
+          </p:cNvPicPr>
+          <p:nvPr/>
+        </p:nvPicPr>
+        <p:blipFill>
+          <a:blip r:embed="rId1"/>
+          <a:stretch>
+            <a:fillRect/>
+          </a:stretch>
+        </p:blipFill>
+        <p:spPr>
+          <a:xfrm>
+            <a:off x="0" y="658368"/>
+            <a:ext cx="5120640" cy="5833872"/>
+          </a:xfrm>
+          <a:prstGeom prst="rect">
+            <a:avLst/>
+          </a:prstGeom>
+        </p:spPr>
+      </p:pic>
+      <p:sp>
+        <p:nvSpPr>
+          <p:cNvPr id="4" name="Text 1"/>
+          <p:cNvSpPr/>
+          <p:nvPr/>
+        </p:nvSpPr>
+        <p:spPr>
+          <a:xfrm>
+            <a:off x="5349240" y="1005840"/>
+            <a:ext cx="6522415" cy="731520"/>
+          </a:xfrm>
+          <a:prstGeom prst="rect">
+            <a:avLst/>
+          </a:prstGeom>
+          <a:noFill/>
+          <a:ln/>
+        </p:spPr>
+        <p:txBody>
+          <a:bodyPr wrap="square" lIns="0" tIns="0" rIns="0" bIns="0" rtlCol="0" anchor="ctr">
+            <a:normAutofit/>
+          </a:bodyPr>
+          <a:lstStyle/>
+          <a:p>
+            <a:pPr algn="ctr" indent="0" marL="0">
+              <a:buNone/>
+            </a:pPr>
+            <a:r>
+              <a:rPr lang="en-US" sz="3600" b="1" dirty="0">
+                <a:solidFill>
+                  <a:srgbClr val="990011"/>
+                </a:solidFill>
+                <a:latin typeface="Times New Roman" pitchFamily="34" charset="0"/>
+                <a:ea typeface="Times New Roman" pitchFamily="34" charset="-122"/>
+                <a:cs typeface="Times New Roman" pitchFamily="34" charset="-120"/>
+              </a:rPr>
+              <a:t>References</a:t>
+            </a:r>
+            <a:endParaRPr lang="en-US" sz="3600" dirty="0"/>
+          </a:p>
+        </p:txBody>
+      </p:sp>
+      <p:sp>
+        <p:nvSpPr>
+          <p:cNvPr id="5" name="Text 2"/>
+          <p:cNvSpPr/>
+          <p:nvPr/>
+        </p:nvSpPr>
+        <p:spPr>
+          <a:xfrm>
+            <a:off x="5349240" y="1783080"/>
+            <a:ext cx="6522415" cy="4663440"/>
+          </a:xfrm>
+          <a:prstGeom prst="rect">
+            <a:avLst/>
+          </a:prstGeom>
+          <a:noFill/>
+          <a:ln/>
+        </p:spPr>
+        <p:txBody>
+          <a:bodyPr wrap="square" lIns="0" tIns="0" rIns="0" bIns="0" rtlCol="0" anchor="t"/>
+          <a:lstStyle/>
+          <a:p>
+            <a:pPr algn="l" marL="342900" indent="-342900">
+              <a:spcAft>
+                <a:spcPts val="800"/>
+              </a:spcAft>
+              <a:buSzPct val="100000"/>
+              <a:buChar char="•"/>
+            </a:pPr>
+            <a:r>
+              <a:rPr lang="en-US" sz="1800" dirty="0">
+                <a:solidFill>
+                  <a:srgbClr val="111111"/>
+                </a:solidFill>
+                <a:latin typeface="Calibri" pitchFamily="34" charset="0"/>
+                <a:ea typeface="Calibri" pitchFamily="34" charset="-122"/>
+                <a:cs typeface="Calibri" pitchFamily="34" charset="-120"/>
+              </a:rPr>
+              <a:t>National Geography Syllabus (MINESEC), Form 4 — The Earth as a Planet in the Solar System.</a:t>
+            </a:r>
+            <a:endParaRPr lang="en-US" sz="1800" dirty="0"/>
+          </a:p>
+          <a:p>
+            <a:pPr algn="l" marL="342900" indent="-342900">
+              <a:spcAft>
+                <a:spcPts val="800"/>
+              </a:spcAft>
+              <a:buSzPct val="100000"/>
+              <a:buChar char="•"/>
+            </a:pPr>
+            <a:r>
+              <a:rPr lang="en-US" sz="1800" dirty="0">
+                <a:solidFill>
+                  <a:srgbClr val="111111"/>
+                </a:solidFill>
+                <a:latin typeface="Calibri" pitchFamily="34" charset="0"/>
+                <a:ea typeface="Calibri" pitchFamily="34" charset="-122"/>
+                <a:cs typeface="Calibri" pitchFamily="34" charset="-120"/>
+              </a:rPr>
+              <a:t>Teacher's lesson notes (Form 4), checked and corrected where necessary.</a:t>
+            </a:r>
+            <a:endParaRPr lang="en-US" sz="1800" dirty="0"/>
+          </a:p>
+          <a:p>
+            <a:pPr algn="l" marL="342900" indent="-342900">
+              <a:spcAft>
+                <a:spcPts val="800"/>
+              </a:spcAft>
+              <a:buSzPct val="100000"/>
+              <a:buChar char="•"/>
+            </a:pPr>
+            <a:r>
+              <a:rPr lang="en-US" sz="1800" dirty="0">
+                <a:solidFill>
+                  <a:srgbClr val="111111"/>
+                </a:solidFill>
+                <a:latin typeface="Calibri" pitchFamily="34" charset="0"/>
+                <a:ea typeface="Calibri" pitchFamily="34" charset="-122"/>
+                <a:cs typeface="Calibri" pitchFamily="34" charset="-120"/>
+              </a:rPr>
+              <a:t>Photo, Activity 2: “New Year's Fireworks - Sydney Harbour” by Charlie Brewer, CC BY-NC-SA 2.0, via Flickr (https://www.flickr.com/photos/11827916@N00/2157381693)</a:t>
+            </a:r>
+            <a:endParaRPr lang="en-US" sz="1800" dirty="0"/>
+          </a:p>
+          <a:p>
+            <a:pPr algn="l" marL="342900" indent="-342900">
+              <a:spcAft>
+                <a:spcPts val="800"/>
+              </a:spcAft>
+              <a:buSzPct val="100000"/>
+              <a:buChar char="•"/>
+            </a:pPr>
+            <a:r>
+              <a:rPr lang="en-US" sz="1800" dirty="0">
+                <a:solidFill>
+                  <a:srgbClr val="111111"/>
+                </a:solidFill>
+                <a:latin typeface="Calibri" pitchFamily="34" charset="0"/>
+                <a:ea typeface="Calibri" pitchFamily="34" charset="-122"/>
+                <a:cs typeface="Calibri" pitchFamily="34" charset="-120"/>
+              </a:rPr>
+              <a:t>Diagrams and animations: drawn for this lesson (Geography Department).</a:t>
+            </a:r>
+            <a:endParaRPr lang="en-US" sz="1800" dirty="0"/>
+          </a:p>
+        </p:txBody>
+      </p:sp>
+      <p:sp>
+        <p:nvSpPr>
+          <p:cNvPr id="25" name="Slide Number Placeholder 0"/>
+          <p:cNvSpPr>
+            <a:spLocks noGrp="1"/>
+          </p:cNvSpPr>
+          <p:nvPr>
+            <p:ph type="sldNum" sz="quarter" idx="4294967295"/>
+          </p:nvPr>
+        </p:nvSpPr>
+        <p:spPr>
+          <a:xfrm>
+            <a:off x="27432" y="91440"/>
+            <a:ext cx="585216" cy="475488"/>
+          </a:xfrm>
+          <a:prstGeom prst="rect">
+            <a:avLst/>
+          </a:prstGeom>
+          <a:extLst>
+            <a:ext uri="{C572A759-6A51-4108-AA02-DFA0A04FC94B}">
+              <ma14:wrappingTextBoxFlag xmlns:ma14="http://schemas.microsoft.com/office/mac/drawingml/2011/main" val="0"/>
+            </a:ext>
+          </a:extLst>
+        </p:spPr>
+        <p:txBody>
+          <a:bodyPr/>
+          <a:lstStyle>
+            <a:lvl1pPr>
+              <a:defRPr sz="2000">
+                <a:solidFill>
+                  <a:srgbClr val="FFFFFF"/>
+                </a:solidFill>
+                <a:latin typeface="Calibri"/>
+                <a:ea typeface="Calibri"/>
+                <a:cs typeface="Calibri"/>
+              </a:defRPr>
+            </a:lvl1pPr>
+          </a:lstStyle>
+          <a:p>
+            <a:pPr algn="ctr"/>
+            <a:fld id="{F7021451-1387-4CA6-816F-3879F97B5CBC}" type="slidenum">
+              <a:rPr b="1" lang="en-US"/>
+              <a:t>51</a:t>
             </a:fld>
             <a:endParaRPr lang="en-US"/>
           </a:p>

</xml_diff>